<commit_message>
deleted MAE TA benchmark + slides changes
</commit_message>
<xml_diff>
--- a/Presentations/Assignment_2_MA.pptx
+++ b/Presentations/Assignment_2_MA.pptx
@@ -717,6 +717,107 @@
           <a:bodyPr/>
           <a:lstStyle/>
           <a:p>
+            <a:r>
+              <a:rPr lang="en-US" b="1" dirty="0"/>
+              <a:t>(Wait for your colleague to finish explaining the temporal split, then take over).</a:t>
+            </a:r>
+            <a:endParaRPr lang="en-US" dirty="0"/>
+          </a:p>
+          <a:p>
+            <a:r>
+              <a:rPr lang="en-US" dirty="0"/>
+              <a:t>"Following up on the temporal split my colleague just explained, I’ll walk you through our baseline models"</a:t>
+            </a:r>
+          </a:p>
+          <a:p>
+            <a:r>
+              <a:rPr lang="en-US" b="1" dirty="0"/>
+              <a:t>(Point to the Bar Chart on your slide)</a:t>
+            </a:r>
+            <a:r>
+              <a:rPr lang="en-US" dirty="0"/>
+              <a:t> "We started with a standard RFM approach—using Recency, Frequency, and Monetary value—and trained a simple Ridge Regression. As you can see, this resulted in a massive Mean Absolute Error of nearly 14,700 NOK."</a:t>
+            </a:r>
+          </a:p>
+          <a:p>
+            <a:r>
+              <a:rPr lang="en-US" b="1" dirty="0"/>
+              <a:t>(Point to the micro-table or simply emphasize the data)</a:t>
+            </a:r>
+            <a:r>
+              <a:rPr lang="en-US" dirty="0"/>
+              <a:t> "The reason it failed is that linear models cannot handle customers who silently churn. For example, in our dataset, Customer Number 3 spent over 55,000 NOK historically, but hasn't rented anything in 245 days. Their actual future revenue is zero. But because the linear model heavily weights historical spend, it hallucinates high future revenue for these dead accounts.</a:t>
+            </a:r>
+          </a:p>
+          <a:p>
+            <a:r>
+              <a:rPr lang="en-US" b="1" dirty="0"/>
+              <a:t>(Gesture back to the </a:t>
+            </a:r>
+            <a:r>
+              <a:rPr lang="en-US" b="1" dirty="0" err="1"/>
+              <a:t>LightGBM</a:t>
+            </a:r>
+            <a:r>
+              <a:rPr lang="en-US" b="1" dirty="0"/>
+              <a:t> bar on the chart)</a:t>
+            </a:r>
+            <a:r>
+              <a:rPr lang="en-US" dirty="0"/>
+              <a:t> "To fix this, we upgraded our baseline to a tree-based model: </a:t>
+            </a:r>
+            <a:r>
+              <a:rPr lang="en-US" dirty="0" err="1"/>
+              <a:t>LightGBM</a:t>
+            </a:r>
+            <a:r>
+              <a:rPr lang="en-US" dirty="0"/>
+              <a:t>. Because it can learn non-linear rules, it implicitly learned that once 'Recency' crosses a certain threshold of inactivity, the predicted revenue must drop to zero. This cut our error by 30%, down to roughly 10,150 NOK."</a:t>
+            </a:r>
+          </a:p>
+          <a:p>
+            <a:r>
+              <a:rPr lang="en-US" b="1" dirty="0"/>
+              <a:t>(Deliver the final punchline / Next Steps)</a:t>
+            </a:r>
+            <a:r>
+              <a:rPr lang="en-US" dirty="0"/>
+              <a:t> "While this is a solid improvement, our conclusion is that pure RFM features are still not enough for a highly accurate prediction. Our next step for the final model is to enrich this </a:t>
+            </a:r>
+            <a:r>
+              <a:rPr lang="en-US" dirty="0" err="1"/>
+              <a:t>LightGBM</a:t>
+            </a:r>
+            <a:r>
+              <a:rPr lang="en-US" dirty="0"/>
+              <a:t> with the behavioral features we engineered earlier—like </a:t>
+            </a:r>
+            <a:r>
+              <a:rPr lang="en-US" i="1" dirty="0"/>
+              <a:t>Style Entropy</a:t>
+            </a:r>
+            <a:r>
+              <a:rPr lang="en-US" dirty="0"/>
+              <a:t> and </a:t>
+            </a:r>
+            <a:r>
+              <a:rPr lang="en-US" i="1" dirty="0"/>
+              <a:t>Cluster Affinity</a:t>
+            </a:r>
+            <a:r>
+              <a:rPr lang="en-US" dirty="0"/>
+              <a:t>—to precisely predict </a:t>
+            </a:r>
+            <a:r>
+              <a:rPr lang="en-US" i="1" dirty="0"/>
+              <a:t>who</a:t>
+            </a:r>
+            <a:r>
+              <a:rPr lang="en-US" dirty="0"/>
+              <a:t> is churning and close the error gap even further. Thank you."</a:t>
+            </a:r>
+          </a:p>
+          <a:p>
             <a:endParaRPr lang="en-US" dirty="0"/>
           </a:p>
         </p:txBody>
@@ -748,6 +849,90 @@
     <p:extLst>
       <p:ext uri="{BB962C8B-B14F-4D97-AF65-F5344CB8AC3E}">
         <p14:creationId xmlns:p14="http://schemas.microsoft.com/office/powerpoint/2010/main" val="2859236339"/>
+      </p:ext>
+    </p:extLst>
+  </p:cSld>
+  <p:clrMapOvr>
+    <a:masterClrMapping/>
+  </p:clrMapOvr>
+</p:notes>
+</file>
+
+<file path=ppt/notesSlides/notesSlide2.xml><?xml version="1.0" encoding="utf-8"?>
+<p:notes xmlns:a="http://schemas.openxmlformats.org/drawingml/2006/main" xmlns:r="http://schemas.openxmlformats.org/officeDocument/2006/relationships" xmlns:p="http://schemas.openxmlformats.org/presentationml/2006/main">
+  <p:cSld>
+    <p:spTree>
+      <p:nvGrpSpPr>
+        <p:cNvPr id="1" name=""/>
+        <p:cNvGrpSpPr/>
+        <p:nvPr/>
+      </p:nvGrpSpPr>
+      <p:grpSpPr>
+        <a:xfrm>
+          <a:off x="0" y="0"/>
+          <a:ext cx="0" cy="0"/>
+          <a:chOff x="0" y="0"/>
+          <a:chExt cx="0" cy="0"/>
+        </a:xfrm>
+      </p:grpSpPr>
+      <p:sp>
+        <p:nvSpPr>
+          <p:cNvPr id="2" name="Slide Image Placeholder 1"/>
+          <p:cNvSpPr>
+            <a:spLocks noGrp="1" noRot="1" noChangeAspect="1"/>
+          </p:cNvSpPr>
+          <p:nvPr>
+            <p:ph type="sldImg"/>
+          </p:nvPr>
+        </p:nvSpPr>
+        <p:spPr/>
+      </p:sp>
+      <p:sp>
+        <p:nvSpPr>
+          <p:cNvPr id="3" name="Notes Placeholder 2"/>
+          <p:cNvSpPr>
+            <a:spLocks noGrp="1"/>
+          </p:cNvSpPr>
+          <p:nvPr>
+            <p:ph type="body" idx="1"/>
+          </p:nvPr>
+        </p:nvSpPr>
+        <p:spPr/>
+        <p:txBody>
+          <a:bodyPr/>
+          <a:lstStyle/>
+          <a:p>
+            <a:endParaRPr lang="en-US" dirty="0"/>
+          </a:p>
+        </p:txBody>
+      </p:sp>
+      <p:sp>
+        <p:nvSpPr>
+          <p:cNvPr id="4" name="Slide Number Placeholder 3"/>
+          <p:cNvSpPr>
+            <a:spLocks noGrp="1"/>
+          </p:cNvSpPr>
+          <p:nvPr>
+            <p:ph type="sldNum" sz="quarter" idx="5"/>
+          </p:nvPr>
+        </p:nvSpPr>
+        <p:spPr/>
+        <p:txBody>
+          <a:bodyPr/>
+          <a:lstStyle/>
+          <a:p>
+            <a:fld id="{F615DDFD-030C-4D5A-B33E-3A7E7538D2BE}" type="slidenum">
+              <a:rPr lang="de-CH" smtClean="0"/>
+              <a:t>3</a:t>
+            </a:fld>
+            <a:endParaRPr lang="de-CH"/>
+          </a:p>
+        </p:txBody>
+      </p:sp>
+    </p:spTree>
+    <p:extLst>
+      <p:ext uri="{BB962C8B-B14F-4D97-AF65-F5344CB8AC3E}">
+        <p14:creationId xmlns:p14="http://schemas.microsoft.com/office/powerpoint/2010/main" val="2854007841"/>
       </p:ext>
     </p:extLst>
   </p:cSld>
@@ -8282,2383 +8467,6 @@
       </p:sp>
       <p:sp>
         <p:nvSpPr>
-          <p:cNvPr id="24" name="TextBox 23">
-            <a:extLst>
-              <a:ext uri="{FF2B5EF4-FFF2-40B4-BE49-F238E27FC236}">
-                <a16:creationId xmlns:a16="http://schemas.microsoft.com/office/drawing/2014/main" id="{D838C4B1-8BA4-8DD6-388B-E7C0C4E144DA}"/>
-              </a:ext>
-            </a:extLst>
-          </p:cNvPr>
-          <p:cNvSpPr txBox="1"/>
-          <p:nvPr/>
-        </p:nvSpPr>
-        <p:spPr>
-          <a:xfrm>
-            <a:off x="6348822" y="2038811"/>
-            <a:ext cx="5866579" cy="4801314"/>
-          </a:xfrm>
-          <a:prstGeom prst="rect">
-            <a:avLst/>
-          </a:prstGeom>
-          <a:noFill/>
-        </p:spPr>
-        <p:txBody>
-          <a:bodyPr wrap="square" rtlCol="0">
-            <a:spAutoFit/>
-          </a:bodyPr>
-          <a:lstStyle/>
-          <a:p>
-            <a:pPr marL="285750" indent="-285750">
-              <a:buFont typeface="Arial" panose="020B0604020202020204" pitchFamily="34" charset="0"/>
-              <a:buChar char="●"/>
-            </a:pPr>
-            <a:r>
-              <a:rPr lang="en-US" b="1" dirty="0"/>
-              <a:t>Ridge Regression</a:t>
-            </a:r>
-            <a:r>
-              <a:rPr lang="en-US" dirty="0"/>
-              <a:t>: </a:t>
-            </a:r>
-            <a:r>
-              <a:rPr lang="en-US" sz="1600" dirty="0"/>
-              <a:t>The simple linear ridge model cannot handle customers who spent a lot in 2021 but stopped completely in 2023. It hallucinates high revenue for dead accounts</a:t>
-            </a:r>
-          </a:p>
-          <a:p>
-            <a:pPr marL="285750" indent="-285750">
-              <a:buFont typeface="Arial" panose="020B0604020202020204" pitchFamily="34" charset="0"/>
-              <a:buChar char="●"/>
-            </a:pPr>
-            <a:endParaRPr lang="en-US" sz="1600" dirty="0"/>
-          </a:p>
-          <a:p>
-            <a:pPr marL="285750" indent="-285750">
-              <a:buFont typeface="Arial" panose="020B0604020202020204" pitchFamily="34" charset="0"/>
-              <a:buChar char="●"/>
-            </a:pPr>
-            <a:endParaRPr lang="en-US" sz="1600" dirty="0"/>
-          </a:p>
-          <a:p>
-            <a:endParaRPr lang="en-US" sz="1600" dirty="0"/>
-          </a:p>
-          <a:p>
-            <a:pPr marL="285750" indent="-285750">
-              <a:buFont typeface="Arial" panose="020B0604020202020204" pitchFamily="34" charset="0"/>
-              <a:buChar char="●"/>
-            </a:pPr>
-            <a:endParaRPr lang="en-US" sz="2000" dirty="0"/>
-          </a:p>
-          <a:p>
-            <a:pPr marL="285750" indent="-285750">
-              <a:buFont typeface="Arial" panose="020B0604020202020204" pitchFamily="34" charset="0"/>
-              <a:buChar char="●"/>
-            </a:pPr>
-            <a:r>
-              <a:rPr lang="en-US" b="1" dirty="0" err="1"/>
-              <a:t>LightGBM</a:t>
-            </a:r>
-            <a:r>
-              <a:rPr lang="en-US" dirty="0"/>
-              <a:t>: </a:t>
-            </a:r>
-            <a:r>
-              <a:rPr lang="en-US" sz="1600" dirty="0"/>
-              <a:t>We implement a tree-based model that can implicitly learn to ignore these churned customers. Upgrading to a tree-based model cuts the MAE by ~30%:</a:t>
-            </a:r>
-          </a:p>
-          <a:p>
-            <a:pPr marL="285750" indent="-285750">
-              <a:buFont typeface="Arial" panose="020B0604020202020204" pitchFamily="34" charset="0"/>
-              <a:buChar char="●"/>
-            </a:pPr>
-            <a:endParaRPr lang="en-US" dirty="0"/>
-          </a:p>
-          <a:p>
-            <a:pPr marL="285750" indent="-285750">
-              <a:buFont typeface="Arial" panose="020B0604020202020204" pitchFamily="34" charset="0"/>
-              <a:buChar char="●"/>
-            </a:pPr>
-            <a:endParaRPr lang="en-US" dirty="0"/>
-          </a:p>
-          <a:p>
-            <a:pPr marL="285750" indent="-285750">
-              <a:buFont typeface="Arial" panose="020B0604020202020204" pitchFamily="34" charset="0"/>
-              <a:buChar char="●"/>
-            </a:pPr>
-            <a:endParaRPr lang="en-US" dirty="0"/>
-          </a:p>
-          <a:p>
-            <a:pPr marL="285750" indent="-285750">
-              <a:buFont typeface="Arial" panose="020B0604020202020204" pitchFamily="34" charset="0"/>
-              <a:buChar char="●"/>
-            </a:pPr>
-            <a:endParaRPr lang="en-US" dirty="0"/>
-          </a:p>
-          <a:p>
-            <a:pPr marL="285750" indent="-285750">
-              <a:buFont typeface="Arial" panose="020B0604020202020204" pitchFamily="34" charset="0"/>
-              <a:buChar char="●"/>
-            </a:pPr>
-            <a:endParaRPr lang="en-US" dirty="0"/>
-          </a:p>
-          <a:p>
-            <a:pPr marL="285750" indent="-285750">
-              <a:buFont typeface="Arial" panose="020B0604020202020204" pitchFamily="34" charset="0"/>
-              <a:buChar char="●"/>
-            </a:pPr>
-            <a:r>
-              <a:rPr lang="en-US" b="1" dirty="0"/>
-              <a:t>Next Steps</a:t>
-            </a:r>
-            <a:r>
-              <a:rPr lang="en-US" dirty="0"/>
-              <a:t>: </a:t>
-            </a:r>
-            <a:r>
-              <a:rPr lang="en-US" sz="1600" dirty="0"/>
-              <a:t>Pure RFM is insufficient to close the gap to the 93 NOK benchmark</a:t>
-            </a:r>
-            <a:endParaRPr lang="en-US" dirty="0"/>
-          </a:p>
-        </p:txBody>
-      </p:sp>
-      <p:grpSp>
-        <p:nvGrpSpPr>
-          <p:cNvPr id="30" name="Group 29">
-            <a:extLst>
-              <a:ext uri="{FF2B5EF4-FFF2-40B4-BE49-F238E27FC236}">
-                <a16:creationId xmlns:a16="http://schemas.microsoft.com/office/drawing/2014/main" id="{F73E8C4E-6B72-DE38-8DAE-1F0E44DCA590}"/>
-              </a:ext>
-            </a:extLst>
-          </p:cNvPr>
-          <p:cNvGrpSpPr/>
-          <p:nvPr/>
-        </p:nvGrpSpPr>
-        <p:grpSpPr>
-          <a:xfrm>
-            <a:off x="122238" y="735339"/>
-            <a:ext cx="6203183" cy="1626621"/>
-            <a:chOff x="4924012" y="1256056"/>
-            <a:chExt cx="7207830" cy="1626621"/>
-          </a:xfrm>
-        </p:grpSpPr>
-        <p:sp>
-          <p:nvSpPr>
-            <p:cNvPr id="71" name="TextBox 70">
-              <a:extLst>
-                <a:ext uri="{FF2B5EF4-FFF2-40B4-BE49-F238E27FC236}">
-                  <a16:creationId xmlns:a16="http://schemas.microsoft.com/office/drawing/2014/main" id="{2FE72850-96D5-C273-26F1-EC72D20FCF41}"/>
-                </a:ext>
-              </a:extLst>
-            </p:cNvPr>
-            <p:cNvSpPr txBox="1"/>
-            <p:nvPr/>
-          </p:nvSpPr>
-          <p:spPr>
-            <a:xfrm>
-              <a:off x="4942917" y="1256056"/>
-              <a:ext cx="992579" cy="230832"/>
-            </a:xfrm>
-            <a:prstGeom prst="rect">
-              <a:avLst/>
-            </a:prstGeom>
-            <a:noFill/>
-          </p:spPr>
-          <p:txBody>
-            <a:bodyPr wrap="none" rtlCol="0">
-              <a:spAutoFit/>
-            </a:bodyPr>
-            <a:lstStyle/>
-            <a:p>
-              <a:pPr algn="l"/>
-              <a:r>
-                <a:rPr lang="en-US" sz="900" b="1" spc="0" baseline="0" dirty="0">
-                  <a:ln/>
-                  <a:solidFill>
-                    <a:srgbClr val="B8B6D8"/>
-                  </a:solidFill>
-                  <a:latin typeface="Segoe UI"/>
-                  <a:cs typeface="Segoe UI"/>
-                  <a:sym typeface="Segoe UI"/>
-                  <a:rtl val="0"/>
-                </a:rPr>
-                <a:t>Validation fold</a:t>
-              </a:r>
-            </a:p>
-          </p:txBody>
-        </p:sp>
-        <p:sp>
-          <p:nvSpPr>
-            <p:cNvPr id="72" name="TextBox 71">
-              <a:extLst>
-                <a:ext uri="{FF2B5EF4-FFF2-40B4-BE49-F238E27FC236}">
-                  <a16:creationId xmlns:a16="http://schemas.microsoft.com/office/drawing/2014/main" id="{D9E0C421-6492-CC4B-0270-38CA8BF5EC4D}"/>
-                </a:ext>
-              </a:extLst>
-            </p:cNvPr>
-            <p:cNvSpPr txBox="1"/>
-            <p:nvPr/>
-          </p:nvSpPr>
-          <p:spPr>
-            <a:xfrm>
-              <a:off x="4942582" y="1399684"/>
-              <a:ext cx="1079142" cy="230832"/>
-            </a:xfrm>
-            <a:prstGeom prst="rect">
-              <a:avLst/>
-            </a:prstGeom>
-            <a:noFill/>
-          </p:spPr>
-          <p:txBody>
-            <a:bodyPr wrap="none" rtlCol="0">
-              <a:spAutoFit/>
-            </a:bodyPr>
-            <a:lstStyle/>
-            <a:p>
-              <a:pPr algn="l"/>
-              <a:r>
-                <a:rPr lang="en-US" sz="900" b="1" spc="0" baseline="0" dirty="0">
-                  <a:ln/>
-                  <a:solidFill>
-                    <a:srgbClr val="625F8A"/>
-                  </a:solidFill>
-                  <a:latin typeface="Segoe UI"/>
-                  <a:cs typeface="Segoe UI"/>
-                  <a:sym typeface="Segoe UI"/>
-                  <a:rtl val="0"/>
-                </a:rPr>
-                <a:t>(current testing)</a:t>
-              </a:r>
-            </a:p>
-          </p:txBody>
-        </p:sp>
-        <p:sp>
-          <p:nvSpPr>
-            <p:cNvPr id="73" name="TextBox 72">
-              <a:extLst>
-                <a:ext uri="{FF2B5EF4-FFF2-40B4-BE49-F238E27FC236}">
-                  <a16:creationId xmlns:a16="http://schemas.microsoft.com/office/drawing/2014/main" id="{13A4AAAF-731E-4D68-68AD-966770499C6F}"/>
-                </a:ext>
-              </a:extLst>
-            </p:cNvPr>
-            <p:cNvSpPr txBox="1"/>
-            <p:nvPr/>
-          </p:nvSpPr>
-          <p:spPr>
-            <a:xfrm>
-              <a:off x="4924718" y="1941856"/>
-              <a:ext cx="1080745" cy="230832"/>
-            </a:xfrm>
-            <a:prstGeom prst="rect">
-              <a:avLst/>
-            </a:prstGeom>
-            <a:noFill/>
-          </p:spPr>
-          <p:txBody>
-            <a:bodyPr wrap="none" rtlCol="0">
-              <a:spAutoFit/>
-            </a:bodyPr>
-            <a:lstStyle/>
-            <a:p>
-              <a:pPr algn="l"/>
-              <a:r>
-                <a:rPr lang="en-US" sz="900" b="1" spc="0" baseline="0" dirty="0">
-                  <a:ln/>
-                  <a:solidFill>
-                    <a:srgbClr val="B8B6D8"/>
-                  </a:solidFill>
-                  <a:latin typeface="Segoe UI"/>
-                  <a:cs typeface="Segoe UI"/>
-                  <a:sym typeface="Segoe UI"/>
-                  <a:rtl val="0"/>
-                </a:rPr>
-                <a:t>Final submission</a:t>
-              </a:r>
-            </a:p>
-          </p:txBody>
-        </p:sp>
-        <p:sp>
-          <p:nvSpPr>
-            <p:cNvPr id="74" name="TextBox 73">
-              <a:extLst>
-                <a:ext uri="{FF2B5EF4-FFF2-40B4-BE49-F238E27FC236}">
-                  <a16:creationId xmlns:a16="http://schemas.microsoft.com/office/drawing/2014/main" id="{F7F49F98-E120-17E6-34B1-E066F4FC4A24}"/>
-                </a:ext>
-              </a:extLst>
-            </p:cNvPr>
-            <p:cNvSpPr txBox="1"/>
-            <p:nvPr/>
-          </p:nvSpPr>
-          <p:spPr>
-            <a:xfrm>
-              <a:off x="4924012" y="2085484"/>
-              <a:ext cx="1202573" cy="230832"/>
-            </a:xfrm>
-            <a:prstGeom prst="rect">
-              <a:avLst/>
-            </a:prstGeom>
-            <a:noFill/>
-          </p:spPr>
-          <p:txBody>
-            <a:bodyPr wrap="none" rtlCol="0">
-              <a:spAutoFit/>
-            </a:bodyPr>
-            <a:lstStyle/>
-            <a:p>
-              <a:pPr algn="l"/>
-              <a:r>
-                <a:rPr lang="en-US" sz="900" b="1" spc="0" baseline="0" dirty="0">
-                  <a:ln/>
-                  <a:solidFill>
-                    <a:srgbClr val="625F8A"/>
-                  </a:solidFill>
-                  <a:latin typeface="Segoe UI"/>
-                  <a:cs typeface="Segoe UI"/>
-                  <a:sym typeface="Segoe UI"/>
-                  <a:rtl val="0"/>
-                </a:rPr>
-                <a:t>(future prediction)</a:t>
-              </a:r>
-            </a:p>
-          </p:txBody>
-        </p:sp>
-        <p:sp>
-          <p:nvSpPr>
-            <p:cNvPr id="75" name="Freeform: Shape 74">
-              <a:extLst>
-                <a:ext uri="{FF2B5EF4-FFF2-40B4-BE49-F238E27FC236}">
-                  <a16:creationId xmlns:a16="http://schemas.microsoft.com/office/drawing/2014/main" id="{B03F168B-92EB-8CA8-C89A-89D0DA73297F}"/>
-                </a:ext>
-              </a:extLst>
-            </p:cNvPr>
-            <p:cNvSpPr/>
-            <p:nvPr/>
-          </p:nvSpPr>
-          <p:spPr>
-            <a:xfrm>
-              <a:off x="6210300" y="1257300"/>
-              <a:ext cx="2457450" cy="247650"/>
-            </a:xfrm>
-            <a:custGeom>
-              <a:avLst/>
-              <a:gdLst>
-                <a:gd name="csX0" fmla="*/ 2419350 w 2457450"/>
-                <a:gd name="csY0" fmla="*/ 0 h 247650"/>
-                <a:gd name="csX1" fmla="*/ 2457450 w 2457450"/>
-                <a:gd name="csY1" fmla="*/ 0 h 247650"/>
-                <a:gd name="csX2" fmla="*/ 2457450 w 2457450"/>
-                <a:gd name="csY2" fmla="*/ 247650 h 247650"/>
-                <a:gd name="csX3" fmla="*/ 2419350 w 2457450"/>
-                <a:gd name="csY3" fmla="*/ 247650 h 247650"/>
-                <a:gd name="csX4" fmla="*/ 38100 w 2457450"/>
-                <a:gd name="csY4" fmla="*/ 247650 h 247650"/>
-                <a:gd name="csX5" fmla="*/ 0 w 2457450"/>
-                <a:gd name="csY5" fmla="*/ 247650 h 247650"/>
-                <a:gd name="csX6" fmla="*/ 0 w 2457450"/>
-                <a:gd name="csY6" fmla="*/ 0 h 247650"/>
-                <a:gd name="csX7" fmla="*/ 38100 w 2457450"/>
-                <a:gd name="csY7" fmla="*/ 0 h 247650"/>
-              </a:gdLst>
-              <a:ahLst/>
-              <a:cxnLst>
-                <a:cxn ang="0">
-                  <a:pos x="csX0" y="csY0"/>
-                </a:cxn>
-                <a:cxn ang="0">
-                  <a:pos x="csX1" y="csY1"/>
-                </a:cxn>
-                <a:cxn ang="0">
-                  <a:pos x="csX2" y="csY2"/>
-                </a:cxn>
-                <a:cxn ang="0">
-                  <a:pos x="csX3" y="csY3"/>
-                </a:cxn>
-                <a:cxn ang="0">
-                  <a:pos x="csX4" y="csY4"/>
-                </a:cxn>
-                <a:cxn ang="0">
-                  <a:pos x="csX5" y="csY5"/>
-                </a:cxn>
-                <a:cxn ang="0">
-                  <a:pos x="csX6" y="csY6"/>
-                </a:cxn>
-                <a:cxn ang="0">
-                  <a:pos x="csX7" y="csY7"/>
-                </a:cxn>
-              </a:cxnLst>
-              <a:rect l="l" t="t" r="r" b="b"/>
-              <a:pathLst>
-                <a:path w="2457450" h="247650">
-                  <a:moveTo>
-                    <a:pt x="2419350" y="0"/>
-                  </a:moveTo>
-                  <a:cubicBezTo>
-                    <a:pt x="2440392" y="0"/>
-                    <a:pt x="2457450" y="0"/>
-                    <a:pt x="2457450" y="0"/>
-                  </a:cubicBezTo>
-                  <a:lnTo>
-                    <a:pt x="2457450" y="247650"/>
-                  </a:lnTo>
-                  <a:cubicBezTo>
-                    <a:pt x="2457450" y="247650"/>
-                    <a:pt x="2440392" y="247650"/>
-                    <a:pt x="2419350" y="247650"/>
-                  </a:cubicBezTo>
-                  <a:lnTo>
-                    <a:pt x="38100" y="247650"/>
-                  </a:lnTo>
-                  <a:cubicBezTo>
-                    <a:pt x="17058" y="247650"/>
-                    <a:pt x="0" y="247650"/>
-                    <a:pt x="0" y="247650"/>
-                  </a:cubicBezTo>
-                  <a:lnTo>
-                    <a:pt x="0" y="0"/>
-                  </a:lnTo>
-                  <a:cubicBezTo>
-                    <a:pt x="0" y="0"/>
-                    <a:pt x="17058" y="0"/>
-                    <a:pt x="38100" y="0"/>
-                  </a:cubicBezTo>
-                  <a:close/>
-                </a:path>
-              </a:pathLst>
-            </a:custGeom>
-            <a:solidFill>
-              <a:srgbClr val="534AB7">
-                <a:alpha val="82000"/>
-              </a:srgbClr>
-            </a:solidFill>
-            <a:ln w="9525" cap="flat">
-              <a:noFill/>
-              <a:prstDash val="solid"/>
-              <a:miter/>
-            </a:ln>
-          </p:spPr>
-          <p:txBody>
-            <a:bodyPr/>
-            <a:lstStyle/>
-            <a:p>
-              <a:endParaRPr lang="en-US" sz="2400" b="1"/>
-            </a:p>
-          </p:txBody>
-        </p:sp>
-        <p:sp>
-          <p:nvSpPr>
-            <p:cNvPr id="76" name="TextBox 75">
-              <a:extLst>
-                <a:ext uri="{FF2B5EF4-FFF2-40B4-BE49-F238E27FC236}">
-                  <a16:creationId xmlns:a16="http://schemas.microsoft.com/office/drawing/2014/main" id="{2A9087F4-A921-B2D4-BD73-C9245E005CA4}"/>
-                </a:ext>
-              </a:extLst>
-            </p:cNvPr>
-            <p:cNvSpPr txBox="1"/>
-            <p:nvPr/>
-          </p:nvSpPr>
-          <p:spPr>
-            <a:xfrm>
-              <a:off x="6989513" y="1270720"/>
-              <a:ext cx="1053494" cy="230832"/>
-            </a:xfrm>
-            <a:prstGeom prst="rect">
-              <a:avLst/>
-            </a:prstGeom>
-            <a:noFill/>
-          </p:spPr>
-          <p:txBody>
-            <a:bodyPr wrap="none" rtlCol="0">
-              <a:spAutoFit/>
-            </a:bodyPr>
-            <a:lstStyle/>
-            <a:p>
-              <a:pPr algn="l"/>
-              <a:r>
-                <a:rPr lang="en-US" sz="900" b="1" spc="0" baseline="0">
-                  <a:ln/>
-                  <a:solidFill>
-                    <a:srgbClr val="D0CEFC"/>
-                  </a:solidFill>
-                  <a:latin typeface="Segoe UI"/>
-                  <a:cs typeface="Segoe UI"/>
-                  <a:sym typeface="Segoe UI"/>
-                  <a:rtl val="0"/>
-                </a:rPr>
-                <a:t>Feature window</a:t>
-              </a:r>
-            </a:p>
-          </p:txBody>
-        </p:sp>
-        <p:sp>
-          <p:nvSpPr>
-            <p:cNvPr id="77" name="Freeform: Shape 76">
-              <a:extLst>
-                <a:ext uri="{FF2B5EF4-FFF2-40B4-BE49-F238E27FC236}">
-                  <a16:creationId xmlns:a16="http://schemas.microsoft.com/office/drawing/2014/main" id="{D5CEB38E-6D0E-3631-CA96-E6AB39F48FE4}"/>
-                </a:ext>
-              </a:extLst>
-            </p:cNvPr>
-            <p:cNvSpPr/>
-            <p:nvPr/>
-          </p:nvSpPr>
-          <p:spPr>
-            <a:xfrm>
-              <a:off x="8667750" y="1257300"/>
-              <a:ext cx="1466850" cy="247650"/>
-            </a:xfrm>
-            <a:custGeom>
-              <a:avLst/>
-              <a:gdLst>
-                <a:gd name="csX0" fmla="*/ 1428750 w 1466850"/>
-                <a:gd name="csY0" fmla="*/ 0 h 247650"/>
-                <a:gd name="csX1" fmla="*/ 1466850 w 1466850"/>
-                <a:gd name="csY1" fmla="*/ 0 h 247650"/>
-                <a:gd name="csX2" fmla="*/ 1466850 w 1466850"/>
-                <a:gd name="csY2" fmla="*/ 247650 h 247650"/>
-                <a:gd name="csX3" fmla="*/ 1428750 w 1466850"/>
-                <a:gd name="csY3" fmla="*/ 247650 h 247650"/>
-                <a:gd name="csX4" fmla="*/ 38100 w 1466850"/>
-                <a:gd name="csY4" fmla="*/ 247650 h 247650"/>
-                <a:gd name="csX5" fmla="*/ 0 w 1466850"/>
-                <a:gd name="csY5" fmla="*/ 247650 h 247650"/>
-                <a:gd name="csX6" fmla="*/ 0 w 1466850"/>
-                <a:gd name="csY6" fmla="*/ 0 h 247650"/>
-                <a:gd name="csX7" fmla="*/ 38100 w 1466850"/>
-                <a:gd name="csY7" fmla="*/ 0 h 247650"/>
-              </a:gdLst>
-              <a:ahLst/>
-              <a:cxnLst>
-                <a:cxn ang="0">
-                  <a:pos x="csX0" y="csY0"/>
-                </a:cxn>
-                <a:cxn ang="0">
-                  <a:pos x="csX1" y="csY1"/>
-                </a:cxn>
-                <a:cxn ang="0">
-                  <a:pos x="csX2" y="csY2"/>
-                </a:cxn>
-                <a:cxn ang="0">
-                  <a:pos x="csX3" y="csY3"/>
-                </a:cxn>
-                <a:cxn ang="0">
-                  <a:pos x="csX4" y="csY4"/>
-                </a:cxn>
-                <a:cxn ang="0">
-                  <a:pos x="csX5" y="csY5"/>
-                </a:cxn>
-                <a:cxn ang="0">
-                  <a:pos x="csX6" y="csY6"/>
-                </a:cxn>
-                <a:cxn ang="0">
-                  <a:pos x="csX7" y="csY7"/>
-                </a:cxn>
-              </a:cxnLst>
-              <a:rect l="l" t="t" r="r" b="b"/>
-              <a:pathLst>
-                <a:path w="1466850" h="247650">
-                  <a:moveTo>
-                    <a:pt x="1428750" y="0"/>
-                  </a:moveTo>
-                  <a:cubicBezTo>
-                    <a:pt x="1449792" y="0"/>
-                    <a:pt x="1466850" y="0"/>
-                    <a:pt x="1466850" y="0"/>
-                  </a:cubicBezTo>
-                  <a:lnTo>
-                    <a:pt x="1466850" y="247650"/>
-                  </a:lnTo>
-                  <a:cubicBezTo>
-                    <a:pt x="1466850" y="247650"/>
-                    <a:pt x="1449792" y="247650"/>
-                    <a:pt x="1428750" y="247650"/>
-                  </a:cubicBezTo>
-                  <a:lnTo>
-                    <a:pt x="38100" y="247650"/>
-                  </a:lnTo>
-                  <a:cubicBezTo>
-                    <a:pt x="17058" y="247650"/>
-                    <a:pt x="0" y="247650"/>
-                    <a:pt x="0" y="247650"/>
-                  </a:cubicBezTo>
-                  <a:lnTo>
-                    <a:pt x="0" y="0"/>
-                  </a:lnTo>
-                  <a:cubicBezTo>
-                    <a:pt x="0" y="0"/>
-                    <a:pt x="17058" y="0"/>
-                    <a:pt x="38100" y="0"/>
-                  </a:cubicBezTo>
-                  <a:close/>
-                </a:path>
-              </a:pathLst>
-            </a:custGeom>
-            <a:solidFill>
-              <a:srgbClr val="D85A30">
-                <a:alpha val="82000"/>
-              </a:srgbClr>
-            </a:solidFill>
-            <a:ln w="9525" cap="flat">
-              <a:noFill/>
-              <a:prstDash val="solid"/>
-              <a:miter/>
-            </a:ln>
-          </p:spPr>
-          <p:txBody>
-            <a:bodyPr/>
-            <a:lstStyle/>
-            <a:p>
-              <a:endParaRPr lang="en-US" sz="2400" b="1"/>
-            </a:p>
-          </p:txBody>
-        </p:sp>
-        <p:sp>
-          <p:nvSpPr>
-            <p:cNvPr id="78" name="TextBox 77">
-              <a:extLst>
-                <a:ext uri="{FF2B5EF4-FFF2-40B4-BE49-F238E27FC236}">
-                  <a16:creationId xmlns:a16="http://schemas.microsoft.com/office/drawing/2014/main" id="{D02B202D-040E-2948-8062-002C4A386590}"/>
-                </a:ext>
-              </a:extLst>
-            </p:cNvPr>
-            <p:cNvSpPr txBox="1"/>
-            <p:nvPr/>
-          </p:nvSpPr>
-          <p:spPr>
-            <a:xfrm>
-              <a:off x="9019031" y="1270720"/>
-              <a:ext cx="901209" cy="230832"/>
-            </a:xfrm>
-            <a:prstGeom prst="rect">
-              <a:avLst/>
-            </a:prstGeom>
-            <a:noFill/>
-          </p:spPr>
-          <p:txBody>
-            <a:bodyPr wrap="none" rtlCol="0">
-              <a:spAutoFit/>
-            </a:bodyPr>
-            <a:lstStyle/>
-            <a:p>
-              <a:pPr algn="l"/>
-              <a:r>
-                <a:rPr lang="en-US" sz="900" b="1" spc="0" baseline="0">
-                  <a:ln/>
-                  <a:solidFill>
-                    <a:srgbClr val="F5CDB6"/>
-                  </a:solidFill>
-                  <a:latin typeface="Segoe UI"/>
-                  <a:cs typeface="Segoe UI"/>
-                  <a:sym typeface="Segoe UI"/>
-                  <a:rtl val="0"/>
-                </a:rPr>
-                <a:t>Target (12M)</a:t>
-              </a:r>
-            </a:p>
-          </p:txBody>
-        </p:sp>
-        <p:sp>
-          <p:nvSpPr>
-            <p:cNvPr id="79" name="Freeform: Shape 78">
-              <a:extLst>
-                <a:ext uri="{FF2B5EF4-FFF2-40B4-BE49-F238E27FC236}">
-                  <a16:creationId xmlns:a16="http://schemas.microsoft.com/office/drawing/2014/main" id="{0CB29E37-5B5A-58E4-C945-8C8B57720F9E}"/>
-                </a:ext>
-              </a:extLst>
-            </p:cNvPr>
-            <p:cNvSpPr/>
-            <p:nvPr/>
-          </p:nvSpPr>
-          <p:spPr>
-            <a:xfrm>
-              <a:off x="7686675" y="1971675"/>
-              <a:ext cx="2447925" cy="247650"/>
-            </a:xfrm>
-            <a:custGeom>
-              <a:avLst/>
-              <a:gdLst>
-                <a:gd name="csX0" fmla="*/ 2409825 w 2447925"/>
-                <a:gd name="csY0" fmla="*/ 0 h 247650"/>
-                <a:gd name="csX1" fmla="*/ 2447925 w 2447925"/>
-                <a:gd name="csY1" fmla="*/ 0 h 247650"/>
-                <a:gd name="csX2" fmla="*/ 2447925 w 2447925"/>
-                <a:gd name="csY2" fmla="*/ 247650 h 247650"/>
-                <a:gd name="csX3" fmla="*/ 2409825 w 2447925"/>
-                <a:gd name="csY3" fmla="*/ 247650 h 247650"/>
-                <a:gd name="csX4" fmla="*/ 38100 w 2447925"/>
-                <a:gd name="csY4" fmla="*/ 247650 h 247650"/>
-                <a:gd name="csX5" fmla="*/ 0 w 2447925"/>
-                <a:gd name="csY5" fmla="*/ 247650 h 247650"/>
-                <a:gd name="csX6" fmla="*/ 0 w 2447925"/>
-                <a:gd name="csY6" fmla="*/ 0 h 247650"/>
-                <a:gd name="csX7" fmla="*/ 38100 w 2447925"/>
-                <a:gd name="csY7" fmla="*/ 0 h 247650"/>
-              </a:gdLst>
-              <a:ahLst/>
-              <a:cxnLst>
-                <a:cxn ang="0">
-                  <a:pos x="csX0" y="csY0"/>
-                </a:cxn>
-                <a:cxn ang="0">
-                  <a:pos x="csX1" y="csY1"/>
-                </a:cxn>
-                <a:cxn ang="0">
-                  <a:pos x="csX2" y="csY2"/>
-                </a:cxn>
-                <a:cxn ang="0">
-                  <a:pos x="csX3" y="csY3"/>
-                </a:cxn>
-                <a:cxn ang="0">
-                  <a:pos x="csX4" y="csY4"/>
-                </a:cxn>
-                <a:cxn ang="0">
-                  <a:pos x="csX5" y="csY5"/>
-                </a:cxn>
-                <a:cxn ang="0">
-                  <a:pos x="csX6" y="csY6"/>
-                </a:cxn>
-                <a:cxn ang="0">
-                  <a:pos x="csX7" y="csY7"/>
-                </a:cxn>
-              </a:cxnLst>
-              <a:rect l="l" t="t" r="r" b="b"/>
-              <a:pathLst>
-                <a:path w="2447925" h="247650">
-                  <a:moveTo>
-                    <a:pt x="2409825" y="0"/>
-                  </a:moveTo>
-                  <a:cubicBezTo>
-                    <a:pt x="2430867" y="0"/>
-                    <a:pt x="2447925" y="0"/>
-                    <a:pt x="2447925" y="0"/>
-                  </a:cubicBezTo>
-                  <a:lnTo>
-                    <a:pt x="2447925" y="247650"/>
-                  </a:lnTo>
-                  <a:cubicBezTo>
-                    <a:pt x="2447925" y="247650"/>
-                    <a:pt x="2430867" y="247650"/>
-                    <a:pt x="2409825" y="247650"/>
-                  </a:cubicBezTo>
-                  <a:lnTo>
-                    <a:pt x="38100" y="247650"/>
-                  </a:lnTo>
-                  <a:cubicBezTo>
-                    <a:pt x="17058" y="247650"/>
-                    <a:pt x="0" y="247650"/>
-                    <a:pt x="0" y="247650"/>
-                  </a:cubicBezTo>
-                  <a:lnTo>
-                    <a:pt x="0" y="0"/>
-                  </a:lnTo>
-                  <a:cubicBezTo>
-                    <a:pt x="0" y="0"/>
-                    <a:pt x="17058" y="0"/>
-                    <a:pt x="38100" y="0"/>
-                  </a:cubicBezTo>
-                  <a:close/>
-                </a:path>
-              </a:pathLst>
-            </a:custGeom>
-            <a:solidFill>
-              <a:srgbClr val="534AB7">
-                <a:alpha val="82000"/>
-              </a:srgbClr>
-            </a:solidFill>
-            <a:ln w="9525" cap="flat">
-              <a:noFill/>
-              <a:prstDash val="solid"/>
-              <a:miter/>
-            </a:ln>
-          </p:spPr>
-          <p:txBody>
-            <a:bodyPr/>
-            <a:lstStyle/>
-            <a:p>
-              <a:endParaRPr lang="en-US" sz="2400" b="1"/>
-            </a:p>
-          </p:txBody>
-        </p:sp>
-        <p:sp>
-          <p:nvSpPr>
-            <p:cNvPr id="80" name="TextBox 79">
-              <a:extLst>
-                <a:ext uri="{FF2B5EF4-FFF2-40B4-BE49-F238E27FC236}">
-                  <a16:creationId xmlns:a16="http://schemas.microsoft.com/office/drawing/2014/main" id="{3745A372-DD15-77FB-4592-20932CDB4D93}"/>
-                </a:ext>
-              </a:extLst>
-            </p:cNvPr>
-            <p:cNvSpPr txBox="1"/>
-            <p:nvPr/>
-          </p:nvSpPr>
-          <p:spPr>
-            <a:xfrm>
-              <a:off x="8456363" y="1985095"/>
-              <a:ext cx="1053494" cy="230832"/>
-            </a:xfrm>
-            <a:prstGeom prst="rect">
-              <a:avLst/>
-            </a:prstGeom>
-            <a:noFill/>
-          </p:spPr>
-          <p:txBody>
-            <a:bodyPr wrap="none" rtlCol="0">
-              <a:spAutoFit/>
-            </a:bodyPr>
-            <a:lstStyle/>
-            <a:p>
-              <a:pPr algn="l"/>
-              <a:r>
-                <a:rPr lang="en-US" sz="900" b="1" spc="0" baseline="0">
-                  <a:ln/>
-                  <a:solidFill>
-                    <a:srgbClr val="D0CEFC"/>
-                  </a:solidFill>
-                  <a:latin typeface="Segoe UI"/>
-                  <a:cs typeface="Segoe UI"/>
-                  <a:sym typeface="Segoe UI"/>
-                  <a:rtl val="0"/>
-                </a:rPr>
-                <a:t>Feature window</a:t>
-              </a:r>
-            </a:p>
-          </p:txBody>
-        </p:sp>
-        <p:sp>
-          <p:nvSpPr>
-            <p:cNvPr id="81" name="Freeform: Shape 80">
-              <a:extLst>
-                <a:ext uri="{FF2B5EF4-FFF2-40B4-BE49-F238E27FC236}">
-                  <a16:creationId xmlns:a16="http://schemas.microsoft.com/office/drawing/2014/main" id="{1B8AD6FC-7DBD-757E-60C3-F7BB7ECCB5C4}"/>
-                </a:ext>
-              </a:extLst>
-            </p:cNvPr>
-            <p:cNvSpPr/>
-            <p:nvPr/>
-          </p:nvSpPr>
-          <p:spPr>
-            <a:xfrm>
-              <a:off x="10134600" y="1971675"/>
-              <a:ext cx="1476375" cy="247650"/>
-            </a:xfrm>
-            <a:custGeom>
-              <a:avLst/>
-              <a:gdLst>
-                <a:gd name="csX0" fmla="*/ 1438275 w 1476375"/>
-                <a:gd name="csY0" fmla="*/ 0 h 247650"/>
-                <a:gd name="csX1" fmla="*/ 1476375 w 1476375"/>
-                <a:gd name="csY1" fmla="*/ 0 h 247650"/>
-                <a:gd name="csX2" fmla="*/ 1476375 w 1476375"/>
-                <a:gd name="csY2" fmla="*/ 247650 h 247650"/>
-                <a:gd name="csX3" fmla="*/ 1438275 w 1476375"/>
-                <a:gd name="csY3" fmla="*/ 247650 h 247650"/>
-                <a:gd name="csX4" fmla="*/ 38100 w 1476375"/>
-                <a:gd name="csY4" fmla="*/ 247650 h 247650"/>
-                <a:gd name="csX5" fmla="*/ 0 w 1476375"/>
-                <a:gd name="csY5" fmla="*/ 247650 h 247650"/>
-                <a:gd name="csX6" fmla="*/ 0 w 1476375"/>
-                <a:gd name="csY6" fmla="*/ 0 h 247650"/>
-                <a:gd name="csX7" fmla="*/ 38100 w 1476375"/>
-                <a:gd name="csY7" fmla="*/ 0 h 247650"/>
-              </a:gdLst>
-              <a:ahLst/>
-              <a:cxnLst>
-                <a:cxn ang="0">
-                  <a:pos x="csX0" y="csY0"/>
-                </a:cxn>
-                <a:cxn ang="0">
-                  <a:pos x="csX1" y="csY1"/>
-                </a:cxn>
-                <a:cxn ang="0">
-                  <a:pos x="csX2" y="csY2"/>
-                </a:cxn>
-                <a:cxn ang="0">
-                  <a:pos x="csX3" y="csY3"/>
-                </a:cxn>
-                <a:cxn ang="0">
-                  <a:pos x="csX4" y="csY4"/>
-                </a:cxn>
-                <a:cxn ang="0">
-                  <a:pos x="csX5" y="csY5"/>
-                </a:cxn>
-                <a:cxn ang="0">
-                  <a:pos x="csX6" y="csY6"/>
-                </a:cxn>
-                <a:cxn ang="0">
-                  <a:pos x="csX7" y="csY7"/>
-                </a:cxn>
-              </a:cxnLst>
-              <a:rect l="l" t="t" r="r" b="b"/>
-              <a:pathLst>
-                <a:path w="1476375" h="247650">
-                  <a:moveTo>
-                    <a:pt x="1438275" y="0"/>
-                  </a:moveTo>
-                  <a:cubicBezTo>
-                    <a:pt x="1459317" y="0"/>
-                    <a:pt x="1476375" y="0"/>
-                    <a:pt x="1476375" y="0"/>
-                  </a:cubicBezTo>
-                  <a:lnTo>
-                    <a:pt x="1476375" y="247650"/>
-                  </a:lnTo>
-                  <a:cubicBezTo>
-                    <a:pt x="1476375" y="247650"/>
-                    <a:pt x="1459317" y="247650"/>
-                    <a:pt x="1438275" y="247650"/>
-                  </a:cubicBezTo>
-                  <a:lnTo>
-                    <a:pt x="38100" y="247650"/>
-                  </a:lnTo>
-                  <a:cubicBezTo>
-                    <a:pt x="17058" y="247650"/>
-                    <a:pt x="0" y="247650"/>
-                    <a:pt x="0" y="247650"/>
-                  </a:cubicBezTo>
-                  <a:lnTo>
-                    <a:pt x="0" y="0"/>
-                  </a:lnTo>
-                  <a:cubicBezTo>
-                    <a:pt x="0" y="0"/>
-                    <a:pt x="17058" y="0"/>
-                    <a:pt x="38100" y="0"/>
-                  </a:cubicBezTo>
-                  <a:close/>
-                </a:path>
-              </a:pathLst>
-            </a:custGeom>
-            <a:solidFill>
-              <a:srgbClr val="D85A30">
-                <a:alpha val="82000"/>
-              </a:srgbClr>
-            </a:solidFill>
-            <a:ln w="9525" cap="flat">
-              <a:noFill/>
-              <a:prstDash val="solid"/>
-              <a:miter/>
-            </a:ln>
-          </p:spPr>
-          <p:txBody>
-            <a:bodyPr/>
-            <a:lstStyle/>
-            <a:p>
-              <a:endParaRPr lang="en-US" sz="2400" b="1"/>
-            </a:p>
-          </p:txBody>
-        </p:sp>
-        <p:sp>
-          <p:nvSpPr>
-            <p:cNvPr id="82" name="TextBox 81">
-              <a:extLst>
-                <a:ext uri="{FF2B5EF4-FFF2-40B4-BE49-F238E27FC236}">
-                  <a16:creationId xmlns:a16="http://schemas.microsoft.com/office/drawing/2014/main" id="{7B825F5F-119F-775B-9BC7-6953DE87AC2A}"/>
-                </a:ext>
-              </a:extLst>
-            </p:cNvPr>
-            <p:cNvSpPr txBox="1"/>
-            <p:nvPr/>
-          </p:nvSpPr>
-          <p:spPr>
-            <a:xfrm>
-              <a:off x="10485881" y="1985095"/>
-              <a:ext cx="901209" cy="230832"/>
-            </a:xfrm>
-            <a:prstGeom prst="rect">
-              <a:avLst/>
-            </a:prstGeom>
-            <a:noFill/>
-          </p:spPr>
-          <p:txBody>
-            <a:bodyPr wrap="none" rtlCol="0">
-              <a:spAutoFit/>
-            </a:bodyPr>
-            <a:lstStyle/>
-            <a:p>
-              <a:pPr algn="l"/>
-              <a:r>
-                <a:rPr lang="en-US" sz="900" b="1" spc="0" baseline="0">
-                  <a:ln/>
-                  <a:solidFill>
-                    <a:srgbClr val="F5CDB6"/>
-                  </a:solidFill>
-                  <a:latin typeface="Segoe UI"/>
-                  <a:cs typeface="Segoe UI"/>
-                  <a:sym typeface="Segoe UI"/>
-                  <a:rtl val="0"/>
-                </a:rPr>
-                <a:t>Target (12M)</a:t>
-              </a:r>
-            </a:p>
-          </p:txBody>
-        </p:sp>
-        <p:sp>
-          <p:nvSpPr>
-            <p:cNvPr id="83" name="Freeform: Shape 82">
-              <a:extLst>
-                <a:ext uri="{FF2B5EF4-FFF2-40B4-BE49-F238E27FC236}">
-                  <a16:creationId xmlns:a16="http://schemas.microsoft.com/office/drawing/2014/main" id="{3CDC5862-3FA7-E42D-8FFA-A2D07FA5C098}"/>
-                </a:ext>
-              </a:extLst>
-            </p:cNvPr>
-            <p:cNvSpPr/>
-            <p:nvPr/>
-          </p:nvSpPr>
-          <p:spPr>
-            <a:xfrm>
-              <a:off x="6210300" y="2438400"/>
-              <a:ext cx="5524500" cy="9525"/>
-            </a:xfrm>
-            <a:custGeom>
-              <a:avLst/>
-              <a:gdLst>
-                <a:gd name="csX0" fmla="*/ 0 w 5524500"/>
-                <a:gd name="csY0" fmla="*/ 0 h 9525"/>
-                <a:gd name="csX1" fmla="*/ 5524500 w 5524500"/>
-                <a:gd name="csY1" fmla="*/ 0 h 9525"/>
-              </a:gdLst>
-              <a:ahLst/>
-              <a:cxnLst>
-                <a:cxn ang="0">
-                  <a:pos x="csX0" y="csY0"/>
-                </a:cxn>
-                <a:cxn ang="0">
-                  <a:pos x="csX1" y="csY1"/>
-                </a:cxn>
-              </a:cxnLst>
-              <a:rect l="l" t="t" r="r" b="b"/>
-              <a:pathLst>
-                <a:path w="5524500" h="9525">
-                  <a:moveTo>
-                    <a:pt x="0" y="0"/>
-                  </a:moveTo>
-                  <a:lnTo>
-                    <a:pt x="5524500" y="0"/>
-                  </a:lnTo>
-                </a:path>
-              </a:pathLst>
-            </a:custGeom>
-            <a:ln w="7620" cap="flat">
-              <a:solidFill>
-                <a:srgbClr val="3A3A6A"/>
-              </a:solidFill>
-              <a:prstDash val="solid"/>
-              <a:miter/>
-            </a:ln>
-          </p:spPr>
-          <p:txBody>
-            <a:bodyPr/>
-            <a:lstStyle/>
-            <a:p>
-              <a:endParaRPr lang="en-US" sz="2400" b="1"/>
-            </a:p>
-          </p:txBody>
-        </p:sp>
-        <p:sp>
-          <p:nvSpPr>
-            <p:cNvPr id="84" name="Freeform: Shape 83">
-              <a:extLst>
-                <a:ext uri="{FF2B5EF4-FFF2-40B4-BE49-F238E27FC236}">
-                  <a16:creationId xmlns:a16="http://schemas.microsoft.com/office/drawing/2014/main" id="{7AC58178-8672-F3A6-BDB1-CFF779C8E1F3}"/>
-                </a:ext>
-              </a:extLst>
-            </p:cNvPr>
-            <p:cNvSpPr/>
-            <p:nvPr/>
-          </p:nvSpPr>
-          <p:spPr>
-            <a:xfrm>
-              <a:off x="6581775" y="2409825"/>
-              <a:ext cx="9525" cy="66675"/>
-            </a:xfrm>
-            <a:custGeom>
-              <a:avLst/>
-              <a:gdLst>
-                <a:gd name="csX0" fmla="*/ 0 w 9525"/>
-                <a:gd name="csY0" fmla="*/ 0 h 66675"/>
-                <a:gd name="csX1" fmla="*/ 0 w 9525"/>
-                <a:gd name="csY1" fmla="*/ 66675 h 66675"/>
-              </a:gdLst>
-              <a:ahLst/>
-              <a:cxnLst>
-                <a:cxn ang="0">
-                  <a:pos x="csX0" y="csY0"/>
-                </a:cxn>
-                <a:cxn ang="0">
-                  <a:pos x="csX1" y="csY1"/>
-                </a:cxn>
-              </a:cxnLst>
-              <a:rect l="l" t="t" r="r" b="b"/>
-              <a:pathLst>
-                <a:path w="9525" h="66675">
-                  <a:moveTo>
-                    <a:pt x="0" y="0"/>
-                  </a:moveTo>
-                  <a:lnTo>
-                    <a:pt x="0" y="66675"/>
-                  </a:lnTo>
-                </a:path>
-              </a:pathLst>
-            </a:custGeom>
-            <a:ln w="7620" cap="flat">
-              <a:solidFill>
-                <a:srgbClr val="3A3A6A"/>
-              </a:solidFill>
-              <a:prstDash val="solid"/>
-              <a:miter/>
-            </a:ln>
-          </p:spPr>
-          <p:txBody>
-            <a:bodyPr/>
-            <a:lstStyle/>
-            <a:p>
-              <a:endParaRPr lang="en-US" sz="2400" b="1"/>
-            </a:p>
-          </p:txBody>
-        </p:sp>
-        <p:sp>
-          <p:nvSpPr>
-            <p:cNvPr id="85" name="TextBox 84">
-              <a:extLst>
-                <a:ext uri="{FF2B5EF4-FFF2-40B4-BE49-F238E27FC236}">
-                  <a16:creationId xmlns:a16="http://schemas.microsoft.com/office/drawing/2014/main" id="{218AC7A8-311C-3C70-F317-87757EFD14CC}"/>
-                </a:ext>
-              </a:extLst>
-            </p:cNvPr>
-            <p:cNvSpPr txBox="1"/>
-            <p:nvPr/>
-          </p:nvSpPr>
-          <p:spPr>
-            <a:xfrm>
-              <a:off x="6308873" y="2456959"/>
-              <a:ext cx="679994" cy="230832"/>
-            </a:xfrm>
-            <a:prstGeom prst="rect">
-              <a:avLst/>
-            </a:prstGeom>
-            <a:noFill/>
-          </p:spPr>
-          <p:txBody>
-            <a:bodyPr wrap="none" rtlCol="0">
-              <a:spAutoFit/>
-            </a:bodyPr>
-            <a:lstStyle/>
-            <a:p>
-              <a:pPr algn="l"/>
-              <a:r>
-                <a:rPr lang="en-US" sz="900" b="1" spc="0" baseline="0">
-                  <a:ln/>
-                  <a:solidFill>
-                    <a:srgbClr val="625F8A"/>
-                  </a:solidFill>
-                  <a:latin typeface="Segoe UI"/>
-                  <a:cs typeface="Segoe UI"/>
-                  <a:sym typeface="Segoe UI"/>
-                  <a:rtl val="0"/>
-                </a:rPr>
-                <a:t>Apr 2021</a:t>
-              </a:r>
-            </a:p>
-          </p:txBody>
-        </p:sp>
-        <p:sp>
-          <p:nvSpPr>
-            <p:cNvPr id="86" name="Freeform: Shape 85">
-              <a:extLst>
-                <a:ext uri="{FF2B5EF4-FFF2-40B4-BE49-F238E27FC236}">
-                  <a16:creationId xmlns:a16="http://schemas.microsoft.com/office/drawing/2014/main" id="{D180F70C-E101-0658-2686-1CFCCFA15D70}"/>
-                </a:ext>
-              </a:extLst>
-            </p:cNvPr>
-            <p:cNvSpPr/>
-            <p:nvPr/>
-          </p:nvSpPr>
-          <p:spPr>
-            <a:xfrm>
-              <a:off x="7315200" y="2409825"/>
-              <a:ext cx="9525" cy="66675"/>
-            </a:xfrm>
-            <a:custGeom>
-              <a:avLst/>
-              <a:gdLst>
-                <a:gd name="csX0" fmla="*/ 0 w 9525"/>
-                <a:gd name="csY0" fmla="*/ 0 h 66675"/>
-                <a:gd name="csX1" fmla="*/ 0 w 9525"/>
-                <a:gd name="csY1" fmla="*/ 66675 h 66675"/>
-              </a:gdLst>
-              <a:ahLst/>
-              <a:cxnLst>
-                <a:cxn ang="0">
-                  <a:pos x="csX0" y="csY0"/>
-                </a:cxn>
-                <a:cxn ang="0">
-                  <a:pos x="csX1" y="csY1"/>
-                </a:cxn>
-              </a:cxnLst>
-              <a:rect l="l" t="t" r="r" b="b"/>
-              <a:pathLst>
-                <a:path w="9525" h="66675">
-                  <a:moveTo>
-                    <a:pt x="0" y="0"/>
-                  </a:moveTo>
-                  <a:lnTo>
-                    <a:pt x="0" y="66675"/>
-                  </a:lnTo>
-                </a:path>
-              </a:pathLst>
-            </a:custGeom>
-            <a:ln w="7620" cap="flat">
-              <a:solidFill>
-                <a:srgbClr val="3A3A6A"/>
-              </a:solidFill>
-              <a:prstDash val="solid"/>
-              <a:miter/>
-            </a:ln>
-          </p:spPr>
-          <p:txBody>
-            <a:bodyPr/>
-            <a:lstStyle/>
-            <a:p>
-              <a:endParaRPr lang="en-US" sz="2400" b="1"/>
-            </a:p>
-          </p:txBody>
-        </p:sp>
-        <p:sp>
-          <p:nvSpPr>
-            <p:cNvPr id="87" name="TextBox 86">
-              <a:extLst>
-                <a:ext uri="{FF2B5EF4-FFF2-40B4-BE49-F238E27FC236}">
-                  <a16:creationId xmlns:a16="http://schemas.microsoft.com/office/drawing/2014/main" id="{6DB8E407-4001-7951-BBED-2D1D484414AD}"/>
-                </a:ext>
-              </a:extLst>
-            </p:cNvPr>
-            <p:cNvSpPr txBox="1"/>
-            <p:nvPr/>
-          </p:nvSpPr>
-          <p:spPr>
-            <a:xfrm>
-              <a:off x="7043469" y="2456959"/>
-              <a:ext cx="668773" cy="230832"/>
-            </a:xfrm>
-            <a:prstGeom prst="rect">
-              <a:avLst/>
-            </a:prstGeom>
-            <a:noFill/>
-          </p:spPr>
-          <p:txBody>
-            <a:bodyPr wrap="none" rtlCol="0">
-              <a:spAutoFit/>
-            </a:bodyPr>
-            <a:lstStyle/>
-            <a:p>
-              <a:pPr algn="l"/>
-              <a:r>
-                <a:rPr lang="en-US" sz="900" b="1" spc="0" baseline="0">
-                  <a:ln/>
-                  <a:solidFill>
-                    <a:srgbClr val="625F8A"/>
-                  </a:solidFill>
-                  <a:latin typeface="Segoe UI"/>
-                  <a:cs typeface="Segoe UI"/>
-                  <a:sym typeface="Segoe UI"/>
-                  <a:rtl val="0"/>
-                </a:rPr>
-                <a:t>Oct 2021</a:t>
-              </a:r>
-            </a:p>
-          </p:txBody>
-        </p:sp>
-        <p:sp>
-          <p:nvSpPr>
-            <p:cNvPr id="88" name="Freeform: Shape 87">
-              <a:extLst>
-                <a:ext uri="{FF2B5EF4-FFF2-40B4-BE49-F238E27FC236}">
-                  <a16:creationId xmlns:a16="http://schemas.microsoft.com/office/drawing/2014/main" id="{63D1978E-3289-125B-2746-03CEA43735DA}"/>
-                </a:ext>
-              </a:extLst>
-            </p:cNvPr>
-            <p:cNvSpPr/>
-            <p:nvPr/>
-          </p:nvSpPr>
-          <p:spPr>
-            <a:xfrm>
-              <a:off x="8048625" y="2409825"/>
-              <a:ext cx="9525" cy="66675"/>
-            </a:xfrm>
-            <a:custGeom>
-              <a:avLst/>
-              <a:gdLst>
-                <a:gd name="csX0" fmla="*/ 0 w 9525"/>
-                <a:gd name="csY0" fmla="*/ 0 h 66675"/>
-                <a:gd name="csX1" fmla="*/ 0 w 9525"/>
-                <a:gd name="csY1" fmla="*/ 66675 h 66675"/>
-              </a:gdLst>
-              <a:ahLst/>
-              <a:cxnLst>
-                <a:cxn ang="0">
-                  <a:pos x="csX0" y="csY0"/>
-                </a:cxn>
-                <a:cxn ang="0">
-                  <a:pos x="csX1" y="csY1"/>
-                </a:cxn>
-              </a:cxnLst>
-              <a:rect l="l" t="t" r="r" b="b"/>
-              <a:pathLst>
-                <a:path w="9525" h="66675">
-                  <a:moveTo>
-                    <a:pt x="0" y="0"/>
-                  </a:moveTo>
-                  <a:lnTo>
-                    <a:pt x="0" y="66675"/>
-                  </a:lnTo>
-                </a:path>
-              </a:pathLst>
-            </a:custGeom>
-            <a:ln w="7620" cap="flat">
-              <a:solidFill>
-                <a:srgbClr val="3A3A6A"/>
-              </a:solidFill>
-              <a:prstDash val="solid"/>
-              <a:miter/>
-            </a:ln>
-          </p:spPr>
-          <p:txBody>
-            <a:bodyPr/>
-            <a:lstStyle/>
-            <a:p>
-              <a:endParaRPr lang="en-US" sz="2400" b="1"/>
-            </a:p>
-          </p:txBody>
-        </p:sp>
-        <p:sp>
-          <p:nvSpPr>
-            <p:cNvPr id="89" name="TextBox 88">
-              <a:extLst>
-                <a:ext uri="{FF2B5EF4-FFF2-40B4-BE49-F238E27FC236}">
-                  <a16:creationId xmlns:a16="http://schemas.microsoft.com/office/drawing/2014/main" id="{E21A0350-A399-3FA7-BADE-014F48B7C028}"/>
-                </a:ext>
-              </a:extLst>
-            </p:cNvPr>
-            <p:cNvSpPr txBox="1"/>
-            <p:nvPr/>
-          </p:nvSpPr>
-          <p:spPr>
-            <a:xfrm>
-              <a:off x="7775723" y="2456959"/>
-              <a:ext cx="679994" cy="230832"/>
-            </a:xfrm>
-            <a:prstGeom prst="rect">
-              <a:avLst/>
-            </a:prstGeom>
-            <a:noFill/>
-          </p:spPr>
-          <p:txBody>
-            <a:bodyPr wrap="none" rtlCol="0">
-              <a:spAutoFit/>
-            </a:bodyPr>
-            <a:lstStyle/>
-            <a:p>
-              <a:pPr algn="l"/>
-              <a:r>
-                <a:rPr lang="en-US" sz="900" b="1" spc="0" baseline="0">
-                  <a:ln/>
-                  <a:solidFill>
-                    <a:srgbClr val="625F8A"/>
-                  </a:solidFill>
-                  <a:latin typeface="Segoe UI"/>
-                  <a:cs typeface="Segoe UI"/>
-                  <a:sym typeface="Segoe UI"/>
-                  <a:rtl val="0"/>
-                </a:rPr>
-                <a:t>Apr 2022</a:t>
-              </a:r>
-            </a:p>
-          </p:txBody>
-        </p:sp>
-        <p:sp>
-          <p:nvSpPr>
-            <p:cNvPr id="90" name="Freeform: Shape 89">
-              <a:extLst>
-                <a:ext uri="{FF2B5EF4-FFF2-40B4-BE49-F238E27FC236}">
-                  <a16:creationId xmlns:a16="http://schemas.microsoft.com/office/drawing/2014/main" id="{46CE8176-3271-D450-536D-534F069963F6}"/>
-                </a:ext>
-              </a:extLst>
-            </p:cNvPr>
-            <p:cNvSpPr/>
-            <p:nvPr/>
-          </p:nvSpPr>
-          <p:spPr>
-            <a:xfrm>
-              <a:off x="8782050" y="2409825"/>
-              <a:ext cx="9525" cy="66675"/>
-            </a:xfrm>
-            <a:custGeom>
-              <a:avLst/>
-              <a:gdLst>
-                <a:gd name="csX0" fmla="*/ 0 w 9525"/>
-                <a:gd name="csY0" fmla="*/ 0 h 66675"/>
-                <a:gd name="csX1" fmla="*/ 0 w 9525"/>
-                <a:gd name="csY1" fmla="*/ 66675 h 66675"/>
-              </a:gdLst>
-              <a:ahLst/>
-              <a:cxnLst>
-                <a:cxn ang="0">
-                  <a:pos x="csX0" y="csY0"/>
-                </a:cxn>
-                <a:cxn ang="0">
-                  <a:pos x="csX1" y="csY1"/>
-                </a:cxn>
-              </a:cxnLst>
-              <a:rect l="l" t="t" r="r" b="b"/>
-              <a:pathLst>
-                <a:path w="9525" h="66675">
-                  <a:moveTo>
-                    <a:pt x="0" y="0"/>
-                  </a:moveTo>
-                  <a:lnTo>
-                    <a:pt x="0" y="66675"/>
-                  </a:lnTo>
-                </a:path>
-              </a:pathLst>
-            </a:custGeom>
-            <a:ln w="7620" cap="flat">
-              <a:solidFill>
-                <a:srgbClr val="3A3A6A"/>
-              </a:solidFill>
-              <a:prstDash val="solid"/>
-              <a:miter/>
-            </a:ln>
-          </p:spPr>
-          <p:txBody>
-            <a:bodyPr/>
-            <a:lstStyle/>
-            <a:p>
-              <a:endParaRPr lang="en-US" sz="2400" b="1"/>
-            </a:p>
-          </p:txBody>
-        </p:sp>
-        <p:sp>
-          <p:nvSpPr>
-            <p:cNvPr id="91" name="TextBox 90">
-              <a:extLst>
-                <a:ext uri="{FF2B5EF4-FFF2-40B4-BE49-F238E27FC236}">
-                  <a16:creationId xmlns:a16="http://schemas.microsoft.com/office/drawing/2014/main" id="{53A612A9-B091-1543-C755-A103554FB818}"/>
-                </a:ext>
-              </a:extLst>
-            </p:cNvPr>
-            <p:cNvSpPr txBox="1"/>
-            <p:nvPr/>
-          </p:nvSpPr>
-          <p:spPr>
-            <a:xfrm>
-              <a:off x="8510319" y="2456959"/>
-              <a:ext cx="668773" cy="230832"/>
-            </a:xfrm>
-            <a:prstGeom prst="rect">
-              <a:avLst/>
-            </a:prstGeom>
-            <a:noFill/>
-          </p:spPr>
-          <p:txBody>
-            <a:bodyPr wrap="none" rtlCol="0">
-              <a:spAutoFit/>
-            </a:bodyPr>
-            <a:lstStyle/>
-            <a:p>
-              <a:pPr algn="l"/>
-              <a:r>
-                <a:rPr lang="en-US" sz="900" b="1" spc="0" baseline="0">
-                  <a:ln/>
-                  <a:solidFill>
-                    <a:srgbClr val="625F8A"/>
-                  </a:solidFill>
-                  <a:latin typeface="Segoe UI"/>
-                  <a:cs typeface="Segoe UI"/>
-                  <a:sym typeface="Segoe UI"/>
-                  <a:rtl val="0"/>
-                </a:rPr>
-                <a:t>Oct 2022</a:t>
-              </a:r>
-            </a:p>
-          </p:txBody>
-        </p:sp>
-        <p:sp>
-          <p:nvSpPr>
-            <p:cNvPr id="92" name="Freeform: Shape 91">
-              <a:extLst>
-                <a:ext uri="{FF2B5EF4-FFF2-40B4-BE49-F238E27FC236}">
-                  <a16:creationId xmlns:a16="http://schemas.microsoft.com/office/drawing/2014/main" id="{278034E3-550A-F453-5A00-78C9F8FD98C6}"/>
-                </a:ext>
-              </a:extLst>
-            </p:cNvPr>
-            <p:cNvSpPr/>
-            <p:nvPr/>
-          </p:nvSpPr>
-          <p:spPr>
-            <a:xfrm>
-              <a:off x="9525000" y="2409825"/>
-              <a:ext cx="9525" cy="66675"/>
-            </a:xfrm>
-            <a:custGeom>
-              <a:avLst/>
-              <a:gdLst>
-                <a:gd name="csX0" fmla="*/ 0 w 9525"/>
-                <a:gd name="csY0" fmla="*/ 0 h 66675"/>
-                <a:gd name="csX1" fmla="*/ 0 w 9525"/>
-                <a:gd name="csY1" fmla="*/ 66675 h 66675"/>
-              </a:gdLst>
-              <a:ahLst/>
-              <a:cxnLst>
-                <a:cxn ang="0">
-                  <a:pos x="csX0" y="csY0"/>
-                </a:cxn>
-                <a:cxn ang="0">
-                  <a:pos x="csX1" y="csY1"/>
-                </a:cxn>
-              </a:cxnLst>
-              <a:rect l="l" t="t" r="r" b="b"/>
-              <a:pathLst>
-                <a:path w="9525" h="66675">
-                  <a:moveTo>
-                    <a:pt x="0" y="0"/>
-                  </a:moveTo>
-                  <a:lnTo>
-                    <a:pt x="0" y="66675"/>
-                  </a:lnTo>
-                </a:path>
-              </a:pathLst>
-            </a:custGeom>
-            <a:ln w="7620" cap="flat">
-              <a:solidFill>
-                <a:srgbClr val="3A3A6A"/>
-              </a:solidFill>
-              <a:prstDash val="solid"/>
-              <a:miter/>
-            </a:ln>
-          </p:spPr>
-          <p:txBody>
-            <a:bodyPr/>
-            <a:lstStyle/>
-            <a:p>
-              <a:endParaRPr lang="en-US" sz="2400" b="1"/>
-            </a:p>
-          </p:txBody>
-        </p:sp>
-        <p:sp>
-          <p:nvSpPr>
-            <p:cNvPr id="93" name="TextBox 92">
-              <a:extLst>
-                <a:ext uri="{FF2B5EF4-FFF2-40B4-BE49-F238E27FC236}">
-                  <a16:creationId xmlns:a16="http://schemas.microsoft.com/office/drawing/2014/main" id="{354C49AA-D41E-A065-E576-4A2E3127319C}"/>
-                </a:ext>
-              </a:extLst>
-            </p:cNvPr>
-            <p:cNvSpPr txBox="1"/>
-            <p:nvPr/>
-          </p:nvSpPr>
-          <p:spPr>
-            <a:xfrm>
-              <a:off x="9252098" y="2456959"/>
-              <a:ext cx="679994" cy="230832"/>
-            </a:xfrm>
-            <a:prstGeom prst="rect">
-              <a:avLst/>
-            </a:prstGeom>
-            <a:noFill/>
-          </p:spPr>
-          <p:txBody>
-            <a:bodyPr wrap="none" rtlCol="0">
-              <a:spAutoFit/>
-            </a:bodyPr>
-            <a:lstStyle/>
-            <a:p>
-              <a:pPr algn="l"/>
-              <a:r>
-                <a:rPr lang="en-US" sz="900" b="1" spc="0" baseline="0">
-                  <a:ln/>
-                  <a:solidFill>
-                    <a:srgbClr val="625F8A"/>
-                  </a:solidFill>
-                  <a:latin typeface="Segoe UI"/>
-                  <a:cs typeface="Segoe UI"/>
-                  <a:sym typeface="Segoe UI"/>
-                  <a:rtl val="0"/>
-                </a:rPr>
-                <a:t>Apr 2023</a:t>
-              </a:r>
-            </a:p>
-          </p:txBody>
-        </p:sp>
-        <p:sp>
-          <p:nvSpPr>
-            <p:cNvPr id="94" name="Freeform: Shape 93">
-              <a:extLst>
-                <a:ext uri="{FF2B5EF4-FFF2-40B4-BE49-F238E27FC236}">
-                  <a16:creationId xmlns:a16="http://schemas.microsoft.com/office/drawing/2014/main" id="{5CCF3DC9-7065-E410-0D18-384C99755681}"/>
-                </a:ext>
-              </a:extLst>
-            </p:cNvPr>
-            <p:cNvSpPr/>
-            <p:nvPr/>
-          </p:nvSpPr>
-          <p:spPr>
-            <a:xfrm>
-              <a:off x="10258425" y="2409825"/>
-              <a:ext cx="9525" cy="66675"/>
-            </a:xfrm>
-            <a:custGeom>
-              <a:avLst/>
-              <a:gdLst>
-                <a:gd name="csX0" fmla="*/ 0 w 9525"/>
-                <a:gd name="csY0" fmla="*/ 0 h 66675"/>
-                <a:gd name="csX1" fmla="*/ 0 w 9525"/>
-                <a:gd name="csY1" fmla="*/ 66675 h 66675"/>
-              </a:gdLst>
-              <a:ahLst/>
-              <a:cxnLst>
-                <a:cxn ang="0">
-                  <a:pos x="csX0" y="csY0"/>
-                </a:cxn>
-                <a:cxn ang="0">
-                  <a:pos x="csX1" y="csY1"/>
-                </a:cxn>
-              </a:cxnLst>
-              <a:rect l="l" t="t" r="r" b="b"/>
-              <a:pathLst>
-                <a:path w="9525" h="66675">
-                  <a:moveTo>
-                    <a:pt x="0" y="0"/>
-                  </a:moveTo>
-                  <a:lnTo>
-                    <a:pt x="0" y="66675"/>
-                  </a:lnTo>
-                </a:path>
-              </a:pathLst>
-            </a:custGeom>
-            <a:ln w="7620" cap="flat">
-              <a:solidFill>
-                <a:srgbClr val="3A3A6A"/>
-              </a:solidFill>
-              <a:prstDash val="solid"/>
-              <a:miter/>
-            </a:ln>
-          </p:spPr>
-          <p:txBody>
-            <a:bodyPr/>
-            <a:lstStyle/>
-            <a:p>
-              <a:endParaRPr lang="en-US" sz="2400" b="1"/>
-            </a:p>
-          </p:txBody>
-        </p:sp>
-        <p:sp>
-          <p:nvSpPr>
-            <p:cNvPr id="95" name="TextBox 94">
-              <a:extLst>
-                <a:ext uri="{FF2B5EF4-FFF2-40B4-BE49-F238E27FC236}">
-                  <a16:creationId xmlns:a16="http://schemas.microsoft.com/office/drawing/2014/main" id="{22B2EFFB-DFCB-740F-4397-6F9AE366DBE1}"/>
-                </a:ext>
-              </a:extLst>
-            </p:cNvPr>
-            <p:cNvSpPr txBox="1"/>
-            <p:nvPr/>
-          </p:nvSpPr>
-          <p:spPr>
-            <a:xfrm>
-              <a:off x="9986694" y="2456959"/>
-              <a:ext cx="668773" cy="230832"/>
-            </a:xfrm>
-            <a:prstGeom prst="rect">
-              <a:avLst/>
-            </a:prstGeom>
-            <a:noFill/>
-          </p:spPr>
-          <p:txBody>
-            <a:bodyPr wrap="none" rtlCol="0">
-              <a:spAutoFit/>
-            </a:bodyPr>
-            <a:lstStyle/>
-            <a:p>
-              <a:pPr algn="l"/>
-              <a:r>
-                <a:rPr lang="en-US" sz="900" b="1" spc="0" baseline="0">
-                  <a:ln/>
-                  <a:solidFill>
-                    <a:srgbClr val="625F8A"/>
-                  </a:solidFill>
-                  <a:latin typeface="Segoe UI"/>
-                  <a:cs typeface="Segoe UI"/>
-                  <a:sym typeface="Segoe UI"/>
-                  <a:rtl val="0"/>
-                </a:rPr>
-                <a:t>Oct 2023</a:t>
-              </a:r>
-            </a:p>
-          </p:txBody>
-        </p:sp>
-        <p:sp>
-          <p:nvSpPr>
-            <p:cNvPr id="96" name="Freeform: Shape 95">
-              <a:extLst>
-                <a:ext uri="{FF2B5EF4-FFF2-40B4-BE49-F238E27FC236}">
-                  <a16:creationId xmlns:a16="http://schemas.microsoft.com/office/drawing/2014/main" id="{F1B2FA54-2789-6E0D-F49F-06289D033B1F}"/>
-                </a:ext>
-              </a:extLst>
-            </p:cNvPr>
-            <p:cNvSpPr/>
-            <p:nvPr/>
-          </p:nvSpPr>
-          <p:spPr>
-            <a:xfrm>
-              <a:off x="10991850" y="2409825"/>
-              <a:ext cx="9525" cy="66675"/>
-            </a:xfrm>
-            <a:custGeom>
-              <a:avLst/>
-              <a:gdLst>
-                <a:gd name="csX0" fmla="*/ 0 w 9525"/>
-                <a:gd name="csY0" fmla="*/ 0 h 66675"/>
-                <a:gd name="csX1" fmla="*/ 0 w 9525"/>
-                <a:gd name="csY1" fmla="*/ 66675 h 66675"/>
-              </a:gdLst>
-              <a:ahLst/>
-              <a:cxnLst>
-                <a:cxn ang="0">
-                  <a:pos x="csX0" y="csY0"/>
-                </a:cxn>
-                <a:cxn ang="0">
-                  <a:pos x="csX1" y="csY1"/>
-                </a:cxn>
-              </a:cxnLst>
-              <a:rect l="l" t="t" r="r" b="b"/>
-              <a:pathLst>
-                <a:path w="9525" h="66675">
-                  <a:moveTo>
-                    <a:pt x="0" y="0"/>
-                  </a:moveTo>
-                  <a:lnTo>
-                    <a:pt x="0" y="66675"/>
-                  </a:lnTo>
-                </a:path>
-              </a:pathLst>
-            </a:custGeom>
-            <a:ln w="7620" cap="flat">
-              <a:solidFill>
-                <a:srgbClr val="3A3A6A"/>
-              </a:solidFill>
-              <a:prstDash val="solid"/>
-              <a:miter/>
-            </a:ln>
-          </p:spPr>
-          <p:txBody>
-            <a:bodyPr/>
-            <a:lstStyle/>
-            <a:p>
-              <a:endParaRPr lang="en-US" sz="2400" b="1"/>
-            </a:p>
-          </p:txBody>
-        </p:sp>
-        <p:sp>
-          <p:nvSpPr>
-            <p:cNvPr id="97" name="TextBox 96">
-              <a:extLst>
-                <a:ext uri="{FF2B5EF4-FFF2-40B4-BE49-F238E27FC236}">
-                  <a16:creationId xmlns:a16="http://schemas.microsoft.com/office/drawing/2014/main" id="{F24246DB-2654-E9A0-3E98-EC9FA3579F7A}"/>
-                </a:ext>
-              </a:extLst>
-            </p:cNvPr>
-            <p:cNvSpPr txBox="1"/>
-            <p:nvPr/>
-          </p:nvSpPr>
-          <p:spPr>
-            <a:xfrm>
-              <a:off x="10718948" y="2456959"/>
-              <a:ext cx="679994" cy="230832"/>
-            </a:xfrm>
-            <a:prstGeom prst="rect">
-              <a:avLst/>
-            </a:prstGeom>
-            <a:noFill/>
-          </p:spPr>
-          <p:txBody>
-            <a:bodyPr wrap="none" rtlCol="0">
-              <a:spAutoFit/>
-            </a:bodyPr>
-            <a:lstStyle/>
-            <a:p>
-              <a:pPr algn="l"/>
-              <a:r>
-                <a:rPr lang="en-US" sz="900" b="1" spc="0" baseline="0">
-                  <a:ln/>
-                  <a:solidFill>
-                    <a:srgbClr val="625F8A"/>
-                  </a:solidFill>
-                  <a:latin typeface="Segoe UI"/>
-                  <a:cs typeface="Segoe UI"/>
-                  <a:sym typeface="Segoe UI"/>
-                  <a:rtl val="0"/>
-                </a:rPr>
-                <a:t>Apr 2024</a:t>
-              </a:r>
-            </a:p>
-          </p:txBody>
-        </p:sp>
-        <p:sp>
-          <p:nvSpPr>
-            <p:cNvPr id="98" name="Freeform: Shape 97">
-              <a:extLst>
-                <a:ext uri="{FF2B5EF4-FFF2-40B4-BE49-F238E27FC236}">
-                  <a16:creationId xmlns:a16="http://schemas.microsoft.com/office/drawing/2014/main" id="{B9FCC387-09FE-1FF6-8993-C4FDAE5EC058}"/>
-                </a:ext>
-              </a:extLst>
-            </p:cNvPr>
-            <p:cNvSpPr/>
-            <p:nvPr/>
-          </p:nvSpPr>
-          <p:spPr>
-            <a:xfrm>
-              <a:off x="11734800" y="2409825"/>
-              <a:ext cx="9525" cy="66675"/>
-            </a:xfrm>
-            <a:custGeom>
-              <a:avLst/>
-              <a:gdLst>
-                <a:gd name="csX0" fmla="*/ 0 w 9525"/>
-                <a:gd name="csY0" fmla="*/ 0 h 66675"/>
-                <a:gd name="csX1" fmla="*/ 0 w 9525"/>
-                <a:gd name="csY1" fmla="*/ 66675 h 66675"/>
-              </a:gdLst>
-              <a:ahLst/>
-              <a:cxnLst>
-                <a:cxn ang="0">
-                  <a:pos x="csX0" y="csY0"/>
-                </a:cxn>
-                <a:cxn ang="0">
-                  <a:pos x="csX1" y="csY1"/>
-                </a:cxn>
-              </a:cxnLst>
-              <a:rect l="l" t="t" r="r" b="b"/>
-              <a:pathLst>
-                <a:path w="9525" h="66675">
-                  <a:moveTo>
-                    <a:pt x="0" y="0"/>
-                  </a:moveTo>
-                  <a:lnTo>
-                    <a:pt x="0" y="66675"/>
-                  </a:lnTo>
-                </a:path>
-              </a:pathLst>
-            </a:custGeom>
-            <a:ln w="7620" cap="flat">
-              <a:solidFill>
-                <a:srgbClr val="3A3A6A"/>
-              </a:solidFill>
-              <a:prstDash val="solid"/>
-              <a:miter/>
-            </a:ln>
-          </p:spPr>
-          <p:txBody>
-            <a:bodyPr/>
-            <a:lstStyle/>
-            <a:p>
-              <a:endParaRPr lang="en-US" sz="2400" b="1"/>
-            </a:p>
-          </p:txBody>
-        </p:sp>
-        <p:sp>
-          <p:nvSpPr>
-            <p:cNvPr id="99" name="TextBox 98">
-              <a:extLst>
-                <a:ext uri="{FF2B5EF4-FFF2-40B4-BE49-F238E27FC236}">
-                  <a16:creationId xmlns:a16="http://schemas.microsoft.com/office/drawing/2014/main" id="{4EF4D1B3-7879-1F6D-977A-1C8A053167A1}"/>
-                </a:ext>
-              </a:extLst>
-            </p:cNvPr>
-            <p:cNvSpPr txBox="1"/>
-            <p:nvPr/>
-          </p:nvSpPr>
-          <p:spPr>
-            <a:xfrm>
-              <a:off x="11463069" y="2456959"/>
-              <a:ext cx="668773" cy="230832"/>
-            </a:xfrm>
-            <a:prstGeom prst="rect">
-              <a:avLst/>
-            </a:prstGeom>
-            <a:noFill/>
-          </p:spPr>
-          <p:txBody>
-            <a:bodyPr wrap="none" rtlCol="0">
-              <a:spAutoFit/>
-            </a:bodyPr>
-            <a:lstStyle/>
-            <a:p>
-              <a:pPr algn="l"/>
-              <a:r>
-                <a:rPr lang="en-US" sz="900" b="1" spc="0" baseline="0">
-                  <a:ln/>
-                  <a:solidFill>
-                    <a:srgbClr val="625F8A"/>
-                  </a:solidFill>
-                  <a:latin typeface="Segoe UI"/>
-                  <a:cs typeface="Segoe UI"/>
-                  <a:sym typeface="Segoe UI"/>
-                  <a:rtl val="0"/>
-                </a:rPr>
-                <a:t>Oct 2024</a:t>
-              </a:r>
-            </a:p>
-          </p:txBody>
-        </p:sp>
-        <p:sp>
-          <p:nvSpPr>
-            <p:cNvPr id="100" name="Freeform: Shape 99">
-              <a:extLst>
-                <a:ext uri="{FF2B5EF4-FFF2-40B4-BE49-F238E27FC236}">
-                  <a16:creationId xmlns:a16="http://schemas.microsoft.com/office/drawing/2014/main" id="{F03B7955-5390-1920-FB1A-1438120F213B}"/>
-                </a:ext>
-              </a:extLst>
-            </p:cNvPr>
-            <p:cNvSpPr/>
-            <p:nvPr/>
-          </p:nvSpPr>
-          <p:spPr>
-            <a:xfrm>
-              <a:off x="7810500" y="2714625"/>
-              <a:ext cx="114300" cy="95250"/>
-            </a:xfrm>
-            <a:custGeom>
-              <a:avLst/>
-              <a:gdLst>
-                <a:gd name="csX0" fmla="*/ 95250 w 114300"/>
-                <a:gd name="csY0" fmla="*/ 0 h 95250"/>
-                <a:gd name="csX1" fmla="*/ 114300 w 114300"/>
-                <a:gd name="csY1" fmla="*/ 0 h 95250"/>
-                <a:gd name="csX2" fmla="*/ 114300 w 114300"/>
-                <a:gd name="csY2" fmla="*/ 95250 h 95250"/>
-                <a:gd name="csX3" fmla="*/ 95250 w 114300"/>
-                <a:gd name="csY3" fmla="*/ 95250 h 95250"/>
-                <a:gd name="csX4" fmla="*/ 19050 w 114300"/>
-                <a:gd name="csY4" fmla="*/ 95250 h 95250"/>
-                <a:gd name="csX5" fmla="*/ 0 w 114300"/>
-                <a:gd name="csY5" fmla="*/ 95250 h 95250"/>
-                <a:gd name="csX6" fmla="*/ 0 w 114300"/>
-                <a:gd name="csY6" fmla="*/ 0 h 95250"/>
-                <a:gd name="csX7" fmla="*/ 19050 w 114300"/>
-                <a:gd name="csY7" fmla="*/ 0 h 95250"/>
-              </a:gdLst>
-              <a:ahLst/>
-              <a:cxnLst>
-                <a:cxn ang="0">
-                  <a:pos x="csX0" y="csY0"/>
-                </a:cxn>
-                <a:cxn ang="0">
-                  <a:pos x="csX1" y="csY1"/>
-                </a:cxn>
-                <a:cxn ang="0">
-                  <a:pos x="csX2" y="csY2"/>
-                </a:cxn>
-                <a:cxn ang="0">
-                  <a:pos x="csX3" y="csY3"/>
-                </a:cxn>
-                <a:cxn ang="0">
-                  <a:pos x="csX4" y="csY4"/>
-                </a:cxn>
-                <a:cxn ang="0">
-                  <a:pos x="csX5" y="csY5"/>
-                </a:cxn>
-                <a:cxn ang="0">
-                  <a:pos x="csX6" y="csY6"/>
-                </a:cxn>
-                <a:cxn ang="0">
-                  <a:pos x="csX7" y="csY7"/>
-                </a:cxn>
-              </a:cxnLst>
-              <a:rect l="l" t="t" r="r" b="b"/>
-              <a:pathLst>
-                <a:path w="114300" h="95250">
-                  <a:moveTo>
-                    <a:pt x="95250" y="0"/>
-                  </a:moveTo>
-                  <a:cubicBezTo>
-                    <a:pt x="105771" y="0"/>
-                    <a:pt x="114300" y="0"/>
-                    <a:pt x="114300" y="0"/>
-                  </a:cubicBezTo>
-                  <a:lnTo>
-                    <a:pt x="114300" y="95250"/>
-                  </a:lnTo>
-                  <a:cubicBezTo>
-                    <a:pt x="114300" y="95250"/>
-                    <a:pt x="105771" y="95250"/>
-                    <a:pt x="95250" y="95250"/>
-                  </a:cubicBezTo>
-                  <a:lnTo>
-                    <a:pt x="19050" y="95250"/>
-                  </a:lnTo>
-                  <a:cubicBezTo>
-                    <a:pt x="8529" y="95250"/>
-                    <a:pt x="0" y="95250"/>
-                    <a:pt x="0" y="95250"/>
-                  </a:cubicBezTo>
-                  <a:lnTo>
-                    <a:pt x="0" y="0"/>
-                  </a:lnTo>
-                  <a:cubicBezTo>
-                    <a:pt x="0" y="0"/>
-                    <a:pt x="8529" y="0"/>
-                    <a:pt x="19050" y="0"/>
-                  </a:cubicBezTo>
-                  <a:close/>
-                </a:path>
-              </a:pathLst>
-            </a:custGeom>
-            <a:solidFill>
-              <a:srgbClr val="534AB7">
-                <a:alpha val="82000"/>
-              </a:srgbClr>
-            </a:solidFill>
-            <a:ln w="9525" cap="flat">
-              <a:noFill/>
-              <a:prstDash val="solid"/>
-              <a:miter/>
-            </a:ln>
-          </p:spPr>
-          <p:txBody>
-            <a:bodyPr/>
-            <a:lstStyle/>
-            <a:p>
-              <a:endParaRPr lang="en-US" sz="2400" b="1"/>
-            </a:p>
-          </p:txBody>
-        </p:sp>
-        <p:sp>
-          <p:nvSpPr>
-            <p:cNvPr id="101" name="TextBox 100">
-              <a:extLst>
-                <a:ext uri="{FF2B5EF4-FFF2-40B4-BE49-F238E27FC236}">
-                  <a16:creationId xmlns:a16="http://schemas.microsoft.com/office/drawing/2014/main" id="{ED057BBC-F4ED-A405-DBA7-F7EDBAE269D1}"/>
-                </a:ext>
-              </a:extLst>
-            </p:cNvPr>
-            <p:cNvSpPr txBox="1"/>
-            <p:nvPr/>
-          </p:nvSpPr>
-          <p:spPr>
-            <a:xfrm>
-              <a:off x="7871460" y="2651845"/>
-              <a:ext cx="1053494" cy="230832"/>
-            </a:xfrm>
-            <a:prstGeom prst="rect">
-              <a:avLst/>
-            </a:prstGeom>
-            <a:noFill/>
-          </p:spPr>
-          <p:txBody>
-            <a:bodyPr wrap="none" rtlCol="0">
-              <a:spAutoFit/>
-            </a:bodyPr>
-            <a:lstStyle/>
-            <a:p>
-              <a:pPr algn="l"/>
-              <a:r>
-                <a:rPr lang="en-US" sz="900" b="1" spc="0" baseline="0">
-                  <a:ln/>
-                  <a:solidFill>
-                    <a:srgbClr val="9F9DC8"/>
-                  </a:solidFill>
-                  <a:latin typeface="Segoe UI"/>
-                  <a:cs typeface="Segoe UI"/>
-                  <a:sym typeface="Segoe UI"/>
-                  <a:rtl val="0"/>
-                </a:rPr>
-                <a:t>Feature window</a:t>
-              </a:r>
-            </a:p>
-          </p:txBody>
-        </p:sp>
-        <p:sp>
-          <p:nvSpPr>
-            <p:cNvPr id="102" name="Freeform: Shape 101">
-              <a:extLst>
-                <a:ext uri="{FF2B5EF4-FFF2-40B4-BE49-F238E27FC236}">
-                  <a16:creationId xmlns:a16="http://schemas.microsoft.com/office/drawing/2014/main" id="{D15D7E9A-0651-179E-FC30-80EAF3F140AB}"/>
-                </a:ext>
-              </a:extLst>
-            </p:cNvPr>
-            <p:cNvSpPr/>
-            <p:nvPr/>
-          </p:nvSpPr>
-          <p:spPr>
-            <a:xfrm>
-              <a:off x="9144000" y="2714625"/>
-              <a:ext cx="114300" cy="95250"/>
-            </a:xfrm>
-            <a:custGeom>
-              <a:avLst/>
-              <a:gdLst>
-                <a:gd name="csX0" fmla="*/ 95250 w 114300"/>
-                <a:gd name="csY0" fmla="*/ 0 h 95250"/>
-                <a:gd name="csX1" fmla="*/ 114300 w 114300"/>
-                <a:gd name="csY1" fmla="*/ 0 h 95250"/>
-                <a:gd name="csX2" fmla="*/ 114300 w 114300"/>
-                <a:gd name="csY2" fmla="*/ 95250 h 95250"/>
-                <a:gd name="csX3" fmla="*/ 95250 w 114300"/>
-                <a:gd name="csY3" fmla="*/ 95250 h 95250"/>
-                <a:gd name="csX4" fmla="*/ 19050 w 114300"/>
-                <a:gd name="csY4" fmla="*/ 95250 h 95250"/>
-                <a:gd name="csX5" fmla="*/ 0 w 114300"/>
-                <a:gd name="csY5" fmla="*/ 95250 h 95250"/>
-                <a:gd name="csX6" fmla="*/ 0 w 114300"/>
-                <a:gd name="csY6" fmla="*/ 0 h 95250"/>
-                <a:gd name="csX7" fmla="*/ 19050 w 114300"/>
-                <a:gd name="csY7" fmla="*/ 0 h 95250"/>
-              </a:gdLst>
-              <a:ahLst/>
-              <a:cxnLst>
-                <a:cxn ang="0">
-                  <a:pos x="csX0" y="csY0"/>
-                </a:cxn>
-                <a:cxn ang="0">
-                  <a:pos x="csX1" y="csY1"/>
-                </a:cxn>
-                <a:cxn ang="0">
-                  <a:pos x="csX2" y="csY2"/>
-                </a:cxn>
-                <a:cxn ang="0">
-                  <a:pos x="csX3" y="csY3"/>
-                </a:cxn>
-                <a:cxn ang="0">
-                  <a:pos x="csX4" y="csY4"/>
-                </a:cxn>
-                <a:cxn ang="0">
-                  <a:pos x="csX5" y="csY5"/>
-                </a:cxn>
-                <a:cxn ang="0">
-                  <a:pos x="csX6" y="csY6"/>
-                </a:cxn>
-                <a:cxn ang="0">
-                  <a:pos x="csX7" y="csY7"/>
-                </a:cxn>
-              </a:cxnLst>
-              <a:rect l="l" t="t" r="r" b="b"/>
-              <a:pathLst>
-                <a:path w="114300" h="95250">
-                  <a:moveTo>
-                    <a:pt x="95250" y="0"/>
-                  </a:moveTo>
-                  <a:cubicBezTo>
-                    <a:pt x="105771" y="0"/>
-                    <a:pt x="114300" y="0"/>
-                    <a:pt x="114300" y="0"/>
-                  </a:cubicBezTo>
-                  <a:lnTo>
-                    <a:pt x="114300" y="95250"/>
-                  </a:lnTo>
-                  <a:cubicBezTo>
-                    <a:pt x="114300" y="95250"/>
-                    <a:pt x="105771" y="95250"/>
-                    <a:pt x="95250" y="95250"/>
-                  </a:cubicBezTo>
-                  <a:lnTo>
-                    <a:pt x="19050" y="95250"/>
-                  </a:lnTo>
-                  <a:cubicBezTo>
-                    <a:pt x="8529" y="95250"/>
-                    <a:pt x="0" y="95250"/>
-                    <a:pt x="0" y="95250"/>
-                  </a:cubicBezTo>
-                  <a:lnTo>
-                    <a:pt x="0" y="0"/>
-                  </a:lnTo>
-                  <a:cubicBezTo>
-                    <a:pt x="0" y="0"/>
-                    <a:pt x="8529" y="0"/>
-                    <a:pt x="19050" y="0"/>
-                  </a:cubicBezTo>
-                  <a:close/>
-                </a:path>
-              </a:pathLst>
-            </a:custGeom>
-            <a:solidFill>
-              <a:srgbClr val="D85A30">
-                <a:alpha val="82000"/>
-              </a:srgbClr>
-            </a:solidFill>
-            <a:ln w="9525" cap="flat">
-              <a:noFill/>
-              <a:prstDash val="solid"/>
-              <a:miter/>
-            </a:ln>
-          </p:spPr>
-          <p:txBody>
-            <a:bodyPr/>
-            <a:lstStyle/>
-            <a:p>
-              <a:endParaRPr lang="en-US" sz="2400" b="1"/>
-            </a:p>
-          </p:txBody>
-        </p:sp>
-        <p:sp>
-          <p:nvSpPr>
-            <p:cNvPr id="103" name="TextBox 102">
-              <a:extLst>
-                <a:ext uri="{FF2B5EF4-FFF2-40B4-BE49-F238E27FC236}">
-                  <a16:creationId xmlns:a16="http://schemas.microsoft.com/office/drawing/2014/main" id="{1A6DBF94-A969-EA6B-555C-19038AF073C9}"/>
-                </a:ext>
-              </a:extLst>
-            </p:cNvPr>
-            <p:cNvSpPr txBox="1"/>
-            <p:nvPr/>
-          </p:nvSpPr>
-          <p:spPr>
-            <a:xfrm>
-              <a:off x="9204960" y="2651845"/>
-              <a:ext cx="1234633" cy="230832"/>
-            </a:xfrm>
-            <a:prstGeom prst="rect">
-              <a:avLst/>
-            </a:prstGeom>
-            <a:noFill/>
-          </p:spPr>
-          <p:txBody>
-            <a:bodyPr wrap="none" rtlCol="0">
-              <a:spAutoFit/>
-            </a:bodyPr>
-            <a:lstStyle/>
-            <a:p>
-              <a:pPr algn="l"/>
-              <a:r>
-                <a:rPr lang="en-US" sz="900" b="1" spc="0" baseline="0">
-                  <a:ln/>
-                  <a:solidFill>
-                    <a:srgbClr val="9F9DC8"/>
-                  </a:solidFill>
-                  <a:latin typeface="Segoe UI"/>
-                  <a:cs typeface="Segoe UI"/>
-                  <a:sym typeface="Segoe UI"/>
-                  <a:rtl val="0"/>
-                </a:rPr>
-                <a:t>Target (12 months)</a:t>
-              </a:r>
-            </a:p>
-          </p:txBody>
-        </p:sp>
-      </p:grpSp>
-      <p:sp>
-        <p:nvSpPr>
-          <p:cNvPr id="36" name="TextBox 35">
-            <a:extLst>
-              <a:ext uri="{FF2B5EF4-FFF2-40B4-BE49-F238E27FC236}">
-                <a16:creationId xmlns:a16="http://schemas.microsoft.com/office/drawing/2014/main" id="{C3A83291-AFA7-90F1-92A1-60F153AD9AB6}"/>
-              </a:ext>
-            </a:extLst>
-          </p:cNvPr>
-          <p:cNvSpPr txBox="1"/>
-          <p:nvPr/>
-        </p:nvSpPr>
-        <p:spPr>
-          <a:xfrm>
-            <a:off x="5684475" y="209815"/>
-            <a:ext cx="6507525" cy="861774"/>
-          </a:xfrm>
-          <a:prstGeom prst="rect">
-            <a:avLst/>
-          </a:prstGeom>
-          <a:noFill/>
-        </p:spPr>
-        <p:txBody>
-          <a:bodyPr wrap="square">
-            <a:spAutoFit/>
-          </a:bodyPr>
-          <a:lstStyle/>
-          <a:p>
-            <a:pPr marL="285750" marR="0" lvl="0" indent="-285750" algn="l" defTabSz="914400" rtl="0" eaLnBrk="1" fontAlgn="auto" latinLnBrk="0" hangingPunct="1">
-              <a:lnSpc>
-                <a:spcPct val="100000"/>
-              </a:lnSpc>
-              <a:spcBef>
-                <a:spcPts val="0"/>
-              </a:spcBef>
-              <a:spcAft>
-                <a:spcPts val="0"/>
-              </a:spcAft>
-              <a:buClrTx/>
-              <a:buSzTx/>
-              <a:buFont typeface="Arial" panose="020B0604020202020204" pitchFamily="34" charset="0"/>
-              <a:buChar char="●"/>
-              <a:tabLst/>
-              <a:defRPr/>
-            </a:pPr>
-            <a:r>
-              <a:rPr kumimoji="0" lang="en-US" sz="1800" b="1" i="0" u="none" strike="noStrike" kern="1200" cap="none" spc="0" normalizeH="0" baseline="0" noProof="0" dirty="0">
-                <a:ln>
-                  <a:noFill/>
-                </a:ln>
-                <a:solidFill>
-                  <a:prstClr val="black"/>
-                </a:solidFill>
-                <a:effectLst/>
-                <a:uLnTx/>
-                <a:uFillTx/>
-                <a:latin typeface="Arial"/>
-                <a:ea typeface="+mn-ea"/>
-                <a:cs typeface="+mn-cs"/>
-              </a:rPr>
-              <a:t>The Setup</a:t>
-            </a:r>
-            <a:r>
-              <a:rPr kumimoji="0" lang="en-US" sz="1800" b="0" i="0" u="none" strike="noStrike" kern="1200" cap="none" spc="0" normalizeH="0" baseline="0" noProof="0" dirty="0">
-                <a:ln>
-                  <a:noFill/>
-                </a:ln>
-                <a:solidFill>
-                  <a:prstClr val="black"/>
-                </a:solidFill>
-                <a:effectLst/>
-                <a:uLnTx/>
-                <a:uFillTx/>
-                <a:latin typeface="Arial"/>
-                <a:ea typeface="+mn-ea"/>
-                <a:cs typeface="+mn-cs"/>
-              </a:rPr>
-              <a:t>: </a:t>
-            </a:r>
-            <a:r>
-              <a:rPr kumimoji="0" lang="en-US" sz="1600" b="0" i="0" u="none" strike="noStrike" kern="1200" cap="none" spc="0" normalizeH="0" baseline="0" noProof="0" dirty="0">
-                <a:ln>
-                  <a:noFill/>
-                </a:ln>
-                <a:solidFill>
-                  <a:prstClr val="black"/>
-                </a:solidFill>
-                <a:effectLst/>
-                <a:uLnTx/>
-                <a:uFillTx/>
-                <a:latin typeface="Arial"/>
-                <a:ea typeface="+mn-ea"/>
-                <a:cs typeface="+mn-cs"/>
-              </a:rPr>
-              <a:t>Filtered dataset to transactions from Jan 1, 2021, onwards to ensure the model learns from the new normal, using pure RFM features (Recency, Frequency, Monetary)</a:t>
-            </a:r>
-            <a:endParaRPr kumimoji="0" lang="en-US" sz="1800" b="0" i="0" u="none" strike="noStrike" kern="1200" cap="none" spc="0" normalizeH="0" baseline="0" noProof="0" dirty="0">
-              <a:ln>
-                <a:noFill/>
-              </a:ln>
-              <a:solidFill>
-                <a:prstClr val="black"/>
-              </a:solidFill>
-              <a:effectLst/>
-              <a:uLnTx/>
-              <a:uFillTx/>
-              <a:latin typeface="Arial"/>
-              <a:ea typeface="+mn-ea"/>
-              <a:cs typeface="+mn-cs"/>
-            </a:endParaRPr>
-          </a:p>
-        </p:txBody>
-      </p:sp>
-      <p:sp>
-        <p:nvSpPr>
           <p:cNvPr id="45" name="Freeform: Shape 44">
             <a:extLst>
               <a:ext uri="{FF2B5EF4-FFF2-40B4-BE49-F238E27FC236}">
@@ -10791,7 +8599,7 @@
         </p:nvGrpSpPr>
         <p:grpSpPr>
           <a:xfrm>
-            <a:off x="6825268" y="1135674"/>
+            <a:off x="113136" y="587947"/>
             <a:ext cx="4453045" cy="862763"/>
             <a:chOff x="7745455" y="1754196"/>
             <a:chExt cx="3420143" cy="862763"/>
@@ -11152,10 +8960,10 @@
       </p:grpSp>
       <p:sp>
         <p:nvSpPr>
-          <p:cNvPr id="14" name="TextBox 13">
-            <a:extLst>
-              <a:ext uri="{FF2B5EF4-FFF2-40B4-BE49-F238E27FC236}">
-                <a16:creationId xmlns:a16="http://schemas.microsoft.com/office/drawing/2014/main" id="{C3766DCB-B959-67E8-F5B9-DF360F58D8BF}"/>
+          <p:cNvPr id="12" name="TextBox 11">
+            <a:extLst>
+              <a:ext uri="{FF2B5EF4-FFF2-40B4-BE49-F238E27FC236}">
+                <a16:creationId xmlns:a16="http://schemas.microsoft.com/office/drawing/2014/main" id="{1E8C2E2E-BDEF-E0F0-0A29-F9FE32BFD08A}"/>
               </a:ext>
             </a:extLst>
           </p:cNvPr>
@@ -11164,8 +8972,8 @@
         </p:nvSpPr>
         <p:spPr>
           <a:xfrm>
-            <a:off x="8430888" y="2899122"/>
-            <a:ext cx="3048000" cy="1200329"/>
+            <a:off x="9648151" y="4838530"/>
+            <a:ext cx="2389816" cy="954107"/>
           </a:xfrm>
           <a:prstGeom prst="rect">
             <a:avLst/>
@@ -11184,118 +8992,269 @@
           <a:lstStyle/>
           <a:p>
             <a:r>
-              <a:rPr lang="en-US" b="1" i="0" dirty="0">
+              <a:rPr lang="en-US" sz="1400" b="1" i="0" dirty="0">
                 <a:effectLst/>
                 <a:latin typeface="Consolas" panose="020B0609020204030204" pitchFamily="49" charset="0"/>
               </a:rPr>
-              <a:t>Feature </a:t>
-            </a:r>
-            <a:r>
-              <a:rPr lang="en-US" b="1" dirty="0">
-                <a:latin typeface="Consolas" panose="020B0609020204030204" pitchFamily="49" charset="0"/>
-              </a:rPr>
-              <a:t>    </a:t>
-            </a:r>
-            <a:r>
-              <a:rPr lang="en-US" b="1" i="0" dirty="0">
+              <a:t>Feature     Importance</a:t>
+            </a:r>
+            <a:br>
+              <a:rPr lang="en-US" sz="1400" b="0" i="0" dirty="0">
                 <a:effectLst/>
                 <a:latin typeface="Consolas" panose="020B0609020204030204" pitchFamily="49" charset="0"/>
               </a:rPr>
-              <a:t>Importance</a:t>
-            </a:r>
-            <a:endParaRPr lang="en-US" b="0" i="0" dirty="0">
-              <a:effectLst/>
-              <a:latin typeface="Consolas" panose="020B0609020204030204" pitchFamily="49" charset="0"/>
-            </a:endParaRPr>
-          </a:p>
-          <a:p>
-            <a:r>
-              <a:rPr lang="en-US" dirty="0">
+            </a:br>
+            <a:r>
+              <a:rPr lang="en-US" sz="1400" dirty="0">
+                <a:latin typeface="Consolas" panose="020B0609020204030204" pitchFamily="49" charset="0"/>
+              </a:rPr>
+              <a:t>M</a:t>
+            </a:r>
+            <a:r>
+              <a:rPr lang="en-US" sz="1400" b="0" i="0" dirty="0">
+                <a:effectLst/>
+                <a:latin typeface="Consolas" panose="020B0609020204030204" pitchFamily="49" charset="0"/>
+              </a:rPr>
+              <a:t>onetary 	      556 </a:t>
+            </a:r>
+            <a:br>
+              <a:rPr lang="en-US" sz="1400" b="0" i="0" dirty="0">
+                <a:effectLst/>
+                <a:latin typeface="Consolas" panose="020B0609020204030204" pitchFamily="49" charset="0"/>
+              </a:rPr>
+            </a:br>
+            <a:r>
+              <a:rPr lang="en-US" sz="1400" dirty="0">
                 <a:latin typeface="Consolas" panose="020B0609020204030204" pitchFamily="49" charset="0"/>
               </a:rPr>
               <a:t>R</a:t>
             </a:r>
             <a:r>
-              <a:rPr lang="en-US" b="0" i="0" dirty="0">
+              <a:rPr lang="en-US" sz="1400" b="0" i="0" dirty="0">
                 <a:effectLst/>
                 <a:latin typeface="Consolas" panose="020B0609020204030204" pitchFamily="49" charset="0"/>
               </a:rPr>
-              <a:t>ecency 	</a:t>
-            </a:r>
-            <a:r>
-              <a:rPr lang="en-US" b="0" i="0" dirty="0">
-                <a:solidFill>
-                  <a:srgbClr val="C00000"/>
-                </a:solidFill>
+              <a:t>ecency 	      451 </a:t>
+            </a:r>
+            <a:br>
+              <a:rPr lang="en-US" sz="1400" b="0" i="0" dirty="0">
                 <a:effectLst/>
                 <a:latin typeface="Consolas" panose="020B0609020204030204" pitchFamily="49" charset="0"/>
               </a:rPr>
-              <a:t>-7793</a:t>
-            </a:r>
-          </a:p>
-          <a:p>
-            <a:r>
-              <a:rPr lang="en-US" dirty="0">
+            </a:br>
+            <a:r>
+              <a:rPr lang="en-US" sz="1400" dirty="0">
                 <a:latin typeface="Consolas" panose="020B0609020204030204" pitchFamily="49" charset="0"/>
               </a:rPr>
               <a:t>F</a:t>
             </a:r>
             <a:r>
-              <a:rPr lang="en-US" b="0" i="0" dirty="0">
+              <a:rPr lang="en-US" sz="1400" b="0" i="0" dirty="0">
                 <a:effectLst/>
                 <a:latin typeface="Consolas" panose="020B0609020204030204" pitchFamily="49" charset="0"/>
               </a:rPr>
-              <a:t>requency 	</a:t>
-            </a:r>
-            <a:r>
-              <a:rPr lang="en-US" b="0" i="0" dirty="0">
-                <a:solidFill>
-                  <a:srgbClr val="C00000"/>
-                </a:solidFill>
+              <a:t>requency      </a:t>
+            </a:r>
+            <a:r>
+              <a:rPr lang="en-US" sz="400" b="0" i="0" dirty="0">
                 <a:effectLst/>
                 <a:latin typeface="Consolas" panose="020B0609020204030204" pitchFamily="49" charset="0"/>
               </a:rPr>
-              <a:t>-9150</a:t>
-            </a:r>
-          </a:p>
-          <a:p>
-            <a:r>
-              <a:rPr lang="en-US" dirty="0">
-                <a:latin typeface="Consolas" panose="020B0609020204030204" pitchFamily="49" charset="0"/>
-              </a:rPr>
-              <a:t>M</a:t>
-            </a:r>
-            <a:r>
-              <a:rPr lang="en-US" b="0" i="0" dirty="0">
+              <a:t> </a:t>
+            </a:r>
+            <a:r>
+              <a:rPr lang="en-US" sz="1400" b="0" i="0" dirty="0">
                 <a:effectLst/>
                 <a:latin typeface="Consolas" panose="020B0609020204030204" pitchFamily="49" charset="0"/>
               </a:rPr>
-              <a:t>onetary 	</a:t>
-            </a:r>
-            <a:r>
-              <a:rPr lang="en-US" b="0" i="0" dirty="0">
-                <a:solidFill>
-                  <a:srgbClr val="1D9E75"/>
-                </a:solidFill>
-                <a:effectLst/>
-                <a:latin typeface="Consolas" panose="020B0609020204030204" pitchFamily="49" charset="0"/>
-              </a:rPr>
-              <a:t>21982</a:t>
-            </a:r>
-            <a:endParaRPr lang="en-US" dirty="0">
+              <a:t>337</a:t>
+            </a:r>
+            <a:endParaRPr lang="en-US" sz="1400" dirty="0"/>
+          </a:p>
+        </p:txBody>
+      </p:sp>
+      <p:sp>
+        <p:nvSpPr>
+          <p:cNvPr id="7" name="TextBox 6">
+            <a:extLst>
+              <a:ext uri="{FF2B5EF4-FFF2-40B4-BE49-F238E27FC236}">
+                <a16:creationId xmlns:a16="http://schemas.microsoft.com/office/drawing/2014/main" id="{46ED149C-09C2-3EEC-58DC-B9A96AE142B0}"/>
+              </a:ext>
+            </a:extLst>
+          </p:cNvPr>
+          <p:cNvSpPr txBox="1"/>
+          <p:nvPr/>
+        </p:nvSpPr>
+        <p:spPr>
+          <a:xfrm>
+            <a:off x="11122753" y="5792637"/>
+            <a:ext cx="559769" cy="276999"/>
+          </a:xfrm>
+          <a:prstGeom prst="rect">
+            <a:avLst/>
+          </a:prstGeom>
+          <a:noFill/>
+        </p:spPr>
+        <p:txBody>
+          <a:bodyPr wrap="none" rtlCol="0">
+            <a:spAutoFit/>
+          </a:bodyPr>
+          <a:lstStyle/>
+          <a:p>
+            <a:r>
+              <a:rPr lang="it-IT" sz="1200" i="1" dirty="0" err="1"/>
+              <a:t>Splits</a:t>
+            </a:r>
+            <a:endParaRPr lang="en-US" i="1" dirty="0"/>
+          </a:p>
+        </p:txBody>
+      </p:sp>
+      <p:grpSp>
+        <p:nvGrpSpPr>
+          <p:cNvPr id="18" name="Group 17">
+            <a:extLst>
+              <a:ext uri="{FF2B5EF4-FFF2-40B4-BE49-F238E27FC236}">
+                <a16:creationId xmlns:a16="http://schemas.microsoft.com/office/drawing/2014/main" id="{97303FA8-A842-8B78-6F17-C7979BFF9A9C}"/>
+              </a:ext>
+            </a:extLst>
+          </p:cNvPr>
+          <p:cNvGrpSpPr/>
+          <p:nvPr/>
+        </p:nvGrpSpPr>
+        <p:grpSpPr>
+          <a:xfrm>
+            <a:off x="113136" y="1579371"/>
+            <a:ext cx="4955457" cy="3683560"/>
+            <a:chOff x="304800" y="2482571"/>
+            <a:chExt cx="5307509" cy="3957118"/>
+          </a:xfrm>
+        </p:grpSpPr>
+        <p:pic>
+          <p:nvPicPr>
+            <p:cNvPr id="16" name="Picture 15">
+              <a:extLst>
+                <a:ext uri="{FF2B5EF4-FFF2-40B4-BE49-F238E27FC236}">
+                  <a16:creationId xmlns:a16="http://schemas.microsoft.com/office/drawing/2014/main" id="{2D987225-2772-B115-2B3D-6C7910618B4C}"/>
+                </a:ext>
+              </a:extLst>
+            </p:cNvPr>
+            <p:cNvPicPr>
+              <a:picLocks noChangeAspect="1"/>
+            </p:cNvPicPr>
+            <p:nvPr/>
+          </p:nvPicPr>
+          <p:blipFill>
+            <a:blip r:embed="rId3"/>
+            <a:stretch>
+              <a:fillRect/>
+            </a:stretch>
+          </p:blipFill>
+          <p:spPr>
+            <a:xfrm>
+              <a:off x="304800" y="2482571"/>
+              <a:ext cx="5307509" cy="3957118"/>
+            </a:xfrm>
+            <a:prstGeom prst="rect">
+              <a:avLst/>
+            </a:prstGeom>
+          </p:spPr>
+        </p:pic>
+        <p:sp>
+          <p:nvSpPr>
+            <p:cNvPr id="10" name="TextBox 9">
+              <a:extLst>
+                <a:ext uri="{FF2B5EF4-FFF2-40B4-BE49-F238E27FC236}">
+                  <a16:creationId xmlns:a16="http://schemas.microsoft.com/office/drawing/2014/main" id="{10C8069D-901F-4AE7-3D95-774CDEF163D4}"/>
+                </a:ext>
+              </a:extLst>
+            </p:cNvPr>
+            <p:cNvSpPr txBox="1"/>
+            <p:nvPr/>
+          </p:nvSpPr>
+          <p:spPr>
+            <a:xfrm>
+              <a:off x="2806499" y="3742189"/>
+              <a:ext cx="765447" cy="357262"/>
+            </a:xfrm>
+            <a:prstGeom prst="rect">
+              <a:avLst/>
+            </a:prstGeom>
+            <a:noFill/>
+          </p:spPr>
+          <p:txBody>
+            <a:bodyPr wrap="none" rtlCol="0">
+              <a:spAutoFit/>
+            </a:bodyPr>
+            <a:lstStyle/>
+            <a:p>
+              <a:pPr algn="l"/>
+              <a:r>
+                <a:rPr lang="en-US" sz="1600" b="1" spc="0" baseline="0" dirty="0">
+                  <a:ln/>
+                  <a:solidFill>
+                    <a:srgbClr val="1D9E75"/>
+                  </a:solidFill>
+                  <a:latin typeface="Segoe UI"/>
+                  <a:cs typeface="Segoe UI"/>
+                  <a:sym typeface="Segoe UI"/>
+                  <a:rtl val="0"/>
+                </a:rPr>
+                <a:t>−31%</a:t>
+              </a:r>
+            </a:p>
+          </p:txBody>
+        </p:sp>
+        <p:cxnSp>
+          <p:nvCxnSpPr>
+            <p:cNvPr id="13" name="Straight Arrow Connector 12">
+              <a:extLst>
+                <a:ext uri="{FF2B5EF4-FFF2-40B4-BE49-F238E27FC236}">
+                  <a16:creationId xmlns:a16="http://schemas.microsoft.com/office/drawing/2014/main" id="{9D124440-49AE-1463-88FD-CFF585FECD2D}"/>
+                </a:ext>
+              </a:extLst>
+            </p:cNvPr>
+            <p:cNvCxnSpPr>
+              <a:cxnSpLocks/>
+            </p:cNvCxnSpPr>
+            <p:nvPr/>
+          </p:nvCxnSpPr>
+          <p:spPr>
+            <a:xfrm>
+              <a:off x="2547278" y="3817040"/>
+              <a:ext cx="1299786" cy="975144"/>
+            </a:xfrm>
+            <a:prstGeom prst="straightConnector1">
+              <a:avLst/>
+            </a:prstGeom>
+            <a:ln>
               <a:solidFill>
                 <a:srgbClr val="1D9E75"/>
               </a:solidFill>
-            </a:endParaRPr>
-          </a:p>
-        </p:txBody>
-      </p:sp>
-      <p:sp>
-        <p:nvSpPr>
-          <p:cNvPr id="12" name="TextBox 11">
-            <a:extLst>
-              <a:ext uri="{FF2B5EF4-FFF2-40B4-BE49-F238E27FC236}">
-                <a16:creationId xmlns:a16="http://schemas.microsoft.com/office/drawing/2014/main" id="{1E8C2E2E-BDEF-E0F0-0A29-F9FE32BFD08A}"/>
+              <a:tailEnd type="triangle"/>
+            </a:ln>
+          </p:spPr>
+          <p:style>
+            <a:lnRef idx="1">
+              <a:schemeClr val="accent1"/>
+            </a:lnRef>
+            <a:fillRef idx="0">
+              <a:schemeClr val="accent1"/>
+            </a:fillRef>
+            <a:effectRef idx="0">
+              <a:schemeClr val="accent1"/>
+            </a:effectRef>
+            <a:fontRef idx="minor">
+              <a:schemeClr val="tx1"/>
+            </a:fontRef>
+          </p:style>
+        </p:cxnSp>
+      </p:grpSp>
+      <p:sp>
+        <p:nvSpPr>
+          <p:cNvPr id="19" name="TextBox 18">
+            <a:extLst>
+              <a:ext uri="{FF2B5EF4-FFF2-40B4-BE49-F238E27FC236}">
+                <a16:creationId xmlns:a16="http://schemas.microsoft.com/office/drawing/2014/main" id="{D4210C51-698D-B115-CD92-15AA68E97334}"/>
               </a:ext>
             </a:extLst>
           </p:cNvPr>
@@ -11304,8 +9263,95 @@
         </p:nvSpPr>
         <p:spPr>
           <a:xfrm>
-            <a:off x="8412163" y="4978907"/>
-            <a:ext cx="3048000" cy="1200329"/>
+            <a:off x="5176927" y="245551"/>
+            <a:ext cx="7015073" cy="861774"/>
+          </a:xfrm>
+          <a:prstGeom prst="rect">
+            <a:avLst/>
+          </a:prstGeom>
+          <a:noFill/>
+        </p:spPr>
+        <p:txBody>
+          <a:bodyPr wrap="square" rtlCol="0">
+            <a:spAutoFit/>
+          </a:bodyPr>
+          <a:lstStyle/>
+          <a:p>
+            <a:pPr marL="285750" indent="-285750">
+              <a:buFont typeface="Arial" panose="020B0604020202020204" pitchFamily="34" charset="0"/>
+              <a:buChar char="●"/>
+            </a:pPr>
+            <a:r>
+              <a:rPr kumimoji="0" lang="en-US" sz="1800" b="1" i="0" u="none" strike="noStrike" kern="1200" cap="none" spc="0" normalizeH="0" baseline="0" noProof="0" dirty="0">
+                <a:ln>
+                  <a:noFill/>
+                </a:ln>
+                <a:solidFill>
+                  <a:prstClr val="black"/>
+                </a:solidFill>
+                <a:effectLst/>
+                <a:uLnTx/>
+                <a:uFillTx/>
+                <a:latin typeface="Arial"/>
+                <a:ea typeface="+mn-ea"/>
+                <a:cs typeface="+mn-cs"/>
+              </a:rPr>
+              <a:t>Ridge Regression</a:t>
+            </a:r>
+            <a:r>
+              <a:rPr kumimoji="0" lang="en-US" sz="1800" b="0" i="0" u="none" strike="noStrike" kern="1200" cap="none" spc="0" normalizeH="0" baseline="0" noProof="0" dirty="0">
+                <a:ln>
+                  <a:noFill/>
+                </a:ln>
+                <a:solidFill>
+                  <a:prstClr val="black"/>
+                </a:solidFill>
+                <a:effectLst/>
+                <a:uLnTx/>
+                <a:uFillTx/>
+                <a:latin typeface="Arial"/>
+                <a:ea typeface="+mn-ea"/>
+                <a:cs typeface="+mn-cs"/>
+              </a:rPr>
+              <a:t>: </a:t>
+            </a:r>
+            <a:r>
+              <a:rPr kumimoji="0" lang="en-US" sz="1600" b="0" i="0" u="none" strike="noStrike" kern="1200" cap="none" spc="0" normalizeH="0" baseline="0" noProof="0" dirty="0">
+                <a:ln>
+                  <a:noFill/>
+                </a:ln>
+                <a:solidFill>
+                  <a:prstClr val="black"/>
+                </a:solidFill>
+                <a:effectLst/>
+                <a:uLnTx/>
+                <a:uFillTx/>
+                <a:latin typeface="Arial"/>
+                <a:ea typeface="+mn-ea"/>
+                <a:cs typeface="+mn-cs"/>
+              </a:rPr>
+              <a:t>The simple linear ridge model cannot handle customers who spent a lot in 2021 but stopped completely in 2023. It hallucinates high revenue for dead accounts</a:t>
+            </a:r>
+            <a:endParaRPr lang="en-US" dirty="0"/>
+          </a:p>
+        </p:txBody>
+      </p:sp>
+      <p:sp>
+        <p:nvSpPr>
+          <p:cNvPr id="20" name="TextBox 19">
+            <a:extLst>
+              <a:ext uri="{FF2B5EF4-FFF2-40B4-BE49-F238E27FC236}">
+                <a16:creationId xmlns:a16="http://schemas.microsoft.com/office/drawing/2014/main" id="{2290EA73-A785-385C-9D8A-9627A70360A8}"/>
+              </a:ext>
+            </a:extLst>
+          </p:cNvPr>
+          <p:cNvSpPr txBox="1"/>
+          <p:nvPr/>
+        </p:nvSpPr>
+        <p:spPr>
+          <a:xfrm>
+            <a:off x="5176928" y="1223462"/>
+            <a:ext cx="4318764" cy="2677656"/>
           </a:xfrm>
           <a:prstGeom prst="rect">
             <a:avLst/>
@@ -11324,76 +9370,409 @@
           <a:lstStyle/>
           <a:p>
             <a:r>
-              <a:rPr lang="en-US" b="1" i="0" dirty="0">
+              <a:rPr lang="en-US" sz="1200" b="1" i="0" dirty="0">
                 <a:effectLst/>
                 <a:latin typeface="Consolas" panose="020B0609020204030204" pitchFamily="49" charset="0"/>
               </a:rPr>
-              <a:t>Feature     Importance</a:t>
-            </a:r>
-            <a:br>
-              <a:rPr lang="en-US" b="0" i="0" dirty="0">
+              <a:t>--- LATENT ATTRITION EXAMPLES --- </a:t>
+            </a:r>
+          </a:p>
+          <a:p>
+            <a:r>
+              <a:rPr lang="en-US" sz="1200" b="0" i="0" u="sng" dirty="0">
                 <a:effectLst/>
                 <a:latin typeface="Consolas" panose="020B0609020204030204" pitchFamily="49" charset="0"/>
               </a:rPr>
-            </a:br>
-            <a:r>
-              <a:rPr lang="en-US" dirty="0">
+              <a:t>Customer ID: 3</a:t>
+            </a:r>
+            <a:r>
+              <a:rPr lang="en-US" sz="1200" b="0" i="0" dirty="0">
+                <a:effectLst/>
+                <a:latin typeface="Consolas" panose="020B0609020204030204" pitchFamily="49" charset="0"/>
+              </a:rPr>
+              <a:t> </a:t>
+            </a:r>
+          </a:p>
+          <a:p>
+            <a:r>
+              <a:rPr lang="en-US" sz="1200" b="0" i="0" dirty="0">
+                <a:effectLst/>
+                <a:latin typeface="Consolas" panose="020B0609020204030204" pitchFamily="49" charset="0"/>
+              </a:rPr>
+              <a:t>  - Recency: 245 days </a:t>
+            </a:r>
+          </a:p>
+          <a:p>
+            <a:r>
+              <a:rPr lang="en-US" sz="1200" b="0" i="0" dirty="0">
+                <a:effectLst/>
+                <a:latin typeface="Consolas" panose="020B0609020204030204" pitchFamily="49" charset="0"/>
+              </a:rPr>
+              <a:t>  - Frequency: 33 rentals </a:t>
+            </a:r>
+          </a:p>
+          <a:p>
+            <a:r>
+              <a:rPr lang="en-US" sz="1200" dirty="0">
+                <a:latin typeface="Consolas" panose="020B0609020204030204" pitchFamily="49" charset="0"/>
+              </a:rPr>
+              <a:t>  </a:t>
+            </a:r>
+            <a:r>
+              <a:rPr lang="en-US" sz="1200" b="0" i="0" dirty="0">
+                <a:effectLst/>
+                <a:latin typeface="Consolas" panose="020B0609020204030204" pitchFamily="49" charset="0"/>
+              </a:rPr>
+              <a:t>- Monetary: 55,451.33 NOK </a:t>
+            </a:r>
+          </a:p>
+          <a:p>
+            <a:r>
+              <a:rPr lang="en-US" sz="1200" dirty="0">
+                <a:latin typeface="Consolas" panose="020B0609020204030204" pitchFamily="49" charset="0"/>
+              </a:rPr>
+              <a:t>  </a:t>
+            </a:r>
+            <a:r>
+              <a:rPr lang="en-US" sz="1200" b="0" i="0" dirty="0">
+                <a:effectLst/>
+                <a:latin typeface="Consolas" panose="020B0609020204030204" pitchFamily="49" charset="0"/>
+              </a:rPr>
+              <a:t>=&gt; </a:t>
+            </a:r>
+            <a:r>
+              <a:rPr lang="en-US" sz="1200" b="0" i="0" dirty="0">
+                <a:solidFill>
+                  <a:srgbClr val="1D9E75"/>
+                </a:solidFill>
+                <a:effectLst/>
+                <a:latin typeface="Consolas" panose="020B0609020204030204" pitchFamily="49" charset="0"/>
+              </a:rPr>
+              <a:t>ACTUAL</a:t>
+            </a:r>
+            <a:r>
+              <a:rPr lang="en-US" sz="1200" b="0" i="0" dirty="0">
+                <a:effectLst/>
+                <a:latin typeface="Consolas" panose="020B0609020204030204" pitchFamily="49" charset="0"/>
+              </a:rPr>
+              <a:t> Future Revenue (Target): 0.00 NOK</a:t>
+            </a:r>
+          </a:p>
+          <a:p>
+            <a:r>
+              <a:rPr lang="en-US" sz="1200" dirty="0">
+                <a:latin typeface="Consolas" panose="020B0609020204030204" pitchFamily="49" charset="0"/>
+              </a:rPr>
+              <a:t>  </a:t>
+            </a:r>
+            <a:r>
+              <a:rPr lang="en-US" sz="1200" b="0" i="0" dirty="0">
+                <a:effectLst/>
+                <a:latin typeface="Consolas" panose="020B0609020204030204" pitchFamily="49" charset="0"/>
+              </a:rPr>
+              <a:t>=&gt; </a:t>
+            </a:r>
+            <a:r>
+              <a:rPr lang="en-US" sz="1200" b="0" i="0" dirty="0">
+                <a:solidFill>
+                  <a:srgbClr val="C00000"/>
+                </a:solidFill>
+                <a:effectLst/>
+                <a:latin typeface="Consolas" panose="020B0609020204030204" pitchFamily="49" charset="0"/>
+              </a:rPr>
+              <a:t>RIDGE</a:t>
+            </a:r>
+            <a:r>
+              <a:rPr lang="en-US" sz="1200" b="0" i="0" dirty="0">
+                <a:effectLst/>
+                <a:latin typeface="Consolas" panose="020B0609020204030204" pitchFamily="49" charset="0"/>
+              </a:rPr>
+              <a:t> Predicted Revenue: 24,355.41 NOK </a:t>
+            </a:r>
+          </a:p>
+          <a:p>
+            <a:endParaRPr lang="en-US" sz="1200" dirty="0">
+              <a:latin typeface="Consolas" panose="020B0609020204030204" pitchFamily="49" charset="0"/>
+            </a:endParaRPr>
+          </a:p>
+          <a:p>
+            <a:r>
+              <a:rPr lang="en-US" sz="1200" b="0" i="0" u="sng" dirty="0">
+                <a:effectLst/>
+                <a:latin typeface="Consolas" panose="020B0609020204030204" pitchFamily="49" charset="0"/>
+              </a:rPr>
+              <a:t>Customer ID: 9</a:t>
+            </a:r>
+            <a:r>
+              <a:rPr lang="en-US" sz="1200" b="0" i="0" dirty="0">
+                <a:effectLst/>
+                <a:latin typeface="Consolas" panose="020B0609020204030204" pitchFamily="49" charset="0"/>
+              </a:rPr>
+              <a:t> </a:t>
+            </a:r>
+          </a:p>
+          <a:p>
+            <a:r>
+              <a:rPr lang="en-US" sz="1200" dirty="0">
+                <a:latin typeface="Consolas" panose="020B0609020204030204" pitchFamily="49" charset="0"/>
+              </a:rPr>
+              <a:t>  </a:t>
+            </a:r>
+            <a:r>
+              <a:rPr lang="en-US" sz="1200" b="0" i="0" dirty="0">
+                <a:effectLst/>
+                <a:latin typeface="Consolas" panose="020B0609020204030204" pitchFamily="49" charset="0"/>
+              </a:rPr>
+              <a:t>- Recency: 3 days </a:t>
+            </a:r>
+          </a:p>
+          <a:p>
+            <a:r>
+              <a:rPr lang="en-US" sz="1200" dirty="0">
+                <a:latin typeface="Consolas" panose="020B0609020204030204" pitchFamily="49" charset="0"/>
+              </a:rPr>
+              <a:t>  </a:t>
+            </a:r>
+            <a:r>
+              <a:rPr lang="en-US" sz="1200" b="0" i="0" dirty="0">
+                <a:effectLst/>
+                <a:latin typeface="Consolas" panose="020B0609020204030204" pitchFamily="49" charset="0"/>
+              </a:rPr>
+              <a:t>- Frequency: 3 rentals </a:t>
+            </a:r>
+          </a:p>
+          <a:p>
+            <a:r>
+              <a:rPr lang="en-US" sz="1200" dirty="0">
+                <a:latin typeface="Consolas" panose="020B0609020204030204" pitchFamily="49" charset="0"/>
+              </a:rPr>
+              <a:t>  </a:t>
+            </a:r>
+            <a:r>
+              <a:rPr lang="en-US" sz="1200" b="0" i="0" dirty="0">
+                <a:effectLst/>
+                <a:latin typeface="Consolas" panose="020B0609020204030204" pitchFamily="49" charset="0"/>
+              </a:rPr>
+              <a:t>- Monetary: 3,402.67 NOK </a:t>
+            </a:r>
+          </a:p>
+          <a:p>
+            <a:r>
+              <a:rPr lang="en-US" sz="1200" dirty="0">
+                <a:latin typeface="Consolas" panose="020B0609020204030204" pitchFamily="49" charset="0"/>
+              </a:rPr>
+              <a:t>  </a:t>
+            </a:r>
+            <a:r>
+              <a:rPr lang="en-US" sz="1200" b="0" i="0" dirty="0">
+                <a:effectLst/>
+                <a:latin typeface="Consolas" panose="020B0609020204030204" pitchFamily="49" charset="0"/>
+              </a:rPr>
+              <a:t>=&gt; </a:t>
+            </a:r>
+            <a:r>
+              <a:rPr lang="en-US" sz="1200" b="0" i="0" dirty="0">
+                <a:solidFill>
+                  <a:srgbClr val="1D9E75"/>
+                </a:solidFill>
+                <a:effectLst/>
+                <a:latin typeface="Consolas" panose="020B0609020204030204" pitchFamily="49" charset="0"/>
+              </a:rPr>
+              <a:t>ACTUAL</a:t>
+            </a:r>
+            <a:r>
+              <a:rPr lang="en-US" sz="1200" b="0" i="0" dirty="0">
+                <a:effectLst/>
+                <a:latin typeface="Consolas" panose="020B0609020204030204" pitchFamily="49" charset="0"/>
+              </a:rPr>
+              <a:t> Future Revenue (Target): 6,700.00 NOK </a:t>
+            </a:r>
+          </a:p>
+          <a:p>
+            <a:r>
+              <a:rPr lang="en-US" sz="1200" dirty="0">
+                <a:latin typeface="Consolas" panose="020B0609020204030204" pitchFamily="49" charset="0"/>
+              </a:rPr>
+              <a:t>  </a:t>
+            </a:r>
+            <a:r>
+              <a:rPr lang="en-US" sz="1200" b="0" i="0" dirty="0">
+                <a:effectLst/>
+                <a:latin typeface="Consolas" panose="020B0609020204030204" pitchFamily="49" charset="0"/>
+              </a:rPr>
+              <a:t>=&gt; </a:t>
+            </a:r>
+            <a:r>
+              <a:rPr lang="en-US" sz="1200" b="0" i="0" dirty="0">
+                <a:solidFill>
+                  <a:srgbClr val="C00000"/>
+                </a:solidFill>
+                <a:effectLst/>
+                <a:latin typeface="Consolas" panose="020B0609020204030204" pitchFamily="49" charset="0"/>
+              </a:rPr>
+              <a:t>RIDGE</a:t>
+            </a:r>
+            <a:r>
+              <a:rPr lang="en-US" sz="1200" b="0" i="0" dirty="0">
+                <a:effectLst/>
+                <a:latin typeface="Consolas" panose="020B0609020204030204" pitchFamily="49" charset="0"/>
+              </a:rPr>
+              <a:t> Predicted Revenue: 14,653.23 NOK</a:t>
+            </a:r>
+            <a:endParaRPr lang="en-US" sz="1200" dirty="0"/>
+          </a:p>
+        </p:txBody>
+      </p:sp>
+      <p:sp>
+        <p:nvSpPr>
+          <p:cNvPr id="21" name="TextBox 20">
+            <a:extLst>
+              <a:ext uri="{FF2B5EF4-FFF2-40B4-BE49-F238E27FC236}">
+                <a16:creationId xmlns:a16="http://schemas.microsoft.com/office/drawing/2014/main" id="{C3766DCB-B959-67E8-F5B9-DF360F58D8BF}"/>
+              </a:ext>
+            </a:extLst>
+          </p:cNvPr>
+          <p:cNvSpPr txBox="1"/>
+          <p:nvPr/>
+        </p:nvSpPr>
+        <p:spPr>
+          <a:xfrm>
+            <a:off x="9574505" y="1223462"/>
+            <a:ext cx="2537109" cy="954107"/>
+          </a:xfrm>
+          <a:prstGeom prst="rect">
+            <a:avLst/>
+          </a:prstGeom>
+          <a:noFill/>
+          <a:ln>
+            <a:solidFill>
+              <a:schemeClr val="tx1"/>
+            </a:solidFill>
+          </a:ln>
+        </p:spPr>
+        <p:txBody>
+          <a:bodyPr wrap="square">
+            <a:spAutoFit/>
+          </a:bodyPr>
+          <a:lstStyle/>
+          <a:p>
+            <a:r>
+              <a:rPr lang="en-US" sz="1400" b="1" i="0" dirty="0">
+                <a:effectLst/>
+                <a:latin typeface="Consolas" panose="020B0609020204030204" pitchFamily="49" charset="0"/>
+              </a:rPr>
+              <a:t>Feature </a:t>
+            </a:r>
+            <a:r>
+              <a:rPr lang="en-US" sz="1400" b="1" dirty="0">
+                <a:latin typeface="Consolas" panose="020B0609020204030204" pitchFamily="49" charset="0"/>
+              </a:rPr>
+              <a:t>     </a:t>
+            </a:r>
+            <a:r>
+              <a:rPr lang="en-US" sz="1400" b="1" i="0" dirty="0">
+                <a:effectLst/>
+                <a:latin typeface="Consolas" panose="020B0609020204030204" pitchFamily="49" charset="0"/>
+              </a:rPr>
+              <a:t>Importance</a:t>
+            </a:r>
+            <a:endParaRPr lang="en-US" sz="1400" b="0" i="0" dirty="0">
+              <a:effectLst/>
+              <a:latin typeface="Consolas" panose="020B0609020204030204" pitchFamily="49" charset="0"/>
+            </a:endParaRPr>
+          </a:p>
+          <a:p>
+            <a:r>
+              <a:rPr lang="en-US" sz="1400" dirty="0">
+                <a:latin typeface="Consolas" panose="020B0609020204030204" pitchFamily="49" charset="0"/>
+              </a:rPr>
+              <a:t>R</a:t>
+            </a:r>
+            <a:r>
+              <a:rPr lang="en-US" sz="1400" b="0" i="0" dirty="0">
+                <a:effectLst/>
+                <a:latin typeface="Consolas" panose="020B0609020204030204" pitchFamily="49" charset="0"/>
+              </a:rPr>
+              <a:t>ecency 	     </a:t>
+            </a:r>
+            <a:r>
+              <a:rPr lang="en-US" sz="1100" b="0" i="0" dirty="0">
+                <a:effectLst/>
+                <a:latin typeface="Consolas" panose="020B0609020204030204" pitchFamily="49" charset="0"/>
+              </a:rPr>
+              <a:t> </a:t>
+            </a:r>
+            <a:r>
+              <a:rPr lang="en-US" sz="1400" b="0" i="0" dirty="0">
+                <a:solidFill>
+                  <a:srgbClr val="C00000"/>
+                </a:solidFill>
+                <a:effectLst/>
+                <a:latin typeface="Consolas" panose="020B0609020204030204" pitchFamily="49" charset="0"/>
+              </a:rPr>
+              <a:t>-7793</a:t>
+            </a:r>
+          </a:p>
+          <a:p>
+            <a:r>
+              <a:rPr lang="en-US" sz="1400" dirty="0">
+                <a:latin typeface="Consolas" panose="020B0609020204030204" pitchFamily="49" charset="0"/>
+              </a:rPr>
+              <a:t>F</a:t>
+            </a:r>
+            <a:r>
+              <a:rPr lang="en-US" sz="1400" b="0" i="0" dirty="0">
+                <a:effectLst/>
+                <a:latin typeface="Consolas" panose="020B0609020204030204" pitchFamily="49" charset="0"/>
+              </a:rPr>
+              <a:t>requency      </a:t>
+            </a:r>
+            <a:r>
+              <a:rPr lang="en-US" sz="1400" b="0" i="0" dirty="0">
+                <a:solidFill>
+                  <a:srgbClr val="C00000"/>
+                </a:solidFill>
+                <a:effectLst/>
+                <a:latin typeface="Consolas" panose="020B0609020204030204" pitchFamily="49" charset="0"/>
+              </a:rPr>
+              <a:t>-9150</a:t>
+            </a:r>
+          </a:p>
+          <a:p>
+            <a:r>
+              <a:rPr lang="en-US" sz="1400" dirty="0">
                 <a:latin typeface="Consolas" panose="020B0609020204030204" pitchFamily="49" charset="0"/>
               </a:rPr>
               <a:t>M</a:t>
             </a:r>
             <a:r>
-              <a:rPr lang="en-US" b="0" i="0" dirty="0">
+              <a:rPr lang="en-US" sz="1400" b="0" i="0" dirty="0">
                 <a:effectLst/>
                 <a:latin typeface="Consolas" panose="020B0609020204030204" pitchFamily="49" charset="0"/>
               </a:rPr>
-              <a:t>onetary 	 556 </a:t>
-            </a:r>
-            <a:br>
-              <a:rPr lang="en-US" b="0" i="0" dirty="0">
+              <a:t>onetary 	      </a:t>
+            </a:r>
+            <a:r>
+              <a:rPr lang="en-US" sz="1400" b="0" i="0" dirty="0">
+                <a:solidFill>
+                  <a:srgbClr val="1D9E75"/>
+                </a:solidFill>
                 <a:effectLst/>
                 <a:latin typeface="Consolas" panose="020B0609020204030204" pitchFamily="49" charset="0"/>
               </a:rPr>
-            </a:br>
-            <a:r>
-              <a:rPr lang="en-US" dirty="0">
-                <a:latin typeface="Consolas" panose="020B0609020204030204" pitchFamily="49" charset="0"/>
-              </a:rPr>
-              <a:t>R</a:t>
-            </a:r>
-            <a:r>
-              <a:rPr lang="en-US" b="0" i="0" dirty="0">
-                <a:effectLst/>
-                <a:latin typeface="Consolas" panose="020B0609020204030204" pitchFamily="49" charset="0"/>
-              </a:rPr>
-              <a:t>ecency 	 451 </a:t>
-            </a:r>
-            <a:br>
-              <a:rPr lang="en-US" b="0" i="0" dirty="0">
-                <a:effectLst/>
-                <a:latin typeface="Consolas" panose="020B0609020204030204" pitchFamily="49" charset="0"/>
-              </a:rPr>
-            </a:br>
-            <a:r>
-              <a:rPr lang="en-US" dirty="0">
-                <a:latin typeface="Consolas" panose="020B0609020204030204" pitchFamily="49" charset="0"/>
-              </a:rPr>
-              <a:t>F</a:t>
-            </a:r>
-            <a:r>
-              <a:rPr lang="en-US" b="0" i="0" dirty="0">
-                <a:effectLst/>
-                <a:latin typeface="Consolas" panose="020B0609020204030204" pitchFamily="49" charset="0"/>
-              </a:rPr>
-              <a:t>requency 	 337</a:t>
-            </a:r>
-            <a:endParaRPr lang="en-US" dirty="0"/>
-          </a:p>
-        </p:txBody>
-      </p:sp>
-      <p:sp>
-        <p:nvSpPr>
-          <p:cNvPr id="2" name="TextBox 1">
+              <a:t>21982</a:t>
+            </a:r>
+            <a:endParaRPr lang="en-US" sz="1400" dirty="0">
+              <a:solidFill>
+                <a:srgbClr val="1D9E75"/>
+              </a:solidFill>
+            </a:endParaRPr>
+          </a:p>
+        </p:txBody>
+      </p:sp>
+      <p:sp>
+        <p:nvSpPr>
+          <p:cNvPr id="22" name="TextBox 21">
             <a:extLst>
               <a:ext uri="{FF2B5EF4-FFF2-40B4-BE49-F238E27FC236}">
                 <a16:creationId xmlns:a16="http://schemas.microsoft.com/office/drawing/2014/main" id="{648C2B7F-B398-AA94-D3A9-0E8FAD03B87D}"/>
@@ -11405,7 +9784,7 @@
         </p:nvSpPr>
         <p:spPr>
           <a:xfrm>
-            <a:off x="7433020" y="3429000"/>
+            <a:off x="10909555" y="2197553"/>
             <a:ext cx="986167" cy="276999"/>
           </a:xfrm>
           <a:prstGeom prst="rect">
@@ -11429,10 +9808,10 @@
       </p:sp>
       <p:sp>
         <p:nvSpPr>
-          <p:cNvPr id="7" name="TextBox 6">
-            <a:extLst>
-              <a:ext uri="{FF2B5EF4-FFF2-40B4-BE49-F238E27FC236}">
-                <a16:creationId xmlns:a16="http://schemas.microsoft.com/office/drawing/2014/main" id="{46ED149C-09C2-3EEC-58DC-B9A96AE142B0}"/>
+          <p:cNvPr id="23" name="TextBox 22">
+            <a:extLst>
+              <a:ext uri="{FF2B5EF4-FFF2-40B4-BE49-F238E27FC236}">
+                <a16:creationId xmlns:a16="http://schemas.microsoft.com/office/drawing/2014/main" id="{E2BDEDB8-5A09-889B-1E17-255AA7019E77}"/>
               </a:ext>
             </a:extLst>
           </p:cNvPr>
@@ -11441,8 +9820,8 @@
         </p:nvSpPr>
         <p:spPr>
           <a:xfrm>
-            <a:off x="7861287" y="5528014"/>
-            <a:ext cx="559769" cy="276999"/>
+            <a:off x="5176927" y="4073248"/>
+            <a:ext cx="7015073" cy="892552"/>
           </a:xfrm>
           <a:prstGeom prst="rect">
             <a:avLst/>
@@ -11450,115 +9829,82 @@
           <a:noFill/>
         </p:spPr>
         <p:txBody>
-          <a:bodyPr wrap="none" rtlCol="0">
+          <a:bodyPr wrap="square" rtlCol="0">
             <a:spAutoFit/>
           </a:bodyPr>
           <a:lstStyle/>
           <a:p>
-            <a:r>
-              <a:rPr lang="it-IT" sz="1200" i="1" dirty="0" err="1"/>
-              <a:t>Splits</a:t>
-            </a:r>
-            <a:endParaRPr lang="en-US" i="1" dirty="0"/>
-          </a:p>
-        </p:txBody>
-      </p:sp>
-      <p:pic>
-        <p:nvPicPr>
-          <p:cNvPr id="9" name="Picture 8">
-            <a:extLst>
-              <a:ext uri="{FF2B5EF4-FFF2-40B4-BE49-F238E27FC236}">
-                <a16:creationId xmlns:a16="http://schemas.microsoft.com/office/drawing/2014/main" id="{A453F874-DA3C-A95A-8086-2DD689F91041}"/>
-              </a:ext>
-            </a:extLst>
-          </p:cNvPr>
-          <p:cNvPicPr>
-            <a:picLocks noChangeAspect="1"/>
-          </p:cNvPicPr>
+            <a:pPr marL="283464" indent="-283464" algn="l" rtl="0" eaLnBrk="1" latinLnBrk="0" hangingPunct="1">
+              <a:buClrTx/>
+              <a:buSzPts val="1800"/>
+              <a:buFont typeface="Arial" panose="020B0604020202020204" pitchFamily="34" charset="0"/>
+              <a:buChar char="●"/>
+            </a:pPr>
+            <a:r>
+              <a:rPr lang="en-US" sz="2000" b="1" kern="1200" dirty="0" err="1">
+                <a:solidFill>
+                  <a:srgbClr val="000000"/>
+                </a:solidFill>
+                <a:effectLst/>
+                <a:latin typeface="Arial" panose="020B0604020202020204" pitchFamily="34" charset="0"/>
+                <a:ea typeface="+mn-ea"/>
+                <a:cs typeface="+mn-cs"/>
+              </a:rPr>
+              <a:t>LightGBM</a:t>
+            </a:r>
+            <a:r>
+              <a:rPr lang="en-US" sz="2000" kern="1200" dirty="0">
+                <a:solidFill>
+                  <a:srgbClr val="000000"/>
+                </a:solidFill>
+                <a:effectLst/>
+                <a:latin typeface="Arial" panose="020B0604020202020204" pitchFamily="34" charset="0"/>
+                <a:ea typeface="+mn-ea"/>
+                <a:cs typeface="+mn-cs"/>
+              </a:rPr>
+              <a:t>: </a:t>
+            </a:r>
+            <a:r>
+              <a:rPr lang="en-US" sz="1600" kern="1200" dirty="0">
+                <a:solidFill>
+                  <a:srgbClr val="000000"/>
+                </a:solidFill>
+                <a:effectLst/>
+                <a:latin typeface="Arial" panose="020B0604020202020204" pitchFamily="34" charset="0"/>
+                <a:ea typeface="+mn-ea"/>
+                <a:cs typeface="+mn-cs"/>
+              </a:rPr>
+              <a:t>We implement a tree-based model that can implicitly learn to ignore these churned customers. Upgrading to a tree-based model cuts the MAE by ~30%:</a:t>
+            </a:r>
+            <a:endParaRPr lang="en-US" sz="2000" dirty="0">
+              <a:effectLst/>
+            </a:endParaRPr>
+          </a:p>
+        </p:txBody>
+      </p:sp>
+      <p:sp>
+        <p:nvSpPr>
+          <p:cNvPr id="26" name="TextBox 25">
+            <a:extLst>
+              <a:ext uri="{FF2B5EF4-FFF2-40B4-BE49-F238E27FC236}">
+                <a16:creationId xmlns:a16="http://schemas.microsoft.com/office/drawing/2014/main" id="{33BFBCD7-0E3E-61C5-3D61-850507BAC495}"/>
+              </a:ext>
+            </a:extLst>
+          </p:cNvPr>
+          <p:cNvSpPr txBox="1"/>
           <p:nvPr/>
-        </p:nvPicPr>
-        <p:blipFill>
-          <a:blip r:embed="rId3"/>
-          <a:stretch>
-            <a:fillRect/>
-          </a:stretch>
-        </p:blipFill>
+        </p:nvSpPr>
         <p:spPr>
           <a:xfrm>
-            <a:off x="25346" y="2543084"/>
-            <a:ext cx="6366660" cy="3791671"/>
+            <a:off x="181231" y="5317243"/>
+            <a:ext cx="9177374" cy="1077218"/>
           </a:xfrm>
           <a:prstGeom prst="rect">
             <a:avLst/>
           </a:prstGeom>
-        </p:spPr>
-      </p:pic>
-      <p:sp>
-        <p:nvSpPr>
-          <p:cNvPr id="10" name="TextBox 9">
-            <a:extLst>
-              <a:ext uri="{FF2B5EF4-FFF2-40B4-BE49-F238E27FC236}">
-                <a16:creationId xmlns:a16="http://schemas.microsoft.com/office/drawing/2014/main" id="{10C8069D-901F-4AE7-3D95-774CDEF163D4}"/>
-              </a:ext>
-            </a:extLst>
-          </p:cNvPr>
-          <p:cNvSpPr txBox="1"/>
-          <p:nvPr/>
-        </p:nvSpPr>
-        <p:spPr>
-          <a:xfrm>
-            <a:off x="2019127" y="3747950"/>
-            <a:ext cx="765447" cy="357262"/>
-          </a:xfrm>
-          <a:prstGeom prst="rect">
-            <a:avLst/>
-          </a:prstGeom>
-          <a:noFill/>
-        </p:spPr>
-        <p:txBody>
-          <a:bodyPr wrap="none" rtlCol="0">
-            <a:spAutoFit/>
-          </a:bodyPr>
-          <a:lstStyle/>
-          <a:p>
-            <a:pPr algn="l"/>
-            <a:r>
-              <a:rPr lang="en-US" sz="1600" b="1" spc="0" baseline="0" dirty="0">
-                <a:ln/>
-                <a:solidFill>
-                  <a:srgbClr val="1D9E75"/>
-                </a:solidFill>
-                <a:latin typeface="Segoe UI"/>
-                <a:cs typeface="Segoe UI"/>
-                <a:sym typeface="Segoe UI"/>
-                <a:rtl val="0"/>
-              </a:rPr>
-              <a:t>−31%</a:t>
-            </a:r>
-          </a:p>
-        </p:txBody>
-      </p:sp>
-      <p:sp>
-        <p:nvSpPr>
-          <p:cNvPr id="11" name="TextBox 10">
-            <a:extLst>
-              <a:ext uri="{FF2B5EF4-FFF2-40B4-BE49-F238E27FC236}">
-                <a16:creationId xmlns:a16="http://schemas.microsoft.com/office/drawing/2014/main" id="{36A3BF1A-5886-13F6-26C7-7930C87A764C}"/>
-              </a:ext>
-            </a:extLst>
-          </p:cNvPr>
-          <p:cNvSpPr txBox="1"/>
-          <p:nvPr/>
-        </p:nvSpPr>
-        <p:spPr>
-          <a:xfrm>
-            <a:off x="4301072" y="4802166"/>
-            <a:ext cx="669050" cy="357262"/>
-          </a:xfrm>
-          <a:prstGeom prst="rect">
-            <a:avLst/>
-          </a:prstGeom>
-          <a:noFill/>
+          <a:solidFill>
+            <a:srgbClr val="000066"/>
+          </a:solidFill>
         </p:spPr>
         <p:txBody>
           <a:bodyPr wrap="square" rtlCol="0">
@@ -11566,134 +9912,33 @@
           </a:bodyPr>
           <a:lstStyle/>
           <a:p>
-            <a:pPr algn="l"/>
-            <a:r>
-              <a:rPr lang="it-IT" sz="1600" b="1" dirty="0">
-                <a:ln/>
+            <a:r>
+              <a:rPr lang="en-US" sz="1600" b="1" dirty="0">
                 <a:solidFill>
-                  <a:srgbClr val="C00000"/>
+                  <a:schemeClr val="bg1"/>
                 </a:solidFill>
-                <a:latin typeface="Segoe UI"/>
-                <a:cs typeface="Segoe UI"/>
-                <a:sym typeface="Segoe UI"/>
-                <a:rtl val="0"/>
               </a:rPr>
-              <a:t>x</a:t>
+              <a:t>While this is a solid improvement, our conclusion is that pure RFM features are still not enough for a highly accurate prediction. Our next step for the final model is to enrich this </a:t>
+            </a:r>
+            <a:r>
+              <a:rPr lang="en-US" sz="1600" b="1" dirty="0" err="1">
+                <a:solidFill>
+                  <a:schemeClr val="bg1"/>
+                </a:solidFill>
+              </a:rPr>
+              <a:t>LightGBM</a:t>
             </a:r>
             <a:r>
               <a:rPr lang="en-US" sz="1600" b="1" dirty="0">
-                <a:ln/>
                 <a:solidFill>
-                  <a:srgbClr val="C00000"/>
+                  <a:schemeClr val="bg1"/>
                 </a:solidFill>
-                <a:latin typeface="Segoe UI"/>
-                <a:cs typeface="Segoe UI"/>
-                <a:sym typeface="Segoe UI"/>
-                <a:rtl val="0"/>
               </a:rPr>
-              <a:t>110</a:t>
-            </a:r>
-            <a:endParaRPr lang="en-US" sz="1600" b="1" spc="0" baseline="0" dirty="0">
-              <a:ln/>
-              <a:solidFill>
-                <a:srgbClr val="C00000"/>
-              </a:solidFill>
-              <a:latin typeface="Segoe UI"/>
-              <a:cs typeface="Segoe UI"/>
-              <a:sym typeface="Segoe UI"/>
-              <a:rtl val="0"/>
-            </a:endParaRPr>
-          </a:p>
-        </p:txBody>
-      </p:sp>
-      <p:cxnSp>
-        <p:nvCxnSpPr>
-          <p:cNvPr id="13" name="Straight Arrow Connector 12">
-            <a:extLst>
-              <a:ext uri="{FF2B5EF4-FFF2-40B4-BE49-F238E27FC236}">
-                <a16:creationId xmlns:a16="http://schemas.microsoft.com/office/drawing/2014/main" id="{9D124440-49AE-1463-88FD-CFF585FECD2D}"/>
-              </a:ext>
-            </a:extLst>
-          </p:cNvPr>
-          <p:cNvCxnSpPr>
-            <a:cxnSpLocks/>
-          </p:cNvCxnSpPr>
-          <p:nvPr/>
-        </p:nvCxnSpPr>
-        <p:spPr>
-          <a:xfrm>
-            <a:off x="1926507" y="3937499"/>
-            <a:ext cx="959860" cy="741854"/>
-          </a:xfrm>
-          <a:prstGeom prst="straightConnector1">
-            <a:avLst/>
-          </a:prstGeom>
-          <a:ln>
-            <a:solidFill>
-              <a:srgbClr val="1D9E75"/>
-            </a:solidFill>
-            <a:tailEnd type="triangle"/>
-          </a:ln>
-        </p:spPr>
-        <p:style>
-          <a:lnRef idx="1">
-            <a:schemeClr val="accent1"/>
-          </a:lnRef>
-          <a:fillRef idx="0">
-            <a:schemeClr val="accent1"/>
-          </a:fillRef>
-          <a:effectRef idx="0">
-            <a:schemeClr val="accent1"/>
-          </a:effectRef>
-          <a:fontRef idx="minor">
-            <a:schemeClr val="tx1"/>
-          </a:fontRef>
-        </p:style>
-      </p:cxnSp>
-      <p:cxnSp>
-        <p:nvCxnSpPr>
-          <p:cNvPr id="15" name="Straight Arrow Connector 14">
-            <a:extLst>
-              <a:ext uri="{FF2B5EF4-FFF2-40B4-BE49-F238E27FC236}">
-                <a16:creationId xmlns:a16="http://schemas.microsoft.com/office/drawing/2014/main" id="{FB683CE5-BA72-E214-811E-567923C39807}"/>
-              </a:ext>
-            </a:extLst>
-          </p:cNvPr>
-          <p:cNvCxnSpPr>
-            <a:cxnSpLocks/>
-          </p:cNvCxnSpPr>
-          <p:nvPr/>
-        </p:nvCxnSpPr>
-        <p:spPr>
-          <a:xfrm flipH="1" flipV="1">
-            <a:off x="4073267" y="5002723"/>
-            <a:ext cx="896855" cy="903539"/>
-          </a:xfrm>
-          <a:prstGeom prst="straightConnector1">
-            <a:avLst/>
-          </a:prstGeom>
-          <a:ln>
-            <a:solidFill>
-              <a:srgbClr val="C00000"/>
-            </a:solidFill>
-            <a:tailEnd type="triangle"/>
-          </a:ln>
-        </p:spPr>
-        <p:style>
-          <a:lnRef idx="1">
-            <a:schemeClr val="accent1"/>
-          </a:lnRef>
-          <a:fillRef idx="0">
-            <a:schemeClr val="accent1"/>
-          </a:fillRef>
-          <a:effectRef idx="0">
-            <a:schemeClr val="accent1"/>
-          </a:effectRef>
-          <a:fontRef idx="minor">
-            <a:schemeClr val="tx1"/>
-          </a:fontRef>
-        </p:style>
-      </p:cxnSp>
+              <a:t> with behavioral features (e.g., Style Entropy and Cluster Affinity) to precisely predict who is churning and close the error gap even further</a:t>
+            </a:r>
+          </a:p>
+        </p:txBody>
+      </p:sp>
     </p:spTree>
     <p:extLst>
       <p:ext uri="{BB962C8B-B14F-4D97-AF65-F5344CB8AC3E}">
@@ -11890,7 +10135,7 @@
             <p:nvPr/>
           </p:nvPicPr>
           <p:blipFill>
-            <a:blip r:embed="rId2"/>
+            <a:blip r:embed="rId3"/>
             <a:stretch>
               <a:fillRect/>
             </a:stretch>
@@ -11920,7 +10165,7 @@
             <p:nvPr/>
           </p:nvPicPr>
           <p:blipFill>
-            <a:blip r:embed="rId3"/>
+            <a:blip r:embed="rId4"/>
             <a:stretch>
               <a:fillRect/>
             </a:stretch>
@@ -11950,7 +10195,7 @@
             <p:nvPr/>
           </p:nvPicPr>
           <p:blipFill>
-            <a:blip r:embed="rId4"/>
+            <a:blip r:embed="rId5"/>
             <a:stretch>
               <a:fillRect/>
             </a:stretch>
@@ -11981,7 +10226,7 @@
           <p:nvPr/>
         </p:nvPicPr>
         <p:blipFill>
-          <a:blip r:embed="rId5"/>
+          <a:blip r:embed="rId6"/>
           <a:stretch>
             <a:fillRect/>
           </a:stretch>
@@ -12659,6 +10904,21 @@
 </file>
 
 <file path=customXml/item1.xml><?xml version="1.0" encoding="utf-8"?>
+<p:properties xmlns:p="http://schemas.microsoft.com/office/2006/metadata/properties" xmlns:xsi="http://www.w3.org/2001/XMLSchema-instance" xmlns:pc="http://schemas.microsoft.com/office/infopath/2007/PartnerControls">
+  <documentManagement/>
+</p:properties>
+</file>
+
+<file path=customXml/item2.xml><?xml version="1.0" encoding="utf-8"?>
+<?mso-contentType ?>
+<FormTemplates xmlns="http://schemas.microsoft.com/sharepoint/v3/contenttype/forms">
+  <Display>DocumentLibraryForm</Display>
+  <Edit>DocumentLibraryForm</Edit>
+  <New>DocumentLibraryForm</New>
+</FormTemplates>
+</file>
+
+<file path=customXml/item3.xml><?xml version="1.0" encoding="utf-8"?>
 <ct:contentTypeSchema xmlns:ct="http://schemas.microsoft.com/office/2006/metadata/contentType" xmlns:ma="http://schemas.microsoft.com/office/2006/metadata/properties/metaAttributes" ct:_="" ma:_="" ma:contentTypeName="Dokument" ma:contentTypeID="0x010100D0F59E03F3A02E49BD70E31348545014" ma:contentTypeVersion="7" ma:contentTypeDescription="Ein neues Dokument erstellen." ma:contentTypeScope="" ma:versionID="907cdc0f808be0b4bc1373a5a8f6a492">
   <xsd:schema xmlns:xsd="http://www.w3.org/2001/XMLSchema" xmlns:xs="http://www.w3.org/2001/XMLSchema" xmlns:p="http://schemas.microsoft.com/office/2006/metadata/properties" xmlns:ns2="7fd05bba-d45d-467f-a5a8-3f2970e80e4a" targetNamespace="http://schemas.microsoft.com/office/2006/metadata/properties" ma:root="true" ma:fieldsID="6eaf8534fcc486a778b01aa1a7a62fa4" ns2:_="">
     <xsd:import namespace="7fd05bba-d45d-467f-a5a8-3f2970e80e4a"/>
@@ -12820,22 +11080,31 @@
 </ct:contentTypeSchema>
 </file>
 
-<file path=customXml/item2.xml><?xml version="1.0" encoding="utf-8"?>
-<?mso-contentType ?>
-<FormTemplates xmlns="http://schemas.microsoft.com/sharepoint/v3/contenttype/forms">
-  <Display>DocumentLibraryForm</Display>
-  <Edit>DocumentLibraryForm</Edit>
-  <New>DocumentLibraryForm</New>
-</FormTemplates>
+<file path=customXml/itemProps1.xml><?xml version="1.0" encoding="utf-8"?>
+<ds:datastoreItem xmlns:ds="http://schemas.openxmlformats.org/officeDocument/2006/customXml" ds:itemID="{2C3B1C8D-BA84-44B8-B31F-BF26E7BAC85C}">
+  <ds:schemaRefs>
+    <ds:schemaRef ds:uri="http://purl.org/dc/elements/1.1/"/>
+    <ds:schemaRef ds:uri="http://www.w3.org/XML/1998/namespace"/>
+    <ds:schemaRef ds:uri="http://schemas.openxmlformats.org/package/2006/metadata/core-properties"/>
+    <ds:schemaRef ds:uri="http://schemas.microsoft.com/office/2006/documentManagement/types"/>
+    <ds:schemaRef ds:uri="http://purl.org/dc/terms/"/>
+    <ds:schemaRef ds:uri="http://schemas.microsoft.com/office/infopath/2007/PartnerControls"/>
+    <ds:schemaRef ds:uri="http://purl.org/dc/dcmitype/"/>
+    <ds:schemaRef ds:uri="7fd05bba-d45d-467f-a5a8-3f2970e80e4a"/>
+    <ds:schemaRef ds:uri="http://schemas.microsoft.com/office/2006/metadata/properties"/>
+  </ds:schemaRefs>
+</ds:datastoreItem>
 </file>
 
-<file path=customXml/item3.xml><?xml version="1.0" encoding="utf-8"?>
-<p:properties xmlns:p="http://schemas.microsoft.com/office/2006/metadata/properties" xmlns:xsi="http://www.w3.org/2001/XMLSchema-instance" xmlns:pc="http://schemas.microsoft.com/office/infopath/2007/PartnerControls">
-  <documentManagement/>
-</p:properties>
+<file path=customXml/itemProps2.xml><?xml version="1.0" encoding="utf-8"?>
+<ds:datastoreItem xmlns:ds="http://schemas.openxmlformats.org/officeDocument/2006/customXml" ds:itemID="{E0CFCB78-2973-46E2-963D-C72C98C43B41}">
+  <ds:schemaRefs>
+    <ds:schemaRef ds:uri="http://schemas.microsoft.com/sharepoint/v3/contenttype/forms"/>
+  </ds:schemaRefs>
+</ds:datastoreItem>
 </file>
 
-<file path=customXml/itemProps1.xml><?xml version="1.0" encoding="utf-8"?>
+<file path=customXml/itemProps3.xml><?xml version="1.0" encoding="utf-8"?>
 <ds:datastoreItem xmlns:ds="http://schemas.openxmlformats.org/officeDocument/2006/customXml" ds:itemID="{6B7B52BC-33EF-4C54-820C-9984D5F8AFB1}">
   <ds:schemaRefs>
     <ds:schemaRef ds:uri="7fd05bba-d45d-467f-a5a8-3f2970e80e4a"/>
@@ -12851,28 +11120,4 @@
     <ds:schemaRef ds:uri="http://www.w3.org/2001/XMLSchema"/>
   </ds:schemaRefs>
 </ds:datastoreItem>
-</file>
-
-<file path=customXml/itemProps2.xml><?xml version="1.0" encoding="utf-8"?>
-<ds:datastoreItem xmlns:ds="http://schemas.openxmlformats.org/officeDocument/2006/customXml" ds:itemID="{E0CFCB78-2973-46E2-963D-C72C98C43B41}">
-  <ds:schemaRefs>
-    <ds:schemaRef ds:uri="http://schemas.microsoft.com/sharepoint/v3/contenttype/forms"/>
-  </ds:schemaRefs>
-</ds:datastoreItem>
-</file>
-
-<file path=customXml/itemProps3.xml><?xml version="1.0" encoding="utf-8"?>
-<ds:datastoreItem xmlns:ds="http://schemas.openxmlformats.org/officeDocument/2006/customXml" ds:itemID="{2C3B1C8D-BA84-44B8-B31F-BF26E7BAC85C}">
-  <ds:schemaRefs>
-    <ds:schemaRef ds:uri="http://purl.org/dc/elements/1.1/"/>
-    <ds:schemaRef ds:uri="http://www.w3.org/XML/1998/namespace"/>
-    <ds:schemaRef ds:uri="http://schemas.openxmlformats.org/package/2006/metadata/core-properties"/>
-    <ds:schemaRef ds:uri="http://schemas.microsoft.com/office/2006/documentManagement/types"/>
-    <ds:schemaRef ds:uri="http://purl.org/dc/terms/"/>
-    <ds:schemaRef ds:uri="http://schemas.microsoft.com/office/infopath/2007/PartnerControls"/>
-    <ds:schemaRef ds:uri="http://purl.org/dc/dcmitype/"/>
-    <ds:schemaRef ds:uri="7fd05bba-d45d-467f-a5a8-3f2970e80e4a"/>
-    <ds:schemaRef ds:uri="http://schemas.microsoft.com/office/2006/metadata/properties"/>
-  </ds:schemaRefs>
-</ds:datastoreItem>
 </file>
</xml_diff>

<commit_message>
added RFM slide script on pptx
</commit_message>
<xml_diff>
--- a/Presentations/Assignment_2_MA.pptx
+++ b/Presentations/Assignment_2_MA.pptx
@@ -718,53 +718,68 @@
           <a:lstStyle/>
           <a:p>
             <a:r>
-              <a:rPr lang="en-US" b="1" dirty="0"/>
-              <a:t>(Wait for your colleague to finish explaining the temporal split, then take over).</a:t>
-            </a:r>
+              <a:rPr lang="en-US" dirty="0"/>
+              <a:t>[Transition - Take the floor from your colleague]</a:t>
+            </a:r>
+          </a:p>
+          <a:p>
+            <a:r>
+              <a:rPr lang="en-US" dirty="0"/>
+              <a:t>"Following up on the temporal split my colleague just explained, I'll walk you through our baseline models and a critical issue we discovered in the data: Latent Attrition."</a:t>
+            </a:r>
+          </a:p>
+          <a:p>
+            <a:br>
+              <a:rPr lang="en-US" dirty="0"/>
+            </a:br>
             <a:endParaRPr lang="en-US" dirty="0"/>
           </a:p>
           <a:p>
             <a:r>
               <a:rPr lang="en-US" dirty="0"/>
-              <a:t>"Following up on the temporal split my colleague just explained, I’ll walk you through our baseline models"</a:t>
-            </a:r>
-          </a:p>
-          <a:p>
-            <a:r>
-              <a:rPr lang="en-US" b="1" dirty="0"/>
-              <a:t>(Point to the Bar Chart on your slide)</a:t>
-            </a:r>
+              <a:t>[Point to the Bar Chart on the left]</a:t>
+            </a:r>
+          </a:p>
+          <a:p>
             <a:r>
               <a:rPr lang="en-US" dirty="0"/>
-              <a:t> "We started with a standard RFM approach—using Recency, Frequency, and Monetary value—and trained a simple Ridge Regression. As you can see, this resulted in a massive Mean Absolute Error of nearly 14,700 NOK."</a:t>
-            </a:r>
-          </a:p>
-          <a:p>
-            <a:r>
-              <a:rPr lang="en-US" b="1" dirty="0"/>
-              <a:t>(Point to the micro-table or simply emphasize the data)</a:t>
-            </a:r>
-            <a:r>
+              <a:t>"We started with a standard RFM approach using a simple Ridge Regression. As you can see on the chart, this resulted in a massive Mean Absolute Error of nearly 14,700 NOK."</a:t>
+            </a:r>
+          </a:p>
+          <a:p>
+            <a:br>
               <a:rPr lang="en-US" dirty="0"/>
-              <a:t> "The reason it failed is that linear models cannot handle customers who silently churn. For example, in our dataset, Customer Number 3 spent over 55,000 NOK historically, but hasn't rented anything in 245 days. Their actual future revenue is zero. But because the linear model heavily weights historical spend, it hallucinates high future revenue for these dead accounts.</a:t>
-            </a:r>
-          </a:p>
-          <a:p>
-            <a:r>
-              <a:rPr lang="en-US" b="1" dirty="0"/>
-              <a:t>(Gesture back to the </a:t>
-            </a:r>
-            <a:r>
-              <a:rPr lang="en-US" b="1" dirty="0" err="1"/>
-              <a:t>LightGBM</a:t>
-            </a:r>
-            <a:r>
-              <a:rPr lang="en-US" b="1" dirty="0"/>
-              <a:t> bar on the chart)</a:t>
-            </a:r>
+            </a:br>
+            <a:endParaRPr lang="en-US" dirty="0"/>
+          </a:p>
+          <a:p>
             <a:r>
               <a:rPr lang="en-US" dirty="0"/>
-              <a:t> "To fix this, we upgraded our baseline to a tree-based model: </a:t>
+              <a:t>[Point to the Table on the top right]</a:t>
+            </a:r>
+          </a:p>
+          <a:p>
+            <a:r>
+              <a:rPr lang="en-US" dirty="0"/>
+              <a:t>"To understand why it failed, look at the actual data in the table. Customer number 3 is a 'churned whale'. They spent over 55,000 NOK historically, but haven't rented anything in 245 days. Their actual future revenue is zero.</a:t>
+            </a:r>
+          </a:p>
+          <a:p>
+            <a:r>
+              <a:rPr lang="en-US" dirty="0"/>
+              <a:t>But because a linear model heavily weights historical spend, it doesn't understand this latent attrition. It hallucinates over 24,000 NOK in future revenue for a completely dead account."</a:t>
+            </a:r>
+          </a:p>
+          <a:p>
+            <a:br>
+              <a:rPr lang="en-US" dirty="0"/>
+            </a:br>
+            <a:endParaRPr lang="en-US" dirty="0"/>
+          </a:p>
+          <a:p>
+            <a:r>
+              <a:rPr lang="en-US" dirty="0"/>
+              <a:t>[Point back to the </a:t>
             </a:r>
             <a:r>
               <a:rPr lang="en-US" dirty="0" err="1"/>
@@ -772,17 +787,13 @@
             </a:r>
             <a:r>
               <a:rPr lang="en-US" dirty="0"/>
-              <a:t>. Because it can learn non-linear rules, it implicitly learned that once 'Recency' crosses a certain threshold of inactivity, the predicted revenue must drop to zero. This cut our error by 30%, down to roughly 10,150 NOK."</a:t>
-            </a:r>
-          </a:p>
-          <a:p>
-            <a:r>
-              <a:rPr lang="en-US" b="1" dirty="0"/>
-              <a:t>(Deliver the final punchline / Next Steps)</a:t>
-            </a:r>
+              <a:t> Bar on the chart]</a:t>
+            </a:r>
+          </a:p>
+          <a:p>
             <a:r>
               <a:rPr lang="en-US" dirty="0"/>
-              <a:t> "While this is a solid improvement, our conclusion is that pure RFM features are still not enough for a highly accurate prediction. Our next step for the final model is to enrich this </a:t>
+              <a:t>"To fix this, we upgraded to a tree-based model: </a:t>
             </a:r>
             <a:r>
               <a:rPr lang="en-US" dirty="0" err="1"/>
@@ -790,35 +801,40 @@
             </a:r>
             <a:r>
               <a:rPr lang="en-US" dirty="0"/>
-              <a:t> with the behavioral features we engineered earlier—like </a:t>
-            </a:r>
-            <a:r>
-              <a:rPr lang="en-US" i="1" dirty="0"/>
-              <a:t>Style Entropy</a:t>
+              <a:t>. Because trees can learn non-linear rules, </a:t>
+            </a:r>
+            <a:r>
+              <a:rPr lang="en-US" dirty="0" err="1"/>
+              <a:t>LightGBM</a:t>
             </a:r>
             <a:r>
               <a:rPr lang="en-US" dirty="0"/>
-              <a:t> and </a:t>
-            </a:r>
-            <a:r>
-              <a:rPr lang="en-US" i="1" dirty="0"/>
-              <a:t>Cluster Affinity</a:t>
-            </a:r>
-            <a:r>
+              <a:t> implicitly learned that once 'Recency' crosses a certain threshold, the predicted revenue must drop to zero. This cut our error by 30%."</a:t>
+            </a:r>
+          </a:p>
+          <a:p>
+            <a:br>
               <a:rPr lang="en-US" dirty="0"/>
-              <a:t>—to precisely predict </a:t>
-            </a:r>
-            <a:r>
-              <a:rPr lang="en-US" i="1" dirty="0"/>
-              <a:t>who</a:t>
-            </a:r>
+            </a:br>
+            <a:endParaRPr lang="en-US" dirty="0"/>
+          </a:p>
+          <a:p>
             <a:r>
               <a:rPr lang="en-US" dirty="0"/>
-              <a:t> is churning and close the error gap even further. Thank you."</a:t>
-            </a:r>
-          </a:p>
-          <a:p>
-            <a:endParaRPr lang="en-US" dirty="0"/>
+              <a:t>[Look at the audience / Point to the Takeaways]</a:t>
+            </a:r>
+          </a:p>
+          <a:p>
+            <a:r>
+              <a:rPr lang="en-US" dirty="0"/>
+              <a:t>"However, the main takeaway here is that even an optimized pure-RFM baseline is insufficient. To close the error gap further, our next step is to enrich this tree model with the behavioral features we engineered earlier — like Style Entropy — to precisely predict who is churning.</a:t>
+            </a:r>
+          </a:p>
+          <a:p>
+            <a:r>
+              <a:rPr lang="en-US" dirty="0"/>
+              <a:t>Thank you."</a:t>
+            </a:r>
           </a:p>
         </p:txBody>
       </p:sp>
@@ -10904,21 +10920,6 @@
 </file>
 
 <file path=customXml/item1.xml><?xml version="1.0" encoding="utf-8"?>
-<p:properties xmlns:p="http://schemas.microsoft.com/office/2006/metadata/properties" xmlns:xsi="http://www.w3.org/2001/XMLSchema-instance" xmlns:pc="http://schemas.microsoft.com/office/infopath/2007/PartnerControls">
-  <documentManagement/>
-</p:properties>
-</file>
-
-<file path=customXml/item2.xml><?xml version="1.0" encoding="utf-8"?>
-<?mso-contentType ?>
-<FormTemplates xmlns="http://schemas.microsoft.com/sharepoint/v3/contenttype/forms">
-  <Display>DocumentLibraryForm</Display>
-  <Edit>DocumentLibraryForm</Edit>
-  <New>DocumentLibraryForm</New>
-</FormTemplates>
-</file>
-
-<file path=customXml/item3.xml><?xml version="1.0" encoding="utf-8"?>
 <ct:contentTypeSchema xmlns:ct="http://schemas.microsoft.com/office/2006/metadata/contentType" xmlns:ma="http://schemas.microsoft.com/office/2006/metadata/properties/metaAttributes" ct:_="" ma:_="" ma:contentTypeName="Dokument" ma:contentTypeID="0x010100D0F59E03F3A02E49BD70E31348545014" ma:contentTypeVersion="7" ma:contentTypeDescription="Ein neues Dokument erstellen." ma:contentTypeScope="" ma:versionID="907cdc0f808be0b4bc1373a5a8f6a492">
   <xsd:schema xmlns:xsd="http://www.w3.org/2001/XMLSchema" xmlns:xs="http://www.w3.org/2001/XMLSchema" xmlns:p="http://schemas.microsoft.com/office/2006/metadata/properties" xmlns:ns2="7fd05bba-d45d-467f-a5a8-3f2970e80e4a" targetNamespace="http://schemas.microsoft.com/office/2006/metadata/properties" ma:root="true" ma:fieldsID="6eaf8534fcc486a778b01aa1a7a62fa4" ns2:_="">
     <xsd:import namespace="7fd05bba-d45d-467f-a5a8-3f2970e80e4a"/>
@@ -11080,31 +11081,22 @@
 </ct:contentTypeSchema>
 </file>
 
-<file path=customXml/itemProps1.xml><?xml version="1.0" encoding="utf-8"?>
-<ds:datastoreItem xmlns:ds="http://schemas.openxmlformats.org/officeDocument/2006/customXml" ds:itemID="{2C3B1C8D-BA84-44B8-B31F-BF26E7BAC85C}">
-  <ds:schemaRefs>
-    <ds:schemaRef ds:uri="http://purl.org/dc/elements/1.1/"/>
-    <ds:schemaRef ds:uri="http://www.w3.org/XML/1998/namespace"/>
-    <ds:schemaRef ds:uri="http://schemas.openxmlformats.org/package/2006/metadata/core-properties"/>
-    <ds:schemaRef ds:uri="http://schemas.microsoft.com/office/2006/documentManagement/types"/>
-    <ds:schemaRef ds:uri="http://purl.org/dc/terms/"/>
-    <ds:schemaRef ds:uri="http://schemas.microsoft.com/office/infopath/2007/PartnerControls"/>
-    <ds:schemaRef ds:uri="http://purl.org/dc/dcmitype/"/>
-    <ds:schemaRef ds:uri="7fd05bba-d45d-467f-a5a8-3f2970e80e4a"/>
-    <ds:schemaRef ds:uri="http://schemas.microsoft.com/office/2006/metadata/properties"/>
-  </ds:schemaRefs>
-</ds:datastoreItem>
+<file path=customXml/item2.xml><?xml version="1.0" encoding="utf-8"?>
+<?mso-contentType ?>
+<FormTemplates xmlns="http://schemas.microsoft.com/sharepoint/v3/contenttype/forms">
+  <Display>DocumentLibraryForm</Display>
+  <Edit>DocumentLibraryForm</Edit>
+  <New>DocumentLibraryForm</New>
+</FormTemplates>
 </file>
 
-<file path=customXml/itemProps2.xml><?xml version="1.0" encoding="utf-8"?>
-<ds:datastoreItem xmlns:ds="http://schemas.openxmlformats.org/officeDocument/2006/customXml" ds:itemID="{E0CFCB78-2973-46E2-963D-C72C98C43B41}">
-  <ds:schemaRefs>
-    <ds:schemaRef ds:uri="http://schemas.microsoft.com/sharepoint/v3/contenttype/forms"/>
-  </ds:schemaRefs>
-</ds:datastoreItem>
+<file path=customXml/item3.xml><?xml version="1.0" encoding="utf-8"?>
+<p:properties xmlns:p="http://schemas.microsoft.com/office/2006/metadata/properties" xmlns:xsi="http://www.w3.org/2001/XMLSchema-instance" xmlns:pc="http://schemas.microsoft.com/office/infopath/2007/PartnerControls">
+  <documentManagement/>
+</p:properties>
 </file>
 
-<file path=customXml/itemProps3.xml><?xml version="1.0" encoding="utf-8"?>
+<file path=customXml/itemProps1.xml><?xml version="1.0" encoding="utf-8"?>
 <ds:datastoreItem xmlns:ds="http://schemas.openxmlformats.org/officeDocument/2006/customXml" ds:itemID="{6B7B52BC-33EF-4C54-820C-9984D5F8AFB1}">
   <ds:schemaRefs>
     <ds:schemaRef ds:uri="7fd05bba-d45d-467f-a5a8-3f2970e80e4a"/>
@@ -11120,4 +11112,28 @@
     <ds:schemaRef ds:uri="http://www.w3.org/2001/XMLSchema"/>
   </ds:schemaRefs>
 </ds:datastoreItem>
+</file>
+
+<file path=customXml/itemProps2.xml><?xml version="1.0" encoding="utf-8"?>
+<ds:datastoreItem xmlns:ds="http://schemas.openxmlformats.org/officeDocument/2006/customXml" ds:itemID="{E0CFCB78-2973-46E2-963D-C72C98C43B41}">
+  <ds:schemaRefs>
+    <ds:schemaRef ds:uri="http://schemas.microsoft.com/sharepoint/v3/contenttype/forms"/>
+  </ds:schemaRefs>
+</ds:datastoreItem>
+</file>
+
+<file path=customXml/itemProps3.xml><?xml version="1.0" encoding="utf-8"?>
+<ds:datastoreItem xmlns:ds="http://schemas.openxmlformats.org/officeDocument/2006/customXml" ds:itemID="{2C3B1C8D-BA84-44B8-B31F-BF26E7BAC85C}">
+  <ds:schemaRefs>
+    <ds:schemaRef ds:uri="http://purl.org/dc/elements/1.1/"/>
+    <ds:schemaRef ds:uri="http://www.w3.org/XML/1998/namespace"/>
+    <ds:schemaRef ds:uri="http://schemas.openxmlformats.org/package/2006/metadata/core-properties"/>
+    <ds:schemaRef ds:uri="http://schemas.microsoft.com/office/2006/documentManagement/types"/>
+    <ds:schemaRef ds:uri="http://purl.org/dc/terms/"/>
+    <ds:schemaRef ds:uri="http://schemas.microsoft.com/office/infopath/2007/PartnerControls"/>
+    <ds:schemaRef ds:uri="http://purl.org/dc/dcmitype/"/>
+    <ds:schemaRef ds:uri="7fd05bba-d45d-467f-a5a8-3f2970e80e4a"/>
+    <ds:schemaRef ds:uri="http://schemas.microsoft.com/office/2006/metadata/properties"/>
+  </ds:schemaRefs>
+</ds:datastoreItem>
 </file>
</xml_diff>

<commit_message>
Added slide about test-train split
</commit_message>
<xml_diff>
--- a/Presentations/Assignment_2_MA.pptx
+++ b/Presentations/Assignment_2_MA.pptx
@@ -12,8 +12,8 @@
   </p:handoutMasterIdLst>
   <p:sldIdLst>
     <p:sldId id="256" r:id="rId5"/>
-    <p:sldId id="1190" r:id="rId6"/>
-    <p:sldId id="1188" r:id="rId7"/>
+    <p:sldId id="276" r:id="rId6"/>
+    <p:sldId id="1190" r:id="rId7"/>
   </p:sldIdLst>
   <p:sldSz cx="12192000" cy="6858000"/>
   <p:notesSz cx="6858000" cy="9144000"/>
@@ -306,7 +306,7 @@
           <a:p>
             <a:fld id="{2B685DCD-866D-47AE-A236-118539F53379}" type="slidenum">
               <a:rPr lang="de-CH" smtClean="0"/>
-              <a:t>‹#›</a:t>
+              <a:t>‹Nr.›</a:t>
             </a:fld>
             <a:endParaRPr lang="de-CH"/>
           </a:p>
@@ -564,7 +564,7 @@
           <a:p>
             <a:fld id="{F615DDFD-030C-4D5A-B33E-3A7E7538D2BE}" type="slidenum">
               <a:rPr lang="de-CH" smtClean="0"/>
-              <a:t>‹#›</a:t>
+              <a:t>‹Nr.›</a:t>
             </a:fld>
             <a:endParaRPr lang="de-CH"/>
           </a:p>
@@ -718,123 +718,348 @@
           <a:lstStyle/>
           <a:p>
             <a:r>
+              <a:rPr lang="de-DE" dirty="0" err="1"/>
+              <a:t>Structural</a:t>
+            </a:r>
+            <a:r>
+              <a:rPr lang="de-DE" dirty="0"/>
+              <a:t> break in </a:t>
+            </a:r>
+            <a:r>
+              <a:rPr lang="de-DE" dirty="0" err="1"/>
+              <a:t>consumer</a:t>
+            </a:r>
+            <a:r>
+              <a:rPr lang="de-DE" dirty="0"/>
+              <a:t> </a:t>
+            </a:r>
+            <a:r>
+              <a:rPr lang="de-DE" dirty="0" err="1"/>
+              <a:t>behavior</a:t>
+            </a:r>
+            <a:r>
+              <a:rPr lang="de-DE" dirty="0"/>
+              <a:t> </a:t>
+            </a:r>
+            <a:r>
+              <a:rPr lang="de-DE" dirty="0" err="1"/>
+              <a:t>or</a:t>
+            </a:r>
+            <a:r>
+              <a:rPr lang="de-DE" dirty="0"/>
+              <a:t> </a:t>
+            </a:r>
+            <a:r>
+              <a:rPr lang="de-DE" dirty="0" err="1"/>
+              <a:t>renting</a:t>
+            </a:r>
+            <a:r>
+              <a:rPr lang="de-DE" dirty="0"/>
+              <a:t> </a:t>
+            </a:r>
+            <a:r>
+              <a:rPr lang="de-DE" dirty="0" err="1"/>
+              <a:t>behavior</a:t>
+            </a:r>
+            <a:r>
+              <a:rPr lang="de-DE" dirty="0"/>
+              <a:t> </a:t>
+            </a:r>
+            <a:r>
+              <a:rPr lang="de-DE" dirty="0">
+                <a:sym typeface="Wingdings" panose="05000000000000000000" pitchFamily="2" charset="2"/>
+              </a:rPr>
+              <a:t> </a:t>
+            </a:r>
+            <a:r>
+              <a:rPr lang="de-DE" dirty="0" err="1">
+                <a:sym typeface="Wingdings" panose="05000000000000000000" pitchFamily="2" charset="2"/>
+              </a:rPr>
+              <a:t>maybe</a:t>
+            </a:r>
+            <a:r>
+              <a:rPr lang="de-DE" dirty="0">
+                <a:sym typeface="Wingdings" panose="05000000000000000000" pitchFamily="2" charset="2"/>
+              </a:rPr>
+              <a:t> </a:t>
+            </a:r>
+            <a:r>
+              <a:rPr lang="de-DE" dirty="0" err="1">
+                <a:sym typeface="Wingdings" panose="05000000000000000000" pitchFamily="2" charset="2"/>
+              </a:rPr>
+              <a:t>iniatied</a:t>
+            </a:r>
+            <a:r>
+              <a:rPr lang="de-DE" dirty="0">
+                <a:sym typeface="Wingdings" panose="05000000000000000000" pitchFamily="2" charset="2"/>
+              </a:rPr>
+              <a:t> </a:t>
+            </a:r>
+            <a:r>
+              <a:rPr lang="de-DE" dirty="0" err="1">
+                <a:sym typeface="Wingdings" panose="05000000000000000000" pitchFamily="2" charset="2"/>
+              </a:rPr>
+              <a:t>by</a:t>
+            </a:r>
+            <a:r>
+              <a:rPr lang="de-DE" dirty="0">
+                <a:sym typeface="Wingdings" panose="05000000000000000000" pitchFamily="2" charset="2"/>
+              </a:rPr>
+              <a:t> a </a:t>
+            </a:r>
+            <a:r>
+              <a:rPr lang="de-DE" dirty="0" err="1">
+                <a:sym typeface="Wingdings" panose="05000000000000000000" pitchFamily="2" charset="2"/>
+              </a:rPr>
+              <a:t>change</a:t>
+            </a:r>
+            <a:r>
+              <a:rPr lang="de-DE" dirty="0">
+                <a:sym typeface="Wingdings" panose="05000000000000000000" pitchFamily="2" charset="2"/>
+              </a:rPr>
+              <a:t> in </a:t>
+            </a:r>
+            <a:r>
+              <a:rPr lang="de-DE" dirty="0" err="1">
+                <a:sym typeface="Wingdings" panose="05000000000000000000" pitchFamily="2" charset="2"/>
+              </a:rPr>
+              <a:t>the</a:t>
+            </a:r>
+            <a:r>
+              <a:rPr lang="de-DE" dirty="0">
+                <a:sym typeface="Wingdings" panose="05000000000000000000" pitchFamily="2" charset="2"/>
+              </a:rPr>
+              <a:t> </a:t>
+            </a:r>
+            <a:r>
+              <a:rPr lang="de-DE" dirty="0" err="1">
+                <a:sym typeface="Wingdings" panose="05000000000000000000" pitchFamily="2" charset="2"/>
+              </a:rPr>
+              <a:t>renting</a:t>
+            </a:r>
+            <a:r>
+              <a:rPr lang="de-DE" dirty="0">
+                <a:sym typeface="Wingdings" panose="05000000000000000000" pitchFamily="2" charset="2"/>
+              </a:rPr>
+              <a:t> </a:t>
+            </a:r>
+            <a:r>
+              <a:rPr lang="de-DE" dirty="0" err="1">
+                <a:sym typeface="Wingdings" panose="05000000000000000000" pitchFamily="2" charset="2"/>
+              </a:rPr>
+              <a:t>business</a:t>
+            </a:r>
+            <a:endParaRPr lang="de-DE" dirty="0">
+              <a:sym typeface="Wingdings" panose="05000000000000000000" pitchFamily="2" charset="2"/>
+            </a:endParaRPr>
+          </a:p>
+          <a:p>
+            <a:endParaRPr lang="de-DE" dirty="0">
+              <a:sym typeface="Wingdings" panose="05000000000000000000" pitchFamily="2" charset="2"/>
+            </a:endParaRPr>
+          </a:p>
+          <a:p>
+            <a:r>
+              <a:rPr lang="de-DE" dirty="0">
+                <a:sym typeface="Wingdings" panose="05000000000000000000" pitchFamily="2" charset="2"/>
+              </a:rPr>
+              <a:t>Because </a:t>
+            </a:r>
+            <a:r>
+              <a:rPr lang="de-DE" dirty="0" err="1">
+                <a:sym typeface="Wingdings" panose="05000000000000000000" pitchFamily="2" charset="2"/>
+              </a:rPr>
+              <a:t>before</a:t>
+            </a:r>
+            <a:r>
+              <a:rPr lang="de-DE" dirty="0">
+                <a:sym typeface="Wingdings" panose="05000000000000000000" pitchFamily="2" charset="2"/>
+              </a:rPr>
+              <a:t> 2020 </a:t>
+            </a:r>
+            <a:r>
+              <a:rPr lang="de-DE" dirty="0" err="1">
+                <a:sym typeface="Wingdings" panose="05000000000000000000" pitchFamily="2" charset="2"/>
+              </a:rPr>
+              <a:t>most</a:t>
+            </a:r>
+            <a:r>
+              <a:rPr lang="de-DE" dirty="0">
+                <a:sym typeface="Wingdings" panose="05000000000000000000" pitchFamily="2" charset="2"/>
+              </a:rPr>
+              <a:t> </a:t>
+            </a:r>
+            <a:r>
+              <a:rPr lang="de-DE" dirty="0" err="1">
+                <a:sym typeface="Wingdings" panose="05000000000000000000" pitchFamily="2" charset="2"/>
+              </a:rPr>
+              <a:t>rentals</a:t>
+            </a:r>
+            <a:r>
+              <a:rPr lang="de-DE" dirty="0">
+                <a:sym typeface="Wingdings" panose="05000000000000000000" pitchFamily="2" charset="2"/>
+              </a:rPr>
+              <a:t> </a:t>
+            </a:r>
+            <a:r>
+              <a:rPr lang="de-DE" dirty="0" err="1">
+                <a:sym typeface="Wingdings" panose="05000000000000000000" pitchFamily="2" charset="2"/>
+              </a:rPr>
+              <a:t>were</a:t>
+            </a:r>
+            <a:r>
+              <a:rPr lang="de-DE" dirty="0">
+                <a:sym typeface="Wingdings" panose="05000000000000000000" pitchFamily="2" charset="2"/>
+              </a:rPr>
+              <a:t> </a:t>
+            </a:r>
+            <a:r>
+              <a:rPr lang="de-DE" dirty="0" err="1">
+                <a:sym typeface="Wingdings" panose="05000000000000000000" pitchFamily="2" charset="2"/>
+              </a:rPr>
+              <a:t>around</a:t>
+            </a:r>
+            <a:r>
+              <a:rPr lang="de-DE" dirty="0">
+                <a:sym typeface="Wingdings" panose="05000000000000000000" pitchFamily="2" charset="2"/>
+              </a:rPr>
+              <a:t> a </a:t>
+            </a:r>
+            <a:r>
+              <a:rPr lang="de-DE" dirty="0" err="1">
+                <a:sym typeface="Wingdings" panose="05000000000000000000" pitchFamily="2" charset="2"/>
+              </a:rPr>
+              <a:t>week</a:t>
+            </a:r>
+            <a:r>
+              <a:rPr lang="de-DE" dirty="0">
+                <a:sym typeface="Wingdings" panose="05000000000000000000" pitchFamily="2" charset="2"/>
+              </a:rPr>
+              <a:t> </a:t>
+            </a:r>
+            <a:r>
+              <a:rPr lang="de-DE" dirty="0" err="1">
+                <a:sym typeface="Wingdings" panose="05000000000000000000" pitchFamily="2" charset="2"/>
+              </a:rPr>
+              <a:t>long</a:t>
+            </a:r>
+            <a:r>
+              <a:rPr lang="de-DE" dirty="0">
+                <a:sym typeface="Wingdings" panose="05000000000000000000" pitchFamily="2" charset="2"/>
+              </a:rPr>
+              <a:t> and after </a:t>
+            </a:r>
+            <a:r>
+              <a:rPr lang="de-DE" dirty="0" err="1">
+                <a:sym typeface="Wingdings" panose="05000000000000000000" pitchFamily="2" charset="2"/>
+              </a:rPr>
+              <a:t>it</a:t>
+            </a:r>
+            <a:r>
+              <a:rPr lang="de-DE" dirty="0">
+                <a:sym typeface="Wingdings" panose="05000000000000000000" pitchFamily="2" charset="2"/>
+              </a:rPr>
+              <a:t> </a:t>
+            </a:r>
+            <a:r>
+              <a:rPr lang="de-DE" dirty="0" err="1">
+                <a:sym typeface="Wingdings" panose="05000000000000000000" pitchFamily="2" charset="2"/>
+              </a:rPr>
+              <a:t>basically</a:t>
+            </a:r>
+            <a:r>
+              <a:rPr lang="de-DE" dirty="0">
+                <a:sym typeface="Wingdings" panose="05000000000000000000" pitchFamily="2" charset="2"/>
+              </a:rPr>
+              <a:t> </a:t>
+            </a:r>
+            <a:r>
+              <a:rPr lang="de-DE" dirty="0" err="1">
+                <a:sym typeface="Wingdings" panose="05000000000000000000" pitchFamily="2" charset="2"/>
+              </a:rPr>
+              <a:t>stabilized</a:t>
+            </a:r>
+            <a:r>
+              <a:rPr lang="de-DE" dirty="0">
+                <a:sym typeface="Wingdings" panose="05000000000000000000" pitchFamily="2" charset="2"/>
+              </a:rPr>
+              <a:t> to 30 </a:t>
+            </a:r>
+            <a:r>
+              <a:rPr lang="de-DE" dirty="0" err="1">
+                <a:sym typeface="Wingdings" panose="05000000000000000000" pitchFamily="2" charset="2"/>
+              </a:rPr>
+              <a:t>day</a:t>
+            </a:r>
+            <a:r>
+              <a:rPr lang="de-DE" dirty="0">
+                <a:sym typeface="Wingdings" panose="05000000000000000000" pitchFamily="2" charset="2"/>
+              </a:rPr>
+              <a:t> </a:t>
+            </a:r>
+            <a:r>
+              <a:rPr lang="de-DE" dirty="0" err="1">
+                <a:sym typeface="Wingdings" panose="05000000000000000000" pitchFamily="2" charset="2"/>
+              </a:rPr>
+              <a:t>rentals</a:t>
+            </a:r>
+            <a:endParaRPr lang="de-DE" dirty="0">
+              <a:sym typeface="Wingdings" panose="05000000000000000000" pitchFamily="2" charset="2"/>
+            </a:endParaRPr>
+          </a:p>
+          <a:p>
+            <a:endParaRPr lang="de-DE" dirty="0">
+              <a:sym typeface="Wingdings" panose="05000000000000000000" pitchFamily="2" charset="2"/>
+            </a:endParaRPr>
+          </a:p>
+          <a:p>
+            <a:r>
               <a:rPr lang="en-US" dirty="0"/>
-              <a:t>[Transition - Take the floor from your colleague]</a:t>
-            </a:r>
+              <a:t>That’s why we are just going to focus on the data after the shift</a:t>
+            </a:r>
+          </a:p>
+          <a:p>
+            <a:endParaRPr lang="en-US" dirty="0"/>
+          </a:p>
+          <a:p>
+            <a:endParaRPr lang="en-US" dirty="0"/>
           </a:p>
           <a:p>
             <a:r>
               <a:rPr lang="en-US" dirty="0"/>
-              <a:t>"Following up on the temporal split my colleague just explained, I'll walk you through our baseline models and a critical issue we discovered in the data: Latent Attrition."</a:t>
-            </a:r>
-          </a:p>
-          <a:p>
-            <a:br>
+              <a:t>We </a:t>
+            </a:r>
+            <a:r>
+              <a:rPr lang="en-US" dirty="0" err="1"/>
+              <a:t>tought</a:t>
+            </a:r>
+            <a:r>
               <a:rPr lang="en-US" dirty="0"/>
-            </a:br>
+              <a:t> about doing a two fold test train approach</a:t>
+            </a:r>
+          </a:p>
+          <a:p>
             <a:endParaRPr lang="en-US" dirty="0"/>
           </a:p>
           <a:p>
             <a:r>
               <a:rPr lang="en-US" dirty="0"/>
-              <a:t>[Point to the Bar Chart on the left]</a:t>
-            </a:r>
+              <a:t>We use Fold 1 to establish a baseline. If Fold 1 performs well, and Fold 2 performs just as well or better, it proves our model is stable and ready to predict </a:t>
+            </a:r>
+          </a:p>
+          <a:p>
+            <a:endParaRPr lang="en-US" dirty="0"/>
           </a:p>
           <a:p>
             <a:r>
               <a:rPr lang="en-US" dirty="0"/>
-              <a:t>"We started with a standard RFM approach using a simple Ridge Regression. As you can see on the chart, this resulted in a massive Mean Absolute Error of nearly 14,700 NOK."</a:t>
-            </a:r>
-          </a:p>
-          <a:p>
-            <a:br>
-              <a:rPr lang="en-US" dirty="0"/>
-            </a:br>
+              <a:t>But what could also be a point is to check if the first couple of months have too much “variance” in them before the data distribution settles. If the first fold is a lot worse that could be a hind to this and then we would crop the data </a:t>
+            </a:r>
+            <a:r>
+              <a:rPr lang="en-US"/>
+              <a:t>even further</a:t>
+            </a:r>
             <a:endParaRPr lang="en-US" dirty="0"/>
-          </a:p>
-          <a:p>
-            <a:r>
-              <a:rPr lang="en-US" dirty="0"/>
-              <a:t>[Point to the Table on the top right]</a:t>
-            </a:r>
-          </a:p>
-          <a:p>
-            <a:r>
-              <a:rPr lang="en-US" dirty="0"/>
-              <a:t>"To understand why it failed, look at the actual data in the table. Customer number 3 is a 'churned whale'. They spent over 55,000 NOK historically, but haven't rented anything in 245 days. Their actual future revenue is zero.</a:t>
-            </a:r>
-          </a:p>
-          <a:p>
-            <a:r>
-              <a:rPr lang="en-US" dirty="0"/>
-              <a:t>But because a linear model heavily weights historical spend, it doesn't understand this latent attrition. It hallucinates over 24,000 NOK in future revenue for a completely dead account."</a:t>
-            </a:r>
-          </a:p>
-          <a:p>
-            <a:br>
-              <a:rPr lang="en-US" dirty="0"/>
-            </a:br>
-            <a:endParaRPr lang="en-US" dirty="0"/>
-          </a:p>
-          <a:p>
-            <a:r>
-              <a:rPr lang="en-US" dirty="0"/>
-              <a:t>[Point back to the </a:t>
-            </a:r>
-            <a:r>
-              <a:rPr lang="en-US" dirty="0" err="1"/>
-              <a:t>LightGBM</a:t>
-            </a:r>
-            <a:r>
-              <a:rPr lang="en-US" dirty="0"/>
-              <a:t> Bar on the chart]</a:t>
-            </a:r>
-          </a:p>
-          <a:p>
-            <a:r>
-              <a:rPr lang="en-US" dirty="0"/>
-              <a:t>"To fix this, we upgraded to a tree-based model: </a:t>
-            </a:r>
-            <a:r>
-              <a:rPr lang="en-US" dirty="0" err="1"/>
-              <a:t>LightGBM</a:t>
-            </a:r>
-            <a:r>
-              <a:rPr lang="en-US" dirty="0"/>
-              <a:t>. Because trees can learn non-linear rules, </a:t>
-            </a:r>
-            <a:r>
-              <a:rPr lang="en-US" dirty="0" err="1"/>
-              <a:t>LightGBM</a:t>
-            </a:r>
-            <a:r>
-              <a:rPr lang="en-US" dirty="0"/>
-              <a:t> implicitly learned that once 'Recency' crosses a certain threshold, the predicted revenue must drop to zero. This cut our error by 30%."</a:t>
-            </a:r>
-          </a:p>
-          <a:p>
-            <a:br>
-              <a:rPr lang="en-US" dirty="0"/>
-            </a:br>
-            <a:endParaRPr lang="en-US" dirty="0"/>
-          </a:p>
-          <a:p>
-            <a:r>
-              <a:rPr lang="en-US" dirty="0"/>
-              <a:t>[Look at the audience / Point to the Takeaways]</a:t>
-            </a:r>
-          </a:p>
-          <a:p>
-            <a:r>
-              <a:rPr lang="en-US" dirty="0"/>
-              <a:t>"However, the main takeaway here is that even an optimized pure-RFM baseline is insufficient. To close the error gap further, our next step is to enrich this tree model with the behavioral features we engineered earlier — like Style Entropy — to precisely predict who is churning.</a:t>
-            </a:r>
-          </a:p>
-          <a:p>
-            <a:r>
-              <a:rPr lang="en-US" dirty="0"/>
-              <a:t>Thank you."</a:t>
-            </a:r>
           </a:p>
         </p:txBody>
       </p:sp>
@@ -864,7 +1089,7 @@
     </p:spTree>
     <p:extLst>
       <p:ext uri="{BB962C8B-B14F-4D97-AF65-F5344CB8AC3E}">
-        <p14:creationId xmlns:p14="http://schemas.microsoft.com/office/powerpoint/2010/main" val="2859236339"/>
+        <p14:creationId xmlns:p14="http://schemas.microsoft.com/office/powerpoint/2010/main" val="3120402234"/>
       </p:ext>
     </p:extLst>
   </p:cSld>
@@ -893,7 +1118,7 @@
       </p:grpSpPr>
       <p:sp>
         <p:nvSpPr>
-          <p:cNvPr id="2" name="Slide Image Placeholder 1"/>
+          <p:cNvPr id="2" name="Folienbildplatzhalter 1"/>
           <p:cNvSpPr>
             <a:spLocks noGrp="1" noRot="1" noChangeAspect="1"/>
           </p:cNvSpPr>
@@ -905,7 +1130,7 @@
       </p:sp>
       <p:sp>
         <p:nvSpPr>
-          <p:cNvPr id="3" name="Notes Placeholder 2"/>
+          <p:cNvPr id="3" name="Notizenplatzhalter 2"/>
           <p:cNvSpPr>
             <a:spLocks noGrp="1"/>
           </p:cNvSpPr>
@@ -918,13 +1143,130 @@
           <a:bodyPr/>
           <a:lstStyle/>
           <a:p>
+            <a:r>
+              <a:rPr lang="en-US" dirty="0"/>
+              <a:t>[Transition - Take the floor from your colleague]</a:t>
+            </a:r>
+          </a:p>
+          <a:p>
+            <a:r>
+              <a:rPr lang="en-US" dirty="0"/>
+              <a:t>"Following up on the temporal split my colleague just explained, I'll walk you through our baseline models and a critical issue we discovered in the data: Latent Attrition."</a:t>
+            </a:r>
+          </a:p>
+          <a:p>
+            <a:br>
+              <a:rPr lang="en-US" dirty="0"/>
+            </a:br>
             <a:endParaRPr lang="en-US" dirty="0"/>
           </a:p>
-        </p:txBody>
-      </p:sp>
-      <p:sp>
-        <p:nvSpPr>
-          <p:cNvPr id="4" name="Slide Number Placeholder 3"/>
+          <a:p>
+            <a:r>
+              <a:rPr lang="en-US" dirty="0"/>
+              <a:t>[Point to the Bar Chart on the left]</a:t>
+            </a:r>
+          </a:p>
+          <a:p>
+            <a:r>
+              <a:rPr lang="en-US" dirty="0"/>
+              <a:t>"We started with a standard RFM approach using a simple Ridge Regression. As you can see on the chart, this resulted in a massive Mean Absolute Error of nearly 14,700 NOK."</a:t>
+            </a:r>
+          </a:p>
+          <a:p>
+            <a:br>
+              <a:rPr lang="en-US" dirty="0"/>
+            </a:br>
+            <a:endParaRPr lang="en-US" dirty="0"/>
+          </a:p>
+          <a:p>
+            <a:r>
+              <a:rPr lang="en-US" dirty="0"/>
+              <a:t>[Point to the Table on the top right]</a:t>
+            </a:r>
+          </a:p>
+          <a:p>
+            <a:r>
+              <a:rPr lang="en-US" dirty="0"/>
+              <a:t>"To understand why it failed, look at the actual data in the table. Customer number 3 is a 'churned whale'. They spent over 55,000 NOK historically, but haven't rented anything in 245 days. Their actual future revenue is zero.</a:t>
+            </a:r>
+          </a:p>
+          <a:p>
+            <a:r>
+              <a:rPr lang="en-US" dirty="0"/>
+              <a:t>But because a linear model heavily weights historical spend, it doesn't understand this latent attrition. It hallucinates over 24,000 NOK in future revenue for a completely dead account."</a:t>
+            </a:r>
+          </a:p>
+          <a:p>
+            <a:br>
+              <a:rPr lang="en-US" dirty="0"/>
+            </a:br>
+            <a:endParaRPr lang="en-US" dirty="0"/>
+          </a:p>
+          <a:p>
+            <a:r>
+              <a:rPr lang="en-US" dirty="0"/>
+              <a:t>[Point back to the </a:t>
+            </a:r>
+            <a:r>
+              <a:rPr lang="en-US" dirty="0" err="1"/>
+              <a:t>LightGBM</a:t>
+            </a:r>
+            <a:r>
+              <a:rPr lang="en-US" dirty="0"/>
+              <a:t> Bar on the chart]</a:t>
+            </a:r>
+          </a:p>
+          <a:p>
+            <a:r>
+              <a:rPr lang="en-US" dirty="0"/>
+              <a:t>"To fix this, we upgraded to a tree-based model: </a:t>
+            </a:r>
+            <a:r>
+              <a:rPr lang="en-US" dirty="0" err="1"/>
+              <a:t>LightGBM</a:t>
+            </a:r>
+            <a:r>
+              <a:rPr lang="en-US" dirty="0"/>
+              <a:t>. Because trees can learn non-linear rules, </a:t>
+            </a:r>
+            <a:r>
+              <a:rPr lang="en-US" dirty="0" err="1"/>
+              <a:t>LightGBM</a:t>
+            </a:r>
+            <a:r>
+              <a:rPr lang="en-US" dirty="0"/>
+              <a:t> implicitly learned that once 'Recency' crosses a certain threshold, the predicted revenue must drop to zero. This cut our error by 30%."</a:t>
+            </a:r>
+          </a:p>
+          <a:p>
+            <a:br>
+              <a:rPr lang="en-US" dirty="0"/>
+            </a:br>
+            <a:endParaRPr lang="en-US" dirty="0"/>
+          </a:p>
+          <a:p>
+            <a:r>
+              <a:rPr lang="en-US" dirty="0"/>
+              <a:t>[Look at the audience / Point to the Takeaways]</a:t>
+            </a:r>
+          </a:p>
+          <a:p>
+            <a:r>
+              <a:rPr lang="en-US" dirty="0"/>
+              <a:t>"However, the main takeaway here is that even an optimized pure-RFM baseline is insufficient. To close the error gap further, our next step is to enrich this tree model with the behavioral features we engineered earlier — like Style Entropy — to precisely predict who is churning.</a:t>
+            </a:r>
+          </a:p>
+          <a:p>
+            <a:r>
+              <a:rPr lang="en-US" dirty="0"/>
+              <a:t>Thank you."</a:t>
+            </a:r>
+          </a:p>
+        </p:txBody>
+      </p:sp>
+      <p:sp>
+        <p:nvSpPr>
+          <p:cNvPr id="4" name="Foliennummernplatzhalter 3"/>
           <p:cNvSpPr>
             <a:spLocks noGrp="1"/>
           </p:cNvSpPr>
@@ -948,7 +1290,7 @@
     </p:spTree>
     <p:extLst>
       <p:ext uri="{BB962C8B-B14F-4D97-AF65-F5344CB8AC3E}">
-        <p14:creationId xmlns:p14="http://schemas.microsoft.com/office/powerpoint/2010/main" val="2854007841"/>
+        <p14:creationId xmlns:p14="http://schemas.microsoft.com/office/powerpoint/2010/main" val="2859236339"/>
       </p:ext>
     </p:extLst>
   </p:cSld>
@@ -1077,13 +1419,13 @@
           <p:nvPr userDrawn="1"/>
         </p:nvPicPr>
         <p:blipFill>
-          <a:blip r:embed="rId2">
+          <a:blip>
             <a:extLst>
               <a:ext uri="{28A0092B-C50C-407E-A947-70E740481C1C}">
                 <a14:useLocalDpi xmlns:a14="http://schemas.microsoft.com/office/drawing/2010/main" val="0"/>
               </a:ext>
               <a:ext uri="{96DAC541-7B7A-43D3-8B79-37D633B846F1}">
-                <asvg:svgBlip xmlns:asvg="http://schemas.microsoft.com/office/drawing/2016/SVG/main" r:embed="rId3"/>
+                <asvg:svgBlip xmlns:asvg="http://schemas.microsoft.com/office/drawing/2016/SVG/main" r:embed="rId2"/>
               </a:ext>
             </a:extLst>
           </a:blip>
@@ -1476,7 +1818,7 @@
           <a:p>
             <a:fld id="{5ACA52AF-F19D-405C-AD5F-7D94B96A5CC3}" type="slidenum">
               <a:rPr lang="de-CH" noProof="0" smtClean="0"/>
-              <a:t>‹#›</a:t>
+              <a:t>‹Nr.›</a:t>
             </a:fld>
             <a:endParaRPr lang="de-CH" noProof="0"/>
           </a:p>
@@ -1497,13 +1839,13 @@
           <p:nvPr userDrawn="1"/>
         </p:nvPicPr>
         <p:blipFill>
-          <a:blip r:embed="rId2">
+          <a:blip>
             <a:extLst>
               <a:ext uri="{28A0092B-C50C-407E-A947-70E740481C1C}">
                 <a14:useLocalDpi xmlns:a14="http://schemas.microsoft.com/office/drawing/2010/main" val="0"/>
               </a:ext>
               <a:ext uri="{96DAC541-7B7A-43D3-8B79-37D633B846F1}">
-                <asvg:svgBlip xmlns:asvg="http://schemas.microsoft.com/office/drawing/2016/SVG/main" r:embed="rId3"/>
+                <asvg:svgBlip xmlns:asvg="http://schemas.microsoft.com/office/drawing/2016/SVG/main" r:embed="rId2"/>
               </a:ext>
             </a:extLst>
           </a:blip>
@@ -1671,7 +2013,7 @@
           <a:p>
             <a:fld id="{5ACA52AF-F19D-405C-AD5F-7D94B96A5CC3}" type="slidenum">
               <a:rPr lang="de-CH" noProof="0" smtClean="0"/>
-              <a:t>‹#›</a:t>
+              <a:t>‹Nr.›</a:t>
             </a:fld>
             <a:endParaRPr lang="de-CH" noProof="0"/>
           </a:p>
@@ -1692,13 +2034,13 @@
           <p:nvPr userDrawn="1"/>
         </p:nvPicPr>
         <p:blipFill>
-          <a:blip r:embed="rId2">
+          <a:blip>
             <a:extLst>
               <a:ext uri="{28A0092B-C50C-407E-A947-70E740481C1C}">
                 <a14:useLocalDpi xmlns:a14="http://schemas.microsoft.com/office/drawing/2010/main" val="0"/>
               </a:ext>
               <a:ext uri="{96DAC541-7B7A-43D3-8B79-37D633B846F1}">
-                <asvg:svgBlip xmlns:asvg="http://schemas.microsoft.com/office/drawing/2016/SVG/main" r:embed="rId3"/>
+                <asvg:svgBlip xmlns:asvg="http://schemas.microsoft.com/office/drawing/2016/SVG/main" r:embed="rId2"/>
               </a:ext>
             </a:extLst>
           </a:blip>
@@ -1958,7 +2300,7 @@
           <a:p>
             <a:fld id="{5ACA52AF-F19D-405C-AD5F-7D94B96A5CC3}" type="slidenum">
               <a:rPr lang="de-CH" noProof="0" smtClean="0"/>
-              <a:t>‹#›</a:t>
+              <a:t>‹Nr.›</a:t>
             </a:fld>
             <a:endParaRPr lang="de-CH" noProof="0"/>
           </a:p>
@@ -1979,13 +2321,13 @@
           <p:nvPr userDrawn="1"/>
         </p:nvPicPr>
         <p:blipFill>
-          <a:blip r:embed="rId2">
+          <a:blip>
             <a:extLst>
               <a:ext uri="{28A0092B-C50C-407E-A947-70E740481C1C}">
                 <a14:useLocalDpi xmlns:a14="http://schemas.microsoft.com/office/drawing/2010/main" val="0"/>
               </a:ext>
               <a:ext uri="{96DAC541-7B7A-43D3-8B79-37D633B846F1}">
-                <asvg:svgBlip xmlns:asvg="http://schemas.microsoft.com/office/drawing/2016/SVG/main" r:embed="rId3"/>
+                <asvg:svgBlip xmlns:asvg="http://schemas.microsoft.com/office/drawing/2016/SVG/main" r:embed="rId2"/>
               </a:ext>
             </a:extLst>
           </a:blip>
@@ -2256,7 +2598,7 @@
           <a:p>
             <a:fld id="{5ACA52AF-F19D-405C-AD5F-7D94B96A5CC3}" type="slidenum">
               <a:rPr lang="de-CH" noProof="0" smtClean="0"/>
-              <a:t>‹#›</a:t>
+              <a:t>‹Nr.›</a:t>
             </a:fld>
             <a:endParaRPr lang="de-CH" noProof="0"/>
           </a:p>
@@ -2277,13 +2619,13 @@
           <p:nvPr userDrawn="1"/>
         </p:nvPicPr>
         <p:blipFill>
-          <a:blip r:embed="rId2">
+          <a:blip>
             <a:extLst>
               <a:ext uri="{28A0092B-C50C-407E-A947-70E740481C1C}">
                 <a14:useLocalDpi xmlns:a14="http://schemas.microsoft.com/office/drawing/2010/main" val="0"/>
               </a:ext>
               <a:ext uri="{96DAC541-7B7A-43D3-8B79-37D633B846F1}">
-                <asvg:svgBlip xmlns:asvg="http://schemas.microsoft.com/office/drawing/2016/SVG/main" r:embed="rId3"/>
+                <asvg:svgBlip xmlns:asvg="http://schemas.microsoft.com/office/drawing/2016/SVG/main" r:embed="rId2"/>
               </a:ext>
             </a:extLst>
           </a:blip>
@@ -2656,7 +2998,7 @@
           <a:p>
             <a:fld id="{5ACA52AF-F19D-405C-AD5F-7D94B96A5CC3}" type="slidenum">
               <a:rPr lang="de-CH" noProof="0" smtClean="0"/>
-              <a:t>‹#›</a:t>
+              <a:t>‹Nr.›</a:t>
             </a:fld>
             <a:endParaRPr lang="de-CH" noProof="0"/>
           </a:p>
@@ -2677,13 +3019,13 @@
           <p:nvPr userDrawn="1"/>
         </p:nvPicPr>
         <p:blipFill>
-          <a:blip r:embed="rId2">
+          <a:blip>
             <a:extLst>
               <a:ext uri="{28A0092B-C50C-407E-A947-70E740481C1C}">
                 <a14:useLocalDpi xmlns:a14="http://schemas.microsoft.com/office/drawing/2010/main" val="0"/>
               </a:ext>
               <a:ext uri="{96DAC541-7B7A-43D3-8B79-37D633B846F1}">
-                <asvg:svgBlip xmlns:asvg="http://schemas.microsoft.com/office/drawing/2016/SVG/main" r:embed="rId3"/>
+                <asvg:svgBlip xmlns:asvg="http://schemas.microsoft.com/office/drawing/2016/SVG/main" r:embed="rId2"/>
               </a:ext>
             </a:extLst>
           </a:blip>
@@ -3024,7 +3366,7 @@
           <a:p>
             <a:fld id="{5ACA52AF-F19D-405C-AD5F-7D94B96A5CC3}" type="slidenum">
               <a:rPr lang="de-CH" noProof="0" smtClean="0"/>
-              <a:t>‹#›</a:t>
+              <a:t>‹Nr.›</a:t>
             </a:fld>
             <a:endParaRPr lang="de-CH" noProof="0"/>
           </a:p>
@@ -3045,13 +3387,13 @@
           <p:nvPr userDrawn="1"/>
         </p:nvPicPr>
         <p:blipFill>
-          <a:blip r:embed="rId2">
+          <a:blip>
             <a:extLst>
               <a:ext uri="{28A0092B-C50C-407E-A947-70E740481C1C}">
                 <a14:useLocalDpi xmlns:a14="http://schemas.microsoft.com/office/drawing/2010/main" val="0"/>
               </a:ext>
               <a:ext uri="{96DAC541-7B7A-43D3-8B79-37D633B846F1}">
-                <asvg:svgBlip xmlns:asvg="http://schemas.microsoft.com/office/drawing/2016/SVG/main" r:embed="rId3"/>
+                <asvg:svgBlip xmlns:asvg="http://schemas.microsoft.com/office/drawing/2016/SVG/main" r:embed="rId2"/>
               </a:ext>
             </a:extLst>
           </a:blip>
@@ -3296,13 +3638,13 @@
           <p:nvPr userDrawn="1"/>
         </p:nvPicPr>
         <p:blipFill>
-          <a:blip r:embed="rId2">
+          <a:blip>
             <a:extLst>
               <a:ext uri="{28A0092B-C50C-407E-A947-70E740481C1C}">
                 <a14:useLocalDpi xmlns:a14="http://schemas.microsoft.com/office/drawing/2010/main" val="0"/>
               </a:ext>
               <a:ext uri="{96DAC541-7B7A-43D3-8B79-37D633B846F1}">
-                <asvg:svgBlip xmlns:asvg="http://schemas.microsoft.com/office/drawing/2016/SVG/main" r:embed="rId3"/>
+                <asvg:svgBlip xmlns:asvg="http://schemas.microsoft.com/office/drawing/2016/SVG/main" r:embed="rId2"/>
               </a:ext>
             </a:extLst>
           </a:blip>
@@ -3473,13 +3815,13 @@
           <p:nvPr userDrawn="1"/>
         </p:nvPicPr>
         <p:blipFill>
-          <a:blip r:embed="rId2">
+          <a:blip>
             <a:extLst>
               <a:ext uri="{28A0092B-C50C-407E-A947-70E740481C1C}">
                 <a14:useLocalDpi xmlns:a14="http://schemas.microsoft.com/office/drawing/2010/main" val="0"/>
               </a:ext>
               <a:ext uri="{96DAC541-7B7A-43D3-8B79-37D633B846F1}">
-                <asvg:svgBlip xmlns:asvg="http://schemas.microsoft.com/office/drawing/2016/SVG/main" r:embed="rId3"/>
+                <asvg:svgBlip xmlns:asvg="http://schemas.microsoft.com/office/drawing/2016/SVG/main" r:embed="rId2"/>
               </a:ext>
             </a:extLst>
           </a:blip>
@@ -3866,13 +4208,13 @@
           <p:nvPr userDrawn="1"/>
         </p:nvPicPr>
         <p:blipFill>
-          <a:blip r:embed="rId2">
+          <a:blip>
             <a:extLst>
               <a:ext uri="{28A0092B-C50C-407E-A947-70E740481C1C}">
                 <a14:useLocalDpi xmlns:a14="http://schemas.microsoft.com/office/drawing/2010/main" val="0"/>
               </a:ext>
               <a:ext uri="{96DAC541-7B7A-43D3-8B79-37D633B846F1}">
-                <asvg:svgBlip xmlns:asvg="http://schemas.microsoft.com/office/drawing/2016/SVG/main" r:embed="rId3"/>
+                <asvg:svgBlip xmlns:asvg="http://schemas.microsoft.com/office/drawing/2016/SVG/main" r:embed="rId2"/>
               </a:ext>
             </a:extLst>
           </a:blip>
@@ -4207,13 +4549,13 @@
           <p:nvPr userDrawn="1"/>
         </p:nvPicPr>
         <p:blipFill>
-          <a:blip r:embed="rId2">
+          <a:blip>
             <a:extLst>
               <a:ext uri="{28A0092B-C50C-407E-A947-70E740481C1C}">
                 <a14:useLocalDpi xmlns:a14="http://schemas.microsoft.com/office/drawing/2010/main" val="0"/>
               </a:ext>
               <a:ext uri="{96DAC541-7B7A-43D3-8B79-37D633B846F1}">
-                <asvg:svgBlip xmlns:asvg="http://schemas.microsoft.com/office/drawing/2016/SVG/main" r:embed="rId3"/>
+                <asvg:svgBlip xmlns:asvg="http://schemas.microsoft.com/office/drawing/2016/SVG/main" r:embed="rId2"/>
               </a:ext>
             </a:extLst>
           </a:blip>
@@ -4584,13 +4926,13 @@
           <p:nvPr userDrawn="1"/>
         </p:nvPicPr>
         <p:blipFill>
-          <a:blip r:embed="rId2">
+          <a:blip>
             <a:extLst>
               <a:ext uri="{28A0092B-C50C-407E-A947-70E740481C1C}">
                 <a14:useLocalDpi xmlns:a14="http://schemas.microsoft.com/office/drawing/2010/main" val="0"/>
               </a:ext>
               <a:ext uri="{96DAC541-7B7A-43D3-8B79-37D633B846F1}">
-                <asvg:svgBlip xmlns:asvg="http://schemas.microsoft.com/office/drawing/2016/SVG/main" r:embed="rId3"/>
+                <asvg:svgBlip xmlns:asvg="http://schemas.microsoft.com/office/drawing/2016/SVG/main" r:embed="rId2"/>
               </a:ext>
             </a:extLst>
           </a:blip>
@@ -5053,7 +5395,7 @@
           <a:p>
             <a:fld id="{5ACA52AF-F19D-405C-AD5F-7D94B96A5CC3}" type="slidenum">
               <a:rPr lang="de-CH" noProof="0" smtClean="0"/>
-              <a:t>‹#›</a:t>
+              <a:t>‹Nr.›</a:t>
             </a:fld>
             <a:endParaRPr lang="de-CH" noProof="0"/>
           </a:p>
@@ -5074,13 +5416,13 @@
           <p:nvPr userDrawn="1"/>
         </p:nvPicPr>
         <p:blipFill>
-          <a:blip r:embed="rId2">
+          <a:blip>
             <a:extLst>
               <a:ext uri="{28A0092B-C50C-407E-A947-70E740481C1C}">
                 <a14:useLocalDpi xmlns:a14="http://schemas.microsoft.com/office/drawing/2010/main" val="0"/>
               </a:ext>
               <a:ext uri="{96DAC541-7B7A-43D3-8B79-37D633B846F1}">
-                <asvg:svgBlip xmlns:asvg="http://schemas.microsoft.com/office/drawing/2016/SVG/main" r:embed="rId3"/>
+                <asvg:svgBlip xmlns:asvg="http://schemas.microsoft.com/office/drawing/2016/SVG/main" r:embed="rId2"/>
               </a:ext>
             </a:extLst>
           </a:blip>
@@ -5296,7 +5638,7 @@
           <a:p>
             <a:fld id="{5ACA52AF-F19D-405C-AD5F-7D94B96A5CC3}" type="slidenum">
               <a:rPr lang="de-CH" noProof="0" smtClean="0"/>
-              <a:t>‹#›</a:t>
+              <a:t>‹Nr.›</a:t>
             </a:fld>
             <a:endParaRPr lang="de-CH" noProof="0"/>
           </a:p>
@@ -5317,13 +5659,13 @@
           <p:nvPr userDrawn="1"/>
         </p:nvPicPr>
         <p:blipFill>
-          <a:blip r:embed="rId2">
+          <a:blip>
             <a:extLst>
               <a:ext uri="{28A0092B-C50C-407E-A947-70E740481C1C}">
                 <a14:useLocalDpi xmlns:a14="http://schemas.microsoft.com/office/drawing/2010/main" val="0"/>
               </a:ext>
               <a:ext uri="{96DAC541-7B7A-43D3-8B79-37D633B846F1}">
-                <asvg:svgBlip xmlns:asvg="http://schemas.microsoft.com/office/drawing/2016/SVG/main" r:embed="rId3"/>
+                <asvg:svgBlip xmlns:asvg="http://schemas.microsoft.com/office/drawing/2016/SVG/main" r:embed="rId2"/>
               </a:ext>
             </a:extLst>
           </a:blip>
@@ -5544,7 +5886,7 @@
           <a:p>
             <a:fld id="{5ACA52AF-F19D-405C-AD5F-7D94B96A5CC3}" type="slidenum">
               <a:rPr lang="de-CH" noProof="0" smtClean="0"/>
-              <a:t>‹#›</a:t>
+              <a:t>‹Nr.›</a:t>
             </a:fld>
             <a:endParaRPr lang="de-CH" noProof="0"/>
           </a:p>
@@ -5565,13 +5907,13 @@
           <p:nvPr userDrawn="1"/>
         </p:nvPicPr>
         <p:blipFill>
-          <a:blip r:embed="rId2">
+          <a:blip>
             <a:extLst>
               <a:ext uri="{28A0092B-C50C-407E-A947-70E740481C1C}">
                 <a14:useLocalDpi xmlns:a14="http://schemas.microsoft.com/office/drawing/2010/main" val="0"/>
               </a:ext>
               <a:ext uri="{96DAC541-7B7A-43D3-8B79-37D633B846F1}">
-                <asvg:svgBlip xmlns:asvg="http://schemas.microsoft.com/office/drawing/2016/SVG/main" r:embed="rId3"/>
+                <asvg:svgBlip xmlns:asvg="http://schemas.microsoft.com/office/drawing/2016/SVG/main" r:embed="rId2"/>
               </a:ext>
             </a:extLst>
           </a:blip>
@@ -5837,7 +6179,7 @@
             <a:fld id="{5ACA52AF-F19D-405C-AD5F-7D94B96A5CC3}" type="slidenum">
               <a:rPr lang="de-CH" noProof="0" smtClean="0"/>
               <a:pPr/>
-              <a:t>‹#›</a:t>
+              <a:t>‹Nr.›</a:t>
             </a:fld>
             <a:endParaRPr lang="de-CH" noProof="0"/>
           </a:p>
@@ -7780,7 +8122,7 @@
             <a:fld id="{5ACA52AF-F19D-405C-AD5F-7D94B96A5CC3}" type="slidenum">
               <a:rPr lang="de-CH" noProof="0" smtClean="0"/>
               <a:pPr/>
-              <a:t>‹#›</a:t>
+              <a:t>‹Nr.›</a:t>
             </a:fld>
             <a:endParaRPr lang="de-CH" noProof="0"/>
           </a:p>
@@ -8344,6 +8686,667 @@
   <p:cSld>
     <p:spTree>
       <p:nvGrpSpPr>
+        <p:cNvPr id="1" name=""/>
+        <p:cNvGrpSpPr/>
+        <p:nvPr/>
+      </p:nvGrpSpPr>
+      <p:grpSpPr>
+        <a:xfrm>
+          <a:off x="0" y="0"/>
+          <a:ext cx="0" cy="0"/>
+          <a:chOff x="0" y="0"/>
+          <a:chExt cx="0" cy="0"/>
+        </a:xfrm>
+      </p:grpSpPr>
+      <p:sp>
+        <p:nvSpPr>
+          <p:cNvPr id="2" name="Titel 1">
+            <a:extLst>
+              <a:ext uri="{FF2B5EF4-FFF2-40B4-BE49-F238E27FC236}">
+                <a16:creationId xmlns:a16="http://schemas.microsoft.com/office/drawing/2014/main" id="{AD59CF38-73BF-14E6-D6D6-89219DE0D4E2}"/>
+              </a:ext>
+            </a:extLst>
+          </p:cNvPr>
+          <p:cNvSpPr>
+            <a:spLocks noGrp="1"/>
+          </p:cNvSpPr>
+          <p:nvPr>
+            <p:ph type="title"/>
+          </p:nvPr>
+        </p:nvSpPr>
+        <p:spPr>
+          <a:xfrm>
+            <a:off x="731837" y="260351"/>
+            <a:ext cx="10728325" cy="900000"/>
+          </a:xfrm>
+        </p:spPr>
+        <p:txBody>
+          <a:bodyPr anchor="t">
+            <a:normAutofit/>
+          </a:bodyPr>
+          <a:lstStyle/>
+          <a:p>
+            <a:r>
+              <a:rPr lang="en-US" dirty="0"/>
+              <a:t>Time-Based Validation Strategy for CLV Prediction</a:t>
+            </a:r>
+          </a:p>
+        </p:txBody>
+      </p:sp>
+      <p:pic>
+        <p:nvPicPr>
+          <p:cNvPr id="8" name="Inhaltsplatzhalter 7">
+            <a:extLst>
+              <a:ext uri="{FF2B5EF4-FFF2-40B4-BE49-F238E27FC236}">
+                <a16:creationId xmlns:a16="http://schemas.microsoft.com/office/drawing/2014/main" id="{85806576-01BD-1368-3251-24A99FBA6D6C}"/>
+              </a:ext>
+            </a:extLst>
+          </p:cNvPr>
+          <p:cNvPicPr>
+            <a:picLocks noGrp="1" noChangeAspect="1"/>
+          </p:cNvPicPr>
+          <p:nvPr>
+            <p:ph idx="1"/>
+          </p:nvPr>
+        </p:nvPicPr>
+        <p:blipFill>
+          <a:blip r:embed="rId3"/>
+          <a:srcRect r="283" b="2"/>
+          <a:stretch>
+            <a:fillRect/>
+          </a:stretch>
+        </p:blipFill>
+        <p:spPr>
+          <a:xfrm>
+            <a:off x="731835" y="1303219"/>
+            <a:ext cx="5017325" cy="2188699"/>
+          </a:xfrm>
+          <a:prstGeom prst="rect">
+            <a:avLst/>
+          </a:prstGeom>
+          <a:noFill/>
+        </p:spPr>
+      </p:pic>
+      <p:sp>
+        <p:nvSpPr>
+          <p:cNvPr id="4" name="Datumsplatzhalter 3">
+            <a:extLst>
+              <a:ext uri="{FF2B5EF4-FFF2-40B4-BE49-F238E27FC236}">
+                <a16:creationId xmlns:a16="http://schemas.microsoft.com/office/drawing/2014/main" id="{1241F404-3525-32B2-7EDA-5192C37A5CE3}"/>
+              </a:ext>
+            </a:extLst>
+          </p:cNvPr>
+          <p:cNvSpPr>
+            <a:spLocks noGrp="1"/>
+          </p:cNvSpPr>
+          <p:nvPr>
+            <p:ph type="dt" sz="half" idx="10"/>
+          </p:nvPr>
+        </p:nvSpPr>
+        <p:spPr>
+          <a:xfrm>
+            <a:off x="10473692" y="6522444"/>
+            <a:ext cx="612000" cy="216000"/>
+          </a:xfrm>
+        </p:spPr>
+        <p:txBody>
+          <a:bodyPr anchor="ctr">
+            <a:normAutofit/>
+          </a:bodyPr>
+          <a:lstStyle/>
+          <a:p>
+            <a:pPr>
+              <a:spcAft>
+                <a:spcPts val="600"/>
+              </a:spcAft>
+            </a:pPr>
+            <a:fld id="{11B96697-4585-4368-989A-16003D150648}" type="datetime1">
+              <a:rPr lang="de-CH" noProof="0" smtClean="0"/>
+              <a:pPr>
+                <a:spcAft>
+                  <a:spcPts val="600"/>
+                </a:spcAft>
+              </a:pPr>
+              <a:t>25.03.2026</a:t>
+            </a:fld>
+            <a:endParaRPr lang="de-CH" noProof="0"/>
+          </a:p>
+        </p:txBody>
+      </p:sp>
+      <p:sp>
+        <p:nvSpPr>
+          <p:cNvPr id="5" name="Fußzeilenplatzhalter 4">
+            <a:extLst>
+              <a:ext uri="{FF2B5EF4-FFF2-40B4-BE49-F238E27FC236}">
+                <a16:creationId xmlns:a16="http://schemas.microsoft.com/office/drawing/2014/main" id="{FE4B1234-E164-FC6C-DAFC-6074E7974189}"/>
+              </a:ext>
+            </a:extLst>
+          </p:cNvPr>
+          <p:cNvSpPr>
+            <a:spLocks noGrp="1"/>
+          </p:cNvSpPr>
+          <p:nvPr>
+            <p:ph type="ftr" sz="quarter" idx="11"/>
+          </p:nvPr>
+        </p:nvSpPr>
+        <p:spPr>
+          <a:xfrm>
+            <a:off x="2171700" y="6522444"/>
+            <a:ext cx="5400000" cy="216000"/>
+          </a:xfrm>
+        </p:spPr>
+        <p:txBody>
+          <a:bodyPr anchor="ctr">
+            <a:normAutofit/>
+          </a:bodyPr>
+          <a:lstStyle/>
+          <a:p>
+            <a:pPr>
+              <a:spcAft>
+                <a:spcPts val="600"/>
+              </a:spcAft>
+            </a:pPr>
+            <a:r>
+              <a:rPr lang="de-DE" noProof="0"/>
+              <a:t>Organisationseinheit verbal</a:t>
+            </a:r>
+            <a:endParaRPr lang="de-CH" noProof="0"/>
+          </a:p>
+        </p:txBody>
+      </p:sp>
+      <p:sp>
+        <p:nvSpPr>
+          <p:cNvPr id="6" name="Foliennummernplatzhalter 5">
+            <a:extLst>
+              <a:ext uri="{FF2B5EF4-FFF2-40B4-BE49-F238E27FC236}">
+                <a16:creationId xmlns:a16="http://schemas.microsoft.com/office/drawing/2014/main" id="{2BA976B1-562C-68B6-998A-659638C4C22D}"/>
+              </a:ext>
+            </a:extLst>
+          </p:cNvPr>
+          <p:cNvSpPr>
+            <a:spLocks noGrp="1"/>
+          </p:cNvSpPr>
+          <p:nvPr>
+            <p:ph type="sldNum" sz="quarter" idx="12"/>
+          </p:nvPr>
+        </p:nvSpPr>
+        <p:spPr>
+          <a:xfrm>
+            <a:off x="11137585" y="6522444"/>
+            <a:ext cx="322577" cy="216000"/>
+          </a:xfrm>
+        </p:spPr>
+        <p:txBody>
+          <a:bodyPr anchor="ctr">
+            <a:normAutofit/>
+          </a:bodyPr>
+          <a:lstStyle/>
+          <a:p>
+            <a:pPr>
+              <a:spcAft>
+                <a:spcPts val="600"/>
+              </a:spcAft>
+            </a:pPr>
+            <a:fld id="{5ACA52AF-F19D-405C-AD5F-7D94B96A5CC3}" type="slidenum">
+              <a:rPr lang="de-CH" noProof="0" smtClean="0"/>
+              <a:pPr>
+                <a:spcAft>
+                  <a:spcPts val="600"/>
+                </a:spcAft>
+              </a:pPr>
+              <a:t>2</a:t>
+            </a:fld>
+            <a:endParaRPr lang="de-CH" noProof="0"/>
+          </a:p>
+        </p:txBody>
+      </p:sp>
+      <p:pic>
+        <p:nvPicPr>
+          <p:cNvPr id="10" name="Grafik 9">
+            <a:extLst>
+              <a:ext uri="{FF2B5EF4-FFF2-40B4-BE49-F238E27FC236}">
+                <a16:creationId xmlns:a16="http://schemas.microsoft.com/office/drawing/2014/main" id="{5A19BDA3-86A0-B299-B5FD-E9084E8C001C}"/>
+              </a:ext>
+            </a:extLst>
+          </p:cNvPr>
+          <p:cNvPicPr>
+            <a:picLocks noChangeAspect="1"/>
+          </p:cNvPicPr>
+          <p:nvPr/>
+        </p:nvPicPr>
+        <p:blipFill>
+          <a:blip r:embed="rId4"/>
+          <a:stretch>
+            <a:fillRect/>
+          </a:stretch>
+        </p:blipFill>
+        <p:spPr>
+          <a:xfrm>
+            <a:off x="731835" y="3535404"/>
+            <a:ext cx="5017324" cy="2177330"/>
+          </a:xfrm>
+          <a:prstGeom prst="rect">
+            <a:avLst/>
+          </a:prstGeom>
+        </p:spPr>
+      </p:pic>
+      <p:sp>
+        <p:nvSpPr>
+          <p:cNvPr id="11" name="Textfeld 10">
+            <a:extLst>
+              <a:ext uri="{FF2B5EF4-FFF2-40B4-BE49-F238E27FC236}">
+                <a16:creationId xmlns:a16="http://schemas.microsoft.com/office/drawing/2014/main" id="{11ADD9EB-ECBE-BFB4-5C5C-C1BF8FEC3DCC}"/>
+              </a:ext>
+            </a:extLst>
+          </p:cNvPr>
+          <p:cNvSpPr txBox="1"/>
+          <p:nvPr/>
+        </p:nvSpPr>
+        <p:spPr>
+          <a:xfrm>
+            <a:off x="731836" y="837852"/>
+            <a:ext cx="5017324" cy="369332"/>
+          </a:xfrm>
+          <a:prstGeom prst="rect">
+            <a:avLst/>
+          </a:prstGeom>
+          <a:solidFill>
+            <a:srgbClr val="215CAF"/>
+          </a:solidFill>
+        </p:spPr>
+        <p:txBody>
+          <a:bodyPr wrap="square" rtlCol="0">
+            <a:spAutoFit/>
+          </a:bodyPr>
+          <a:lstStyle/>
+          <a:p>
+            <a:pPr algn="ctr"/>
+            <a:r>
+              <a:rPr lang="de-DE" dirty="0">
+                <a:solidFill>
+                  <a:schemeClr val="bg1"/>
+                </a:solidFill>
+              </a:rPr>
+              <a:t>Data Analysis</a:t>
+            </a:r>
+            <a:endParaRPr lang="en-US" dirty="0">
+              <a:solidFill>
+                <a:schemeClr val="bg1"/>
+              </a:solidFill>
+            </a:endParaRPr>
+          </a:p>
+        </p:txBody>
+      </p:sp>
+      <p:sp>
+        <p:nvSpPr>
+          <p:cNvPr id="12" name="Textfeld 11">
+            <a:extLst>
+              <a:ext uri="{FF2B5EF4-FFF2-40B4-BE49-F238E27FC236}">
+                <a16:creationId xmlns:a16="http://schemas.microsoft.com/office/drawing/2014/main" id="{1B5D105C-3E82-A1E7-16F5-F1FF44791031}"/>
+              </a:ext>
+            </a:extLst>
+          </p:cNvPr>
+          <p:cNvSpPr txBox="1"/>
+          <p:nvPr/>
+        </p:nvSpPr>
+        <p:spPr>
+          <a:xfrm>
+            <a:off x="6442838" y="837852"/>
+            <a:ext cx="5017324" cy="369332"/>
+          </a:xfrm>
+          <a:prstGeom prst="rect">
+            <a:avLst/>
+          </a:prstGeom>
+          <a:solidFill>
+            <a:srgbClr val="215CAF"/>
+          </a:solidFill>
+        </p:spPr>
+        <p:txBody>
+          <a:bodyPr wrap="square" rtlCol="0">
+            <a:spAutoFit/>
+          </a:bodyPr>
+          <a:lstStyle/>
+          <a:p>
+            <a:pPr algn="ctr"/>
+            <a:r>
+              <a:rPr lang="de-DE" dirty="0">
+                <a:solidFill>
+                  <a:schemeClr val="bg1"/>
+                </a:solidFill>
+              </a:rPr>
+              <a:t>Train-test </a:t>
+            </a:r>
+            <a:r>
+              <a:rPr lang="de-DE" dirty="0" err="1">
+                <a:solidFill>
+                  <a:schemeClr val="bg1"/>
+                </a:solidFill>
+              </a:rPr>
+              <a:t>split</a:t>
+            </a:r>
+            <a:endParaRPr lang="en-US" dirty="0">
+              <a:solidFill>
+                <a:schemeClr val="bg1"/>
+              </a:solidFill>
+            </a:endParaRPr>
+          </a:p>
+        </p:txBody>
+      </p:sp>
+      <p:sp>
+        <p:nvSpPr>
+          <p:cNvPr id="13" name="Textfeld 12">
+            <a:extLst>
+              <a:ext uri="{FF2B5EF4-FFF2-40B4-BE49-F238E27FC236}">
+                <a16:creationId xmlns:a16="http://schemas.microsoft.com/office/drawing/2014/main" id="{80C11ECE-32CA-9E14-57D2-2CBB7566D165}"/>
+              </a:ext>
+            </a:extLst>
+          </p:cNvPr>
+          <p:cNvSpPr txBox="1"/>
+          <p:nvPr/>
+        </p:nvSpPr>
+        <p:spPr>
+          <a:xfrm>
+            <a:off x="767672" y="5792832"/>
+            <a:ext cx="5017324" cy="523220"/>
+          </a:xfrm>
+          <a:prstGeom prst="rect">
+            <a:avLst/>
+          </a:prstGeom>
+          <a:noFill/>
+        </p:spPr>
+        <p:txBody>
+          <a:bodyPr wrap="square" rtlCol="0">
+            <a:spAutoFit/>
+          </a:bodyPr>
+          <a:lstStyle/>
+          <a:p>
+            <a:pPr marL="285750" indent="-285750">
+              <a:buFont typeface="Wingdings" panose="05000000000000000000" pitchFamily="2" charset="2"/>
+              <a:buChar char="Ø"/>
+            </a:pPr>
+            <a:r>
+              <a:rPr lang="de-DE" sz="1400" dirty="0"/>
+              <a:t>Plots </a:t>
+            </a:r>
+            <a:r>
+              <a:rPr lang="de-DE" sz="1400" dirty="0" err="1"/>
+              <a:t>reveal</a:t>
+            </a:r>
+            <a:r>
+              <a:rPr lang="de-DE" sz="1400" dirty="0"/>
+              <a:t> a </a:t>
+            </a:r>
+            <a:r>
+              <a:rPr lang="de-DE" sz="1400" b="1" dirty="0" err="1"/>
+              <a:t>structural</a:t>
+            </a:r>
+            <a:r>
+              <a:rPr lang="de-DE" sz="1400" b="1" dirty="0"/>
+              <a:t> break</a:t>
+            </a:r>
+            <a:r>
+              <a:rPr lang="de-DE" sz="1400" dirty="0"/>
+              <a:t> in </a:t>
+            </a:r>
+            <a:r>
+              <a:rPr lang="de-DE" sz="1400" dirty="0" err="1"/>
+              <a:t>consumer</a:t>
+            </a:r>
+            <a:r>
+              <a:rPr lang="de-DE" sz="1400" dirty="0"/>
+              <a:t> </a:t>
+            </a:r>
+            <a:r>
+              <a:rPr lang="de-DE" sz="1400" dirty="0" err="1"/>
+              <a:t>behavior</a:t>
+            </a:r>
+            <a:r>
+              <a:rPr lang="de-DE" sz="1400" dirty="0"/>
+              <a:t> </a:t>
+            </a:r>
+            <a:r>
+              <a:rPr lang="de-DE" sz="1400" dirty="0" err="1"/>
+              <a:t>starting</a:t>
+            </a:r>
+            <a:r>
+              <a:rPr lang="de-DE" sz="1400" dirty="0"/>
+              <a:t> April 2020</a:t>
+            </a:r>
+            <a:endParaRPr lang="en-US" sz="1400" dirty="0"/>
+          </a:p>
+        </p:txBody>
+      </p:sp>
+      <p:pic>
+        <p:nvPicPr>
+          <p:cNvPr id="53" name="Grafik 52">
+            <a:extLst>
+              <a:ext uri="{FF2B5EF4-FFF2-40B4-BE49-F238E27FC236}">
+                <a16:creationId xmlns:a16="http://schemas.microsoft.com/office/drawing/2014/main" id="{5875D0B7-E59C-033E-8563-2C696D7C7B9D}"/>
+              </a:ext>
+            </a:extLst>
+          </p:cNvPr>
+          <p:cNvPicPr>
+            <a:picLocks noChangeAspect="1"/>
+          </p:cNvPicPr>
+          <p:nvPr/>
+        </p:nvPicPr>
+        <p:blipFill>
+          <a:blip r:embed="rId5"/>
+          <a:srcRect t="42607" b="25369"/>
+          <a:stretch>
+            <a:fillRect/>
+          </a:stretch>
+        </p:blipFill>
+        <p:spPr>
+          <a:xfrm>
+            <a:off x="6575873" y="4526324"/>
+            <a:ext cx="4751254" cy="1163312"/>
+          </a:xfrm>
+          <a:prstGeom prst="rect">
+            <a:avLst/>
+          </a:prstGeom>
+        </p:spPr>
+      </p:pic>
+      <p:sp>
+        <p:nvSpPr>
+          <p:cNvPr id="55" name="Textfeld 54">
+            <a:extLst>
+              <a:ext uri="{FF2B5EF4-FFF2-40B4-BE49-F238E27FC236}">
+                <a16:creationId xmlns:a16="http://schemas.microsoft.com/office/drawing/2014/main" id="{E3466438-2397-5171-233F-C2CFC72E4EA6}"/>
+              </a:ext>
+            </a:extLst>
+          </p:cNvPr>
+          <p:cNvSpPr txBox="1"/>
+          <p:nvPr/>
+        </p:nvSpPr>
+        <p:spPr>
+          <a:xfrm>
+            <a:off x="6442838" y="1366743"/>
+            <a:ext cx="5017324" cy="3062377"/>
+          </a:xfrm>
+          <a:prstGeom prst="rect">
+            <a:avLst/>
+          </a:prstGeom>
+          <a:noFill/>
+        </p:spPr>
+        <p:txBody>
+          <a:bodyPr wrap="square" rtlCol="0">
+            <a:spAutoFit/>
+          </a:bodyPr>
+          <a:lstStyle/>
+          <a:p>
+            <a:pPr marL="285750" indent="-285750">
+              <a:spcAft>
+                <a:spcPts val="600"/>
+              </a:spcAft>
+              <a:buFont typeface="Arial" panose="020B0604020202020204" pitchFamily="34" charset="0"/>
+              <a:buChar char="•"/>
+            </a:pPr>
+            <a:r>
+              <a:rPr lang="de-DE" sz="1400" dirty="0"/>
+              <a:t>F</a:t>
+            </a:r>
+            <a:r>
+              <a:rPr lang="en-US" sz="1400" dirty="0" err="1"/>
+              <a:t>ocus</a:t>
+            </a:r>
+            <a:r>
+              <a:rPr lang="en-US" sz="1400" dirty="0"/>
+              <a:t> on </a:t>
+            </a:r>
+            <a:r>
+              <a:rPr lang="en-US" sz="1400" b="1" dirty="0"/>
+              <a:t>post-behavioral shift period (Apr 2020 onward)</a:t>
+            </a:r>
+            <a:r>
+              <a:rPr lang="en-US" sz="1400" dirty="0"/>
+              <a:t> to ensure consistent customer dynamics</a:t>
+            </a:r>
+          </a:p>
+          <a:p>
+            <a:pPr marL="285750" indent="-285750">
+              <a:spcAft>
+                <a:spcPts val="600"/>
+              </a:spcAft>
+              <a:buFont typeface="Arial" panose="020B0604020202020204" pitchFamily="34" charset="0"/>
+              <a:buChar char="•"/>
+            </a:pPr>
+            <a:r>
+              <a:rPr lang="en-US" sz="1400" b="1" dirty="0"/>
+              <a:t>Forward-chaining validation (2 folds)</a:t>
+            </a:r>
+            <a:r>
+              <a:rPr lang="en-US" sz="1400" dirty="0"/>
+              <a:t> tests model stability across time</a:t>
+            </a:r>
+          </a:p>
+          <a:p>
+            <a:pPr marL="742950" lvl="1" indent="-285750">
+              <a:spcAft>
+                <a:spcPts val="600"/>
+              </a:spcAft>
+              <a:buFont typeface="Wingdings" panose="05000000000000000000" pitchFamily="2" charset="2"/>
+              <a:buChar char="§"/>
+            </a:pPr>
+            <a:r>
+              <a:rPr lang="en-US" sz="1400" dirty="0"/>
+              <a:t>Fold 1 (consistency check): </a:t>
+            </a:r>
+            <a:r>
+              <a:rPr lang="en-US" sz="1400" i="1" dirty="0"/>
+              <a:t>Can the model generalize to unseen data before the final period?</a:t>
+            </a:r>
+          </a:p>
+          <a:p>
+            <a:pPr marL="742950" lvl="1" indent="-285750">
+              <a:spcAft>
+                <a:spcPts val="600"/>
+              </a:spcAft>
+              <a:buFont typeface="Wingdings" panose="05000000000000000000" pitchFamily="2" charset="2"/>
+              <a:buChar char="§"/>
+            </a:pPr>
+            <a:r>
+              <a:rPr lang="en-US" sz="1400" dirty="0"/>
+              <a:t>Fold 2 (main validation): </a:t>
+            </a:r>
+            <a:r>
+              <a:rPr lang="en-US" sz="1400" i="1" dirty="0"/>
+              <a:t>Does the model work in the most recent, most relevant period?</a:t>
+            </a:r>
+            <a:r>
+              <a:rPr lang="en-US" sz="1400" dirty="0"/>
+              <a:t> </a:t>
+            </a:r>
+          </a:p>
+          <a:p>
+            <a:pPr marL="285750" indent="-285750">
+              <a:spcAft>
+                <a:spcPts val="600"/>
+              </a:spcAft>
+              <a:buFont typeface="Arial" panose="020B0604020202020204" pitchFamily="34" charset="0"/>
+              <a:buChar char="•"/>
+            </a:pPr>
+            <a:r>
+              <a:rPr lang="en-US" sz="1400" dirty="0"/>
+              <a:t>Consistent performance across folds → reliable generalization to unseen period</a:t>
+            </a:r>
+          </a:p>
+          <a:p>
+            <a:pPr marL="742950" lvl="1" indent="-285750">
+              <a:spcAft>
+                <a:spcPts val="600"/>
+              </a:spcAft>
+              <a:buFont typeface="Wingdings" panose="05000000000000000000" pitchFamily="2" charset="2"/>
+              <a:buChar char="§"/>
+            </a:pPr>
+            <a:r>
+              <a:rPr lang="en-US" sz="1400" dirty="0"/>
+              <a:t>With expanded historical data, Fold 2 is expected to match or exceed baseline performance</a:t>
+            </a:r>
+          </a:p>
+        </p:txBody>
+      </p:sp>
+      <p:sp>
+        <p:nvSpPr>
+          <p:cNvPr id="58" name="Textfeld 57">
+            <a:extLst>
+              <a:ext uri="{FF2B5EF4-FFF2-40B4-BE49-F238E27FC236}">
+                <a16:creationId xmlns:a16="http://schemas.microsoft.com/office/drawing/2014/main" id="{F64E5EFB-5C74-FDBA-3ED0-3F45AEF0D1F2}"/>
+              </a:ext>
+            </a:extLst>
+          </p:cNvPr>
+          <p:cNvSpPr txBox="1"/>
+          <p:nvPr/>
+        </p:nvSpPr>
+        <p:spPr>
+          <a:xfrm>
+            <a:off x="6442838" y="5792832"/>
+            <a:ext cx="5017324" cy="523220"/>
+          </a:xfrm>
+          <a:prstGeom prst="rect">
+            <a:avLst/>
+          </a:prstGeom>
+          <a:noFill/>
+        </p:spPr>
+        <p:txBody>
+          <a:bodyPr wrap="square" rtlCol="0">
+            <a:spAutoFit/>
+          </a:bodyPr>
+          <a:lstStyle/>
+          <a:p>
+            <a:pPr marL="285750" indent="-285750">
+              <a:buFont typeface="Wingdings" panose="05000000000000000000" pitchFamily="2" charset="2"/>
+              <a:buChar char="Ø"/>
+            </a:pPr>
+            <a:r>
+              <a:rPr lang="en-US" sz="1400" dirty="0"/>
+              <a:t>Final model predicts CLV for Sep 2023 – Sep 2024 using </a:t>
+            </a:r>
+            <a:r>
+              <a:rPr lang="en-US" sz="1400" b="1" dirty="0"/>
+              <a:t>all available stable data</a:t>
+            </a:r>
+          </a:p>
+        </p:txBody>
+      </p:sp>
+    </p:spTree>
+    <p:extLst>
+      <p:ext uri="{BB962C8B-B14F-4D97-AF65-F5344CB8AC3E}">
+        <p14:creationId xmlns:p14="http://schemas.microsoft.com/office/powerpoint/2010/main" val="280782846"/>
+      </p:ext>
+    </p:extLst>
+  </p:cSld>
+  <p:clrMapOvr>
+    <a:masterClrMapping/>
+  </p:clrMapOvr>
+</p:sld>
+</file>
+
+<file path=ppt/slides/slide3.xml><?xml version="1.0" encoding="utf-8"?>
+<p:sld xmlns:a="http://schemas.openxmlformats.org/drawingml/2006/main" xmlns:r="http://schemas.openxmlformats.org/officeDocument/2006/relationships" xmlns:p="http://schemas.openxmlformats.org/presentationml/2006/main">
+  <p:cSld>
+    <p:spTree>
+      <p:nvGrpSpPr>
         <p:cNvPr id="1" name="">
           <a:extLst>
             <a:ext uri="{FF2B5EF4-FFF2-40B4-BE49-F238E27FC236}">
@@ -8442,7 +9445,7 @@
           <a:p>
             <a:fld id="{5ACA52AF-F19D-405C-AD5F-7D94B96A5CC3}" type="slidenum">
               <a:rPr lang="de-CH" noProof="0" smtClean="0"/>
-              <a:t>2</a:t>
+              <a:t>3</a:t>
             </a:fld>
             <a:endParaRPr lang="de-CH" noProof="0"/>
           </a:p>
@@ -9959,308 +10962,6 @@
     <p:extLst>
       <p:ext uri="{BB962C8B-B14F-4D97-AF65-F5344CB8AC3E}">
         <p14:creationId xmlns:p14="http://schemas.microsoft.com/office/powerpoint/2010/main" val="2995642186"/>
-      </p:ext>
-    </p:extLst>
-  </p:cSld>
-  <p:clrMapOvr>
-    <a:masterClrMapping/>
-  </p:clrMapOvr>
-</p:sld>
-</file>
-
-<file path=ppt/slides/slide3.xml><?xml version="1.0" encoding="utf-8"?>
-<p:sld xmlns:a="http://schemas.openxmlformats.org/drawingml/2006/main" xmlns:r="http://schemas.openxmlformats.org/officeDocument/2006/relationships" xmlns:p="http://schemas.openxmlformats.org/presentationml/2006/main">
-  <p:cSld>
-    <p:spTree>
-      <p:nvGrpSpPr>
-        <p:cNvPr id="1" name=""/>
-        <p:cNvGrpSpPr/>
-        <p:nvPr/>
-      </p:nvGrpSpPr>
-      <p:grpSpPr>
-        <a:xfrm>
-          <a:off x="0" y="0"/>
-          <a:ext cx="0" cy="0"/>
-          <a:chOff x="0" y="0"/>
-          <a:chExt cx="0" cy="0"/>
-        </a:xfrm>
-      </p:grpSpPr>
-      <p:sp>
-        <p:nvSpPr>
-          <p:cNvPr id="2" name="Titel 1">
-            <a:extLst>
-              <a:ext uri="{FF2B5EF4-FFF2-40B4-BE49-F238E27FC236}">
-                <a16:creationId xmlns:a16="http://schemas.microsoft.com/office/drawing/2014/main" id="{2BA7B57A-EDA6-909B-2745-CEECB32A3245}"/>
-              </a:ext>
-            </a:extLst>
-          </p:cNvPr>
-          <p:cNvSpPr>
-            <a:spLocks noGrp="1"/>
-          </p:cNvSpPr>
-          <p:nvPr>
-            <p:ph type="title"/>
-          </p:nvPr>
-        </p:nvSpPr>
-        <p:spPr/>
-        <p:txBody>
-          <a:bodyPr/>
-          <a:lstStyle/>
-          <a:p>
-            <a:r>
-              <a:rPr lang="de-DE" dirty="0"/>
-              <a:t>Cluster Interpretation</a:t>
-            </a:r>
-            <a:br>
-              <a:rPr lang="de-DE" dirty="0"/>
-            </a:br>
-            <a:r>
-              <a:rPr lang="de-DE" sz="800" dirty="0">
-                <a:solidFill>
-                  <a:schemeClr val="bg1"/>
-                </a:solidFill>
-              </a:rPr>
-              <a:t>a</a:t>
-            </a:r>
-            <a:br>
-              <a:rPr lang="de-DE" dirty="0"/>
-            </a:br>
-            <a:r>
-              <a:rPr lang="en-US" sz="2000" dirty="0"/>
-              <a:t>Cross-referencing predicted clusters with manual category tags validates the model's high semantic accuracy.</a:t>
-            </a:r>
-          </a:p>
-        </p:txBody>
-      </p:sp>
-      <p:sp>
-        <p:nvSpPr>
-          <p:cNvPr id="4" name="Datumsplatzhalter 3">
-            <a:extLst>
-              <a:ext uri="{FF2B5EF4-FFF2-40B4-BE49-F238E27FC236}">
-                <a16:creationId xmlns:a16="http://schemas.microsoft.com/office/drawing/2014/main" id="{00BCE553-DE36-0EB6-BE5C-43E0D2EDCCC0}"/>
-              </a:ext>
-            </a:extLst>
-          </p:cNvPr>
-          <p:cNvSpPr>
-            <a:spLocks noGrp="1"/>
-          </p:cNvSpPr>
-          <p:nvPr>
-            <p:ph type="dt" sz="half" idx="10"/>
-          </p:nvPr>
-        </p:nvSpPr>
-        <p:spPr/>
-        <p:txBody>
-          <a:bodyPr/>
-          <a:lstStyle/>
-          <a:p>
-            <a:fld id="{0F7782B2-018B-4FD3-AD95-2F64EDE0E9D6}" type="datetime1">
-              <a:rPr lang="de-CH" noProof="0" smtClean="0"/>
-              <a:t>25.03.2026</a:t>
-            </a:fld>
-            <a:endParaRPr lang="de-CH" noProof="0"/>
-          </a:p>
-        </p:txBody>
-      </p:sp>
-      <p:sp>
-        <p:nvSpPr>
-          <p:cNvPr id="5" name="Fußzeilenplatzhalter 4">
-            <a:extLst>
-              <a:ext uri="{FF2B5EF4-FFF2-40B4-BE49-F238E27FC236}">
-                <a16:creationId xmlns:a16="http://schemas.microsoft.com/office/drawing/2014/main" id="{21218AD0-A83F-EA78-9FFA-E8C0815DF04B}"/>
-              </a:ext>
-            </a:extLst>
-          </p:cNvPr>
-          <p:cNvSpPr>
-            <a:spLocks noGrp="1"/>
-          </p:cNvSpPr>
-          <p:nvPr>
-            <p:ph type="ftr" sz="quarter" idx="11"/>
-          </p:nvPr>
-        </p:nvSpPr>
-        <p:spPr/>
-        <p:txBody>
-          <a:bodyPr/>
-          <a:lstStyle/>
-          <a:p>
-            <a:endParaRPr lang="de-CH" noProof="0" dirty="0"/>
-          </a:p>
-        </p:txBody>
-      </p:sp>
-      <p:sp>
-        <p:nvSpPr>
-          <p:cNvPr id="6" name="Foliennummernplatzhalter 5">
-            <a:extLst>
-              <a:ext uri="{FF2B5EF4-FFF2-40B4-BE49-F238E27FC236}">
-                <a16:creationId xmlns:a16="http://schemas.microsoft.com/office/drawing/2014/main" id="{05BDADE5-00DA-D112-E3B5-6CDEEE55849F}"/>
-              </a:ext>
-            </a:extLst>
-          </p:cNvPr>
-          <p:cNvSpPr>
-            <a:spLocks noGrp="1"/>
-          </p:cNvSpPr>
-          <p:nvPr>
-            <p:ph type="sldNum" sz="quarter" idx="12"/>
-          </p:nvPr>
-        </p:nvSpPr>
-        <p:spPr/>
-        <p:txBody>
-          <a:bodyPr/>
-          <a:lstStyle/>
-          <a:p>
-            <a:fld id="{5ACA52AF-F19D-405C-AD5F-7D94B96A5CC3}" type="slidenum">
-              <a:rPr lang="de-CH" noProof="0" smtClean="0"/>
-              <a:t>3</a:t>
-            </a:fld>
-            <a:endParaRPr lang="de-CH" noProof="0"/>
-          </a:p>
-        </p:txBody>
-      </p:sp>
-      <p:grpSp>
-        <p:nvGrpSpPr>
-          <p:cNvPr id="3" name="Gruppieren 2">
-            <a:extLst>
-              <a:ext uri="{FF2B5EF4-FFF2-40B4-BE49-F238E27FC236}">
-                <a16:creationId xmlns:a16="http://schemas.microsoft.com/office/drawing/2014/main" id="{8711214C-5C6A-70F4-D4EB-661599A6E23E}"/>
-              </a:ext>
-            </a:extLst>
-          </p:cNvPr>
-          <p:cNvGrpSpPr>
-            <a:grpSpLocks noChangeAspect="1"/>
-          </p:cNvGrpSpPr>
-          <p:nvPr/>
-        </p:nvGrpSpPr>
-        <p:grpSpPr>
-          <a:xfrm>
-            <a:off x="731837" y="1324528"/>
-            <a:ext cx="5072742" cy="5152342"/>
-            <a:chOff x="482874" y="710351"/>
-            <a:chExt cx="5613125" cy="5701204"/>
-          </a:xfrm>
-        </p:grpSpPr>
-        <p:pic>
-          <p:nvPicPr>
-            <p:cNvPr id="21" name="Grafik 20" descr="Ein Bild, das Screenshot, Design enthält.&#10;&#10;KI-generierte Inhalte können fehlerhaft sein.">
-              <a:extLst>
-                <a:ext uri="{FF2B5EF4-FFF2-40B4-BE49-F238E27FC236}">
-                  <a16:creationId xmlns:a16="http://schemas.microsoft.com/office/drawing/2014/main" id="{1A45BBD7-4CE0-BDFD-F46E-5B4731E31A0F}"/>
-                </a:ext>
-              </a:extLst>
-            </p:cNvPr>
-            <p:cNvPicPr>
-              <a:picLocks noChangeAspect="1"/>
-            </p:cNvPicPr>
-            <p:nvPr/>
-          </p:nvPicPr>
-          <p:blipFill>
-            <a:blip r:embed="rId3"/>
-            <a:stretch>
-              <a:fillRect/>
-            </a:stretch>
-          </p:blipFill>
-          <p:spPr>
-            <a:xfrm>
-              <a:off x="1023936" y="4497030"/>
-              <a:ext cx="4638675" cy="1914525"/>
-            </a:xfrm>
-            <a:prstGeom prst="rect">
-              <a:avLst/>
-            </a:prstGeom>
-          </p:spPr>
-        </p:pic>
-        <p:pic>
-          <p:nvPicPr>
-            <p:cNvPr id="32" name="Grafik 31" descr="Ein Bild, das Zubehör, Handtasche, Tasche, Gepäck und Koffer enthält.&#10;&#10;KI-generierte Inhalte können fehlerhaft sein.">
-              <a:extLst>
-                <a:ext uri="{FF2B5EF4-FFF2-40B4-BE49-F238E27FC236}">
-                  <a16:creationId xmlns:a16="http://schemas.microsoft.com/office/drawing/2014/main" id="{B49C7DE2-AD46-CC17-9B0E-C56A2830B7E2}"/>
-                </a:ext>
-              </a:extLst>
-            </p:cNvPr>
-            <p:cNvPicPr>
-              <a:picLocks noChangeAspect="1"/>
-            </p:cNvPicPr>
-            <p:nvPr/>
-          </p:nvPicPr>
-          <p:blipFill>
-            <a:blip r:embed="rId4"/>
-            <a:stretch>
-              <a:fillRect/>
-            </a:stretch>
-          </p:blipFill>
-          <p:spPr>
-            <a:xfrm>
-              <a:off x="482874" y="710351"/>
-              <a:ext cx="2752725" cy="3771900"/>
-            </a:xfrm>
-            <a:prstGeom prst="rect">
-              <a:avLst/>
-            </a:prstGeom>
-          </p:spPr>
-        </p:pic>
-        <p:pic>
-          <p:nvPicPr>
-            <p:cNvPr id="36" name="Grafik 35" descr="Ein Bild, das Kleidung, Ärmel, Muster (Modedesign), Freizeitkleidung enthält.&#10;&#10;KI-generierte Inhalte können fehlerhaft sein.">
-              <a:extLst>
-                <a:ext uri="{FF2B5EF4-FFF2-40B4-BE49-F238E27FC236}">
-                  <a16:creationId xmlns:a16="http://schemas.microsoft.com/office/drawing/2014/main" id="{6B46B2A3-589C-F528-B99E-88B0C07954C3}"/>
-                </a:ext>
-              </a:extLst>
-            </p:cNvPr>
-            <p:cNvPicPr>
-              <a:picLocks noChangeAspect="1"/>
-            </p:cNvPicPr>
-            <p:nvPr/>
-          </p:nvPicPr>
-          <p:blipFill>
-            <a:blip r:embed="rId5"/>
-            <a:stretch>
-              <a:fillRect/>
-            </a:stretch>
-          </p:blipFill>
-          <p:spPr>
-            <a:xfrm>
-              <a:off x="3343274" y="715605"/>
-              <a:ext cx="2752725" cy="3781425"/>
-            </a:xfrm>
-            <a:prstGeom prst="rect">
-              <a:avLst/>
-            </a:prstGeom>
-          </p:spPr>
-        </p:pic>
-      </p:grpSp>
-      <p:pic>
-        <p:nvPicPr>
-          <p:cNvPr id="40" name="Grafik 39" descr="Ein Bild, das Text, Screenshot, Zahl, parallel enthält.&#10;&#10;KI-generierte Inhalte können fehlerhaft sein.">
-            <a:extLst>
-              <a:ext uri="{FF2B5EF4-FFF2-40B4-BE49-F238E27FC236}">
-                <a16:creationId xmlns:a16="http://schemas.microsoft.com/office/drawing/2014/main" id="{E7FF2963-4BC7-95A4-B276-6F53674E60B9}"/>
-              </a:ext>
-            </a:extLst>
-          </p:cNvPr>
-          <p:cNvPicPr>
-            <a:picLocks noChangeAspect="1"/>
-          </p:cNvPicPr>
-          <p:nvPr/>
-        </p:nvPicPr>
-        <p:blipFill>
-          <a:blip r:embed="rId6"/>
-          <a:stretch>
-            <a:fillRect/>
-          </a:stretch>
-        </p:blipFill>
-        <p:spPr>
-          <a:xfrm>
-            <a:off x="6069782" y="1657954"/>
-            <a:ext cx="5390380" cy="4475747"/>
-          </a:xfrm>
-          <a:prstGeom prst="rect">
-            <a:avLst/>
-          </a:prstGeom>
-        </p:spPr>
-      </p:pic>
-    </p:spTree>
-    <p:extLst>
-      <p:ext uri="{BB962C8B-B14F-4D97-AF65-F5344CB8AC3E}">
-        <p14:creationId xmlns:p14="http://schemas.microsoft.com/office/powerpoint/2010/main" val="3026351573"/>
       </p:ext>
     </p:extLst>
   </p:cSld>
@@ -10920,6 +11621,21 @@
 </file>
 
 <file path=customXml/item1.xml><?xml version="1.0" encoding="utf-8"?>
+<p:properties xmlns:p="http://schemas.microsoft.com/office/2006/metadata/properties" xmlns:xsi="http://www.w3.org/2001/XMLSchema-instance" xmlns:pc="http://schemas.microsoft.com/office/infopath/2007/PartnerControls">
+  <documentManagement/>
+</p:properties>
+</file>
+
+<file path=customXml/item2.xml><?xml version="1.0" encoding="utf-8"?>
+<?mso-contentType ?>
+<FormTemplates xmlns="http://schemas.microsoft.com/sharepoint/v3/contenttype/forms">
+  <Display>DocumentLibraryForm</Display>
+  <Edit>DocumentLibraryForm</Edit>
+  <New>DocumentLibraryForm</New>
+</FormTemplates>
+</file>
+
+<file path=customXml/item3.xml><?xml version="1.0" encoding="utf-8"?>
 <ct:contentTypeSchema xmlns:ct="http://schemas.microsoft.com/office/2006/metadata/contentType" xmlns:ma="http://schemas.microsoft.com/office/2006/metadata/properties/metaAttributes" ct:_="" ma:_="" ma:contentTypeName="Dokument" ma:contentTypeID="0x010100D0F59E03F3A02E49BD70E31348545014" ma:contentTypeVersion="7" ma:contentTypeDescription="Ein neues Dokument erstellen." ma:contentTypeScope="" ma:versionID="907cdc0f808be0b4bc1373a5a8f6a492">
   <xsd:schema xmlns:xsd="http://www.w3.org/2001/XMLSchema" xmlns:xs="http://www.w3.org/2001/XMLSchema" xmlns:p="http://schemas.microsoft.com/office/2006/metadata/properties" xmlns:ns2="7fd05bba-d45d-467f-a5a8-3f2970e80e4a" targetNamespace="http://schemas.microsoft.com/office/2006/metadata/properties" ma:root="true" ma:fieldsID="6eaf8534fcc486a778b01aa1a7a62fa4" ns2:_="">
     <xsd:import namespace="7fd05bba-d45d-467f-a5a8-3f2970e80e4a"/>
@@ -11081,22 +11797,31 @@
 </ct:contentTypeSchema>
 </file>
 
-<file path=customXml/item2.xml><?xml version="1.0" encoding="utf-8"?>
-<?mso-contentType ?>
-<FormTemplates xmlns="http://schemas.microsoft.com/sharepoint/v3/contenttype/forms">
-  <Display>DocumentLibraryForm</Display>
-  <Edit>DocumentLibraryForm</Edit>
-  <New>DocumentLibraryForm</New>
-</FormTemplates>
+<file path=customXml/itemProps1.xml><?xml version="1.0" encoding="utf-8"?>
+<ds:datastoreItem xmlns:ds="http://schemas.openxmlformats.org/officeDocument/2006/customXml" ds:itemID="{2C3B1C8D-BA84-44B8-B31F-BF26E7BAC85C}">
+  <ds:schemaRefs>
+    <ds:schemaRef ds:uri="http://purl.org/dc/elements/1.1/"/>
+    <ds:schemaRef ds:uri="http://www.w3.org/XML/1998/namespace"/>
+    <ds:schemaRef ds:uri="http://schemas.openxmlformats.org/package/2006/metadata/core-properties"/>
+    <ds:schemaRef ds:uri="http://schemas.microsoft.com/office/2006/documentManagement/types"/>
+    <ds:schemaRef ds:uri="http://purl.org/dc/terms/"/>
+    <ds:schemaRef ds:uri="http://schemas.microsoft.com/office/infopath/2007/PartnerControls"/>
+    <ds:schemaRef ds:uri="http://purl.org/dc/dcmitype/"/>
+    <ds:schemaRef ds:uri="7fd05bba-d45d-467f-a5a8-3f2970e80e4a"/>
+    <ds:schemaRef ds:uri="http://schemas.microsoft.com/office/2006/metadata/properties"/>
+  </ds:schemaRefs>
+</ds:datastoreItem>
 </file>
 
-<file path=customXml/item3.xml><?xml version="1.0" encoding="utf-8"?>
-<p:properties xmlns:p="http://schemas.microsoft.com/office/2006/metadata/properties" xmlns:xsi="http://www.w3.org/2001/XMLSchema-instance" xmlns:pc="http://schemas.microsoft.com/office/infopath/2007/PartnerControls">
-  <documentManagement/>
-</p:properties>
+<file path=customXml/itemProps2.xml><?xml version="1.0" encoding="utf-8"?>
+<ds:datastoreItem xmlns:ds="http://schemas.openxmlformats.org/officeDocument/2006/customXml" ds:itemID="{E0CFCB78-2973-46E2-963D-C72C98C43B41}">
+  <ds:schemaRefs>
+    <ds:schemaRef ds:uri="http://schemas.microsoft.com/sharepoint/v3/contenttype/forms"/>
+  </ds:schemaRefs>
+</ds:datastoreItem>
 </file>
 
-<file path=customXml/itemProps1.xml><?xml version="1.0" encoding="utf-8"?>
+<file path=customXml/itemProps3.xml><?xml version="1.0" encoding="utf-8"?>
 <ds:datastoreItem xmlns:ds="http://schemas.openxmlformats.org/officeDocument/2006/customXml" ds:itemID="{6B7B52BC-33EF-4C54-820C-9984D5F8AFB1}">
   <ds:schemaRefs>
     <ds:schemaRef ds:uri="7fd05bba-d45d-467f-a5a8-3f2970e80e4a"/>
@@ -11112,28 +11837,4 @@
     <ds:schemaRef ds:uri="http://www.w3.org/2001/XMLSchema"/>
   </ds:schemaRefs>
 </ds:datastoreItem>
-</file>
-
-<file path=customXml/itemProps2.xml><?xml version="1.0" encoding="utf-8"?>
-<ds:datastoreItem xmlns:ds="http://schemas.openxmlformats.org/officeDocument/2006/customXml" ds:itemID="{E0CFCB78-2973-46E2-963D-C72C98C43B41}">
-  <ds:schemaRefs>
-    <ds:schemaRef ds:uri="http://schemas.microsoft.com/sharepoint/v3/contenttype/forms"/>
-  </ds:schemaRefs>
-</ds:datastoreItem>
-</file>
-
-<file path=customXml/itemProps3.xml><?xml version="1.0" encoding="utf-8"?>
-<ds:datastoreItem xmlns:ds="http://schemas.openxmlformats.org/officeDocument/2006/customXml" ds:itemID="{2C3B1C8D-BA84-44B8-B31F-BF26E7BAC85C}">
-  <ds:schemaRefs>
-    <ds:schemaRef ds:uri="http://purl.org/dc/elements/1.1/"/>
-    <ds:schemaRef ds:uri="http://www.w3.org/XML/1998/namespace"/>
-    <ds:schemaRef ds:uri="http://schemas.openxmlformats.org/package/2006/metadata/core-properties"/>
-    <ds:schemaRef ds:uri="http://schemas.microsoft.com/office/2006/documentManagement/types"/>
-    <ds:schemaRef ds:uri="http://purl.org/dc/terms/"/>
-    <ds:schemaRef ds:uri="http://schemas.microsoft.com/office/infopath/2007/PartnerControls"/>
-    <ds:schemaRef ds:uri="http://purl.org/dc/dcmitype/"/>
-    <ds:schemaRef ds:uri="7fd05bba-d45d-467f-a5a8-3f2970e80e4a"/>
-    <ds:schemaRef ds:uri="http://schemas.microsoft.com/office/2006/metadata/properties"/>
-  </ds:schemaRefs>
-</ds:datastoreItem>
 </file>
</xml_diff>

<commit_message>
minor changes to the pptx
</commit_message>
<xml_diff>
--- a/Presentations/Assignment_2_MA.pptx
+++ b/Presentations/Assignment_2_MA.pptx
@@ -306,7 +306,7 @@
           <a:p>
             <a:fld id="{2B685DCD-866D-47AE-A236-118539F53379}" type="slidenum">
               <a:rPr lang="de-CH" smtClean="0"/>
-              <a:t>‹Nr.›</a:t>
+              <a:t>‹#›</a:t>
             </a:fld>
             <a:endParaRPr lang="de-CH"/>
           </a:p>
@@ -564,7 +564,7 @@
           <a:p>
             <a:fld id="{F615DDFD-030C-4D5A-B33E-3A7E7538D2BE}" type="slidenum">
               <a:rPr lang="de-CH" smtClean="0"/>
-              <a:t>‹Nr.›</a:t>
+              <a:t>‹#›</a:t>
             </a:fld>
             <a:endParaRPr lang="de-CH"/>
           </a:p>
@@ -692,6 +692,90 @@
       </p:grpSpPr>
       <p:sp>
         <p:nvSpPr>
+          <p:cNvPr id="2" name="Slide Image Placeholder 1"/>
+          <p:cNvSpPr>
+            <a:spLocks noGrp="1" noRot="1" noChangeAspect="1"/>
+          </p:cNvSpPr>
+          <p:nvPr>
+            <p:ph type="sldImg"/>
+          </p:nvPr>
+        </p:nvSpPr>
+        <p:spPr/>
+      </p:sp>
+      <p:sp>
+        <p:nvSpPr>
+          <p:cNvPr id="3" name="Notes Placeholder 2"/>
+          <p:cNvSpPr>
+            <a:spLocks noGrp="1"/>
+          </p:cNvSpPr>
+          <p:nvPr>
+            <p:ph type="body" idx="1"/>
+          </p:nvPr>
+        </p:nvSpPr>
+        <p:spPr/>
+        <p:txBody>
+          <a:bodyPr/>
+          <a:lstStyle/>
+          <a:p>
+            <a:endParaRPr lang="en-US" dirty="0"/>
+          </a:p>
+        </p:txBody>
+      </p:sp>
+      <p:sp>
+        <p:nvSpPr>
+          <p:cNvPr id="4" name="Slide Number Placeholder 3"/>
+          <p:cNvSpPr>
+            <a:spLocks noGrp="1"/>
+          </p:cNvSpPr>
+          <p:nvPr>
+            <p:ph type="sldNum" sz="quarter" idx="5"/>
+          </p:nvPr>
+        </p:nvSpPr>
+        <p:spPr/>
+        <p:txBody>
+          <a:bodyPr/>
+          <a:lstStyle/>
+          <a:p>
+            <a:fld id="{F615DDFD-030C-4D5A-B33E-3A7E7538D2BE}" type="slidenum">
+              <a:rPr lang="de-CH" smtClean="0"/>
+              <a:t>1</a:t>
+            </a:fld>
+            <a:endParaRPr lang="de-CH"/>
+          </a:p>
+        </p:txBody>
+      </p:sp>
+    </p:spTree>
+    <p:extLst>
+      <p:ext uri="{BB962C8B-B14F-4D97-AF65-F5344CB8AC3E}">
+        <p14:creationId xmlns:p14="http://schemas.microsoft.com/office/powerpoint/2010/main" val="3836580731"/>
+      </p:ext>
+    </p:extLst>
+  </p:cSld>
+  <p:clrMapOvr>
+    <a:masterClrMapping/>
+  </p:clrMapOvr>
+</p:notes>
+</file>
+
+<file path=ppt/notesSlides/notesSlide2.xml><?xml version="1.0" encoding="utf-8"?>
+<p:notes xmlns:a="http://schemas.openxmlformats.org/drawingml/2006/main" xmlns:r="http://schemas.openxmlformats.org/officeDocument/2006/relationships" xmlns:p="http://schemas.openxmlformats.org/presentationml/2006/main">
+  <p:cSld>
+    <p:spTree>
+      <p:nvGrpSpPr>
+        <p:cNvPr id="1" name=""/>
+        <p:cNvGrpSpPr/>
+        <p:nvPr/>
+      </p:nvGrpSpPr>
+      <p:grpSpPr>
+        <a:xfrm>
+          <a:off x="0" y="0"/>
+          <a:ext cx="0" cy="0"/>
+          <a:chOff x="0" y="0"/>
+          <a:chExt cx="0" cy="0"/>
+        </a:xfrm>
+      </p:grpSpPr>
+      <p:sp>
+        <p:nvSpPr>
           <p:cNvPr id="2" name="Folienbildplatzhalter 1"/>
           <p:cNvSpPr>
             <a:spLocks noGrp="1" noRot="1" noChangeAspect="1"/>
@@ -1099,7 +1183,7 @@
 </p:notes>
 </file>
 
-<file path=ppt/notesSlides/notesSlide2.xml><?xml version="1.0" encoding="utf-8"?>
+<file path=ppt/notesSlides/notesSlide3.xml><?xml version="1.0" encoding="utf-8"?>
 <p:notes xmlns:a="http://schemas.openxmlformats.org/drawingml/2006/main" xmlns:r="http://schemas.openxmlformats.org/officeDocument/2006/relationships" xmlns:p="http://schemas.openxmlformats.org/presentationml/2006/main">
   <p:cSld>
     <p:spTree>
@@ -1419,13 +1503,13 @@
           <p:nvPr userDrawn="1"/>
         </p:nvPicPr>
         <p:blipFill>
-          <a:blip>
+          <a:blip r:embed="rId2">
             <a:extLst>
               <a:ext uri="{28A0092B-C50C-407E-A947-70E740481C1C}">
                 <a14:useLocalDpi xmlns:a14="http://schemas.microsoft.com/office/drawing/2010/main" val="0"/>
               </a:ext>
               <a:ext uri="{96DAC541-7B7A-43D3-8B79-37D633B846F1}">
-                <asvg:svgBlip xmlns:asvg="http://schemas.microsoft.com/office/drawing/2016/SVG/main" r:embed="rId2"/>
+                <asvg:svgBlip xmlns:asvg="http://schemas.microsoft.com/office/drawing/2016/SVG/main" r:embed="rId3"/>
               </a:ext>
             </a:extLst>
           </a:blip>
@@ -1818,7 +1902,7 @@
           <a:p>
             <a:fld id="{5ACA52AF-F19D-405C-AD5F-7D94B96A5CC3}" type="slidenum">
               <a:rPr lang="de-CH" noProof="0" smtClean="0"/>
-              <a:t>‹Nr.›</a:t>
+              <a:t>‹#›</a:t>
             </a:fld>
             <a:endParaRPr lang="de-CH" noProof="0"/>
           </a:p>
@@ -1839,13 +1923,13 @@
           <p:nvPr userDrawn="1"/>
         </p:nvPicPr>
         <p:blipFill>
-          <a:blip>
+          <a:blip r:embed="rId2">
             <a:extLst>
               <a:ext uri="{28A0092B-C50C-407E-A947-70E740481C1C}">
                 <a14:useLocalDpi xmlns:a14="http://schemas.microsoft.com/office/drawing/2010/main" val="0"/>
               </a:ext>
               <a:ext uri="{96DAC541-7B7A-43D3-8B79-37D633B846F1}">
-                <asvg:svgBlip xmlns:asvg="http://schemas.microsoft.com/office/drawing/2016/SVG/main" r:embed="rId2"/>
+                <asvg:svgBlip xmlns:asvg="http://schemas.microsoft.com/office/drawing/2016/SVG/main" r:embed="rId3"/>
               </a:ext>
             </a:extLst>
           </a:blip>
@@ -2013,7 +2097,7 @@
           <a:p>
             <a:fld id="{5ACA52AF-F19D-405C-AD5F-7D94B96A5CC3}" type="slidenum">
               <a:rPr lang="de-CH" noProof="0" smtClean="0"/>
-              <a:t>‹Nr.›</a:t>
+              <a:t>‹#›</a:t>
             </a:fld>
             <a:endParaRPr lang="de-CH" noProof="0"/>
           </a:p>
@@ -2034,13 +2118,13 @@
           <p:nvPr userDrawn="1"/>
         </p:nvPicPr>
         <p:blipFill>
-          <a:blip>
+          <a:blip r:embed="rId2">
             <a:extLst>
               <a:ext uri="{28A0092B-C50C-407E-A947-70E740481C1C}">
                 <a14:useLocalDpi xmlns:a14="http://schemas.microsoft.com/office/drawing/2010/main" val="0"/>
               </a:ext>
               <a:ext uri="{96DAC541-7B7A-43D3-8B79-37D633B846F1}">
-                <asvg:svgBlip xmlns:asvg="http://schemas.microsoft.com/office/drawing/2016/SVG/main" r:embed="rId2"/>
+                <asvg:svgBlip xmlns:asvg="http://schemas.microsoft.com/office/drawing/2016/SVG/main" r:embed="rId3"/>
               </a:ext>
             </a:extLst>
           </a:blip>
@@ -2300,7 +2384,7 @@
           <a:p>
             <a:fld id="{5ACA52AF-F19D-405C-AD5F-7D94B96A5CC3}" type="slidenum">
               <a:rPr lang="de-CH" noProof="0" smtClean="0"/>
-              <a:t>‹Nr.›</a:t>
+              <a:t>‹#›</a:t>
             </a:fld>
             <a:endParaRPr lang="de-CH" noProof="0"/>
           </a:p>
@@ -2321,13 +2405,13 @@
           <p:nvPr userDrawn="1"/>
         </p:nvPicPr>
         <p:blipFill>
-          <a:blip>
+          <a:blip r:embed="rId2">
             <a:extLst>
               <a:ext uri="{28A0092B-C50C-407E-A947-70E740481C1C}">
                 <a14:useLocalDpi xmlns:a14="http://schemas.microsoft.com/office/drawing/2010/main" val="0"/>
               </a:ext>
               <a:ext uri="{96DAC541-7B7A-43D3-8B79-37D633B846F1}">
-                <asvg:svgBlip xmlns:asvg="http://schemas.microsoft.com/office/drawing/2016/SVG/main" r:embed="rId2"/>
+                <asvg:svgBlip xmlns:asvg="http://schemas.microsoft.com/office/drawing/2016/SVG/main" r:embed="rId3"/>
               </a:ext>
             </a:extLst>
           </a:blip>
@@ -2598,7 +2682,7 @@
           <a:p>
             <a:fld id="{5ACA52AF-F19D-405C-AD5F-7D94B96A5CC3}" type="slidenum">
               <a:rPr lang="de-CH" noProof="0" smtClean="0"/>
-              <a:t>‹Nr.›</a:t>
+              <a:t>‹#›</a:t>
             </a:fld>
             <a:endParaRPr lang="de-CH" noProof="0"/>
           </a:p>
@@ -2619,13 +2703,13 @@
           <p:nvPr userDrawn="1"/>
         </p:nvPicPr>
         <p:blipFill>
-          <a:blip>
+          <a:blip r:embed="rId2">
             <a:extLst>
               <a:ext uri="{28A0092B-C50C-407E-A947-70E740481C1C}">
                 <a14:useLocalDpi xmlns:a14="http://schemas.microsoft.com/office/drawing/2010/main" val="0"/>
               </a:ext>
               <a:ext uri="{96DAC541-7B7A-43D3-8B79-37D633B846F1}">
-                <asvg:svgBlip xmlns:asvg="http://schemas.microsoft.com/office/drawing/2016/SVG/main" r:embed="rId2"/>
+                <asvg:svgBlip xmlns:asvg="http://schemas.microsoft.com/office/drawing/2016/SVG/main" r:embed="rId3"/>
               </a:ext>
             </a:extLst>
           </a:blip>
@@ -2998,7 +3082,7 @@
           <a:p>
             <a:fld id="{5ACA52AF-F19D-405C-AD5F-7D94B96A5CC3}" type="slidenum">
               <a:rPr lang="de-CH" noProof="0" smtClean="0"/>
-              <a:t>‹Nr.›</a:t>
+              <a:t>‹#›</a:t>
             </a:fld>
             <a:endParaRPr lang="de-CH" noProof="0"/>
           </a:p>
@@ -3019,13 +3103,13 @@
           <p:nvPr userDrawn="1"/>
         </p:nvPicPr>
         <p:blipFill>
-          <a:blip>
+          <a:blip r:embed="rId2">
             <a:extLst>
               <a:ext uri="{28A0092B-C50C-407E-A947-70E740481C1C}">
                 <a14:useLocalDpi xmlns:a14="http://schemas.microsoft.com/office/drawing/2010/main" val="0"/>
               </a:ext>
               <a:ext uri="{96DAC541-7B7A-43D3-8B79-37D633B846F1}">
-                <asvg:svgBlip xmlns:asvg="http://schemas.microsoft.com/office/drawing/2016/SVG/main" r:embed="rId2"/>
+                <asvg:svgBlip xmlns:asvg="http://schemas.microsoft.com/office/drawing/2016/SVG/main" r:embed="rId3"/>
               </a:ext>
             </a:extLst>
           </a:blip>
@@ -3366,7 +3450,7 @@
           <a:p>
             <a:fld id="{5ACA52AF-F19D-405C-AD5F-7D94B96A5CC3}" type="slidenum">
               <a:rPr lang="de-CH" noProof="0" smtClean="0"/>
-              <a:t>‹Nr.›</a:t>
+              <a:t>‹#›</a:t>
             </a:fld>
             <a:endParaRPr lang="de-CH" noProof="0"/>
           </a:p>
@@ -3387,13 +3471,13 @@
           <p:nvPr userDrawn="1"/>
         </p:nvPicPr>
         <p:blipFill>
-          <a:blip>
+          <a:blip r:embed="rId2">
             <a:extLst>
               <a:ext uri="{28A0092B-C50C-407E-A947-70E740481C1C}">
                 <a14:useLocalDpi xmlns:a14="http://schemas.microsoft.com/office/drawing/2010/main" val="0"/>
               </a:ext>
               <a:ext uri="{96DAC541-7B7A-43D3-8B79-37D633B846F1}">
-                <asvg:svgBlip xmlns:asvg="http://schemas.microsoft.com/office/drawing/2016/SVG/main" r:embed="rId2"/>
+                <asvg:svgBlip xmlns:asvg="http://schemas.microsoft.com/office/drawing/2016/SVG/main" r:embed="rId3"/>
               </a:ext>
             </a:extLst>
           </a:blip>
@@ -3638,13 +3722,13 @@
           <p:nvPr userDrawn="1"/>
         </p:nvPicPr>
         <p:blipFill>
-          <a:blip>
+          <a:blip r:embed="rId2">
             <a:extLst>
               <a:ext uri="{28A0092B-C50C-407E-A947-70E740481C1C}">
                 <a14:useLocalDpi xmlns:a14="http://schemas.microsoft.com/office/drawing/2010/main" val="0"/>
               </a:ext>
               <a:ext uri="{96DAC541-7B7A-43D3-8B79-37D633B846F1}">
-                <asvg:svgBlip xmlns:asvg="http://schemas.microsoft.com/office/drawing/2016/SVG/main" r:embed="rId2"/>
+                <asvg:svgBlip xmlns:asvg="http://schemas.microsoft.com/office/drawing/2016/SVG/main" r:embed="rId3"/>
               </a:ext>
             </a:extLst>
           </a:blip>
@@ -3815,13 +3899,13 @@
           <p:nvPr userDrawn="1"/>
         </p:nvPicPr>
         <p:blipFill>
-          <a:blip>
+          <a:blip r:embed="rId2">
             <a:extLst>
               <a:ext uri="{28A0092B-C50C-407E-A947-70E740481C1C}">
                 <a14:useLocalDpi xmlns:a14="http://schemas.microsoft.com/office/drawing/2010/main" val="0"/>
               </a:ext>
               <a:ext uri="{96DAC541-7B7A-43D3-8B79-37D633B846F1}">
-                <asvg:svgBlip xmlns:asvg="http://schemas.microsoft.com/office/drawing/2016/SVG/main" r:embed="rId2"/>
+                <asvg:svgBlip xmlns:asvg="http://schemas.microsoft.com/office/drawing/2016/SVG/main" r:embed="rId3"/>
               </a:ext>
             </a:extLst>
           </a:blip>
@@ -4208,13 +4292,13 @@
           <p:nvPr userDrawn="1"/>
         </p:nvPicPr>
         <p:blipFill>
-          <a:blip>
+          <a:blip r:embed="rId2">
             <a:extLst>
               <a:ext uri="{28A0092B-C50C-407E-A947-70E740481C1C}">
                 <a14:useLocalDpi xmlns:a14="http://schemas.microsoft.com/office/drawing/2010/main" val="0"/>
               </a:ext>
               <a:ext uri="{96DAC541-7B7A-43D3-8B79-37D633B846F1}">
-                <asvg:svgBlip xmlns:asvg="http://schemas.microsoft.com/office/drawing/2016/SVG/main" r:embed="rId2"/>
+                <asvg:svgBlip xmlns:asvg="http://schemas.microsoft.com/office/drawing/2016/SVG/main" r:embed="rId3"/>
               </a:ext>
             </a:extLst>
           </a:blip>
@@ -4549,13 +4633,13 @@
           <p:nvPr userDrawn="1"/>
         </p:nvPicPr>
         <p:blipFill>
-          <a:blip>
+          <a:blip r:embed="rId2">
             <a:extLst>
               <a:ext uri="{28A0092B-C50C-407E-A947-70E740481C1C}">
                 <a14:useLocalDpi xmlns:a14="http://schemas.microsoft.com/office/drawing/2010/main" val="0"/>
               </a:ext>
               <a:ext uri="{96DAC541-7B7A-43D3-8B79-37D633B846F1}">
-                <asvg:svgBlip xmlns:asvg="http://schemas.microsoft.com/office/drawing/2016/SVG/main" r:embed="rId2"/>
+                <asvg:svgBlip xmlns:asvg="http://schemas.microsoft.com/office/drawing/2016/SVG/main" r:embed="rId3"/>
               </a:ext>
             </a:extLst>
           </a:blip>
@@ -4926,13 +5010,13 @@
           <p:nvPr userDrawn="1"/>
         </p:nvPicPr>
         <p:blipFill>
-          <a:blip>
+          <a:blip r:embed="rId2">
             <a:extLst>
               <a:ext uri="{28A0092B-C50C-407E-A947-70E740481C1C}">
                 <a14:useLocalDpi xmlns:a14="http://schemas.microsoft.com/office/drawing/2010/main" val="0"/>
               </a:ext>
               <a:ext uri="{96DAC541-7B7A-43D3-8B79-37D633B846F1}">
-                <asvg:svgBlip xmlns:asvg="http://schemas.microsoft.com/office/drawing/2016/SVG/main" r:embed="rId2"/>
+                <asvg:svgBlip xmlns:asvg="http://schemas.microsoft.com/office/drawing/2016/SVG/main" r:embed="rId3"/>
               </a:ext>
             </a:extLst>
           </a:blip>
@@ -5395,7 +5479,7 @@
           <a:p>
             <a:fld id="{5ACA52AF-F19D-405C-AD5F-7D94B96A5CC3}" type="slidenum">
               <a:rPr lang="de-CH" noProof="0" smtClean="0"/>
-              <a:t>‹Nr.›</a:t>
+              <a:t>‹#›</a:t>
             </a:fld>
             <a:endParaRPr lang="de-CH" noProof="0"/>
           </a:p>
@@ -5416,13 +5500,13 @@
           <p:nvPr userDrawn="1"/>
         </p:nvPicPr>
         <p:blipFill>
-          <a:blip>
+          <a:blip r:embed="rId2">
             <a:extLst>
               <a:ext uri="{28A0092B-C50C-407E-A947-70E740481C1C}">
                 <a14:useLocalDpi xmlns:a14="http://schemas.microsoft.com/office/drawing/2010/main" val="0"/>
               </a:ext>
               <a:ext uri="{96DAC541-7B7A-43D3-8B79-37D633B846F1}">
-                <asvg:svgBlip xmlns:asvg="http://schemas.microsoft.com/office/drawing/2016/SVG/main" r:embed="rId2"/>
+                <asvg:svgBlip xmlns:asvg="http://schemas.microsoft.com/office/drawing/2016/SVG/main" r:embed="rId3"/>
               </a:ext>
             </a:extLst>
           </a:blip>
@@ -5638,7 +5722,7 @@
           <a:p>
             <a:fld id="{5ACA52AF-F19D-405C-AD5F-7D94B96A5CC3}" type="slidenum">
               <a:rPr lang="de-CH" noProof="0" smtClean="0"/>
-              <a:t>‹Nr.›</a:t>
+              <a:t>‹#›</a:t>
             </a:fld>
             <a:endParaRPr lang="de-CH" noProof="0"/>
           </a:p>
@@ -5659,13 +5743,13 @@
           <p:nvPr userDrawn="1"/>
         </p:nvPicPr>
         <p:blipFill>
-          <a:blip>
+          <a:blip r:embed="rId2">
             <a:extLst>
               <a:ext uri="{28A0092B-C50C-407E-A947-70E740481C1C}">
                 <a14:useLocalDpi xmlns:a14="http://schemas.microsoft.com/office/drawing/2010/main" val="0"/>
               </a:ext>
               <a:ext uri="{96DAC541-7B7A-43D3-8B79-37D633B846F1}">
-                <asvg:svgBlip xmlns:asvg="http://schemas.microsoft.com/office/drawing/2016/SVG/main" r:embed="rId2"/>
+                <asvg:svgBlip xmlns:asvg="http://schemas.microsoft.com/office/drawing/2016/SVG/main" r:embed="rId3"/>
               </a:ext>
             </a:extLst>
           </a:blip>
@@ -5886,7 +5970,7 @@
           <a:p>
             <a:fld id="{5ACA52AF-F19D-405C-AD5F-7D94B96A5CC3}" type="slidenum">
               <a:rPr lang="de-CH" noProof="0" smtClean="0"/>
-              <a:t>‹Nr.›</a:t>
+              <a:t>‹#›</a:t>
             </a:fld>
             <a:endParaRPr lang="de-CH" noProof="0"/>
           </a:p>
@@ -5907,13 +5991,13 @@
           <p:nvPr userDrawn="1"/>
         </p:nvPicPr>
         <p:blipFill>
-          <a:blip>
+          <a:blip r:embed="rId2">
             <a:extLst>
               <a:ext uri="{28A0092B-C50C-407E-A947-70E740481C1C}">
                 <a14:useLocalDpi xmlns:a14="http://schemas.microsoft.com/office/drawing/2010/main" val="0"/>
               </a:ext>
               <a:ext uri="{96DAC541-7B7A-43D3-8B79-37D633B846F1}">
-                <asvg:svgBlip xmlns:asvg="http://schemas.microsoft.com/office/drawing/2016/SVG/main" r:embed="rId2"/>
+                <asvg:svgBlip xmlns:asvg="http://schemas.microsoft.com/office/drawing/2016/SVG/main" r:embed="rId3"/>
               </a:ext>
             </a:extLst>
           </a:blip>
@@ -6179,7 +6263,7 @@
             <a:fld id="{5ACA52AF-F19D-405C-AD5F-7D94B96A5CC3}" type="slidenum">
               <a:rPr lang="de-CH" noProof="0" smtClean="0"/>
               <a:pPr/>
-              <a:t>‹Nr.›</a:t>
+              <a:t>‹#›</a:t>
             </a:fld>
             <a:endParaRPr lang="de-CH" noProof="0"/>
           </a:p>
@@ -8122,7 +8206,7 @@
             <a:fld id="{5ACA52AF-F19D-405C-AD5F-7D94B96A5CC3}" type="slidenum">
               <a:rPr lang="de-CH" noProof="0" smtClean="0"/>
               <a:pPr/>
-              <a:t>‹Nr.›</a:t>
+              <a:t>‹#›</a:t>
             </a:fld>
             <a:endParaRPr lang="de-CH" noProof="0"/>
           </a:p>
@@ -8508,7 +8592,7 @@
           </p:nvPr>
         </p:nvPicPr>
         <p:blipFill>
-          <a:blip r:embed="rId2">
+          <a:blip r:embed="rId3">
             <a:extLst>
               <a:ext uri="{28A0092B-C50C-407E-A947-70E740481C1C}">
                 <a14:useLocalDpi xmlns:a14="http://schemas.microsoft.com/office/drawing/2010/main" val="0"/>
@@ -8543,13 +8627,6 @@
           <a:bodyPr/>
           <a:lstStyle/>
           <a:p>
-            <a:r>
-              <a:rPr lang="en-US" sz="2400" noProof="0" dirty="0">
-                <a:ea typeface="+mj-lt"/>
-                <a:cs typeface="+mj-lt"/>
-              </a:rPr>
-              <a:t>Assignment 2:</a:t>
-            </a:r>
             <a:br>
               <a:rPr lang="en-US" sz="2400" noProof="0" dirty="0">
                 <a:ea typeface="+mj-lt"/>
@@ -8561,6 +8638,19 @@
                 <a:ea typeface="+mj-lt"/>
                 <a:cs typeface="+mj-lt"/>
               </a:rPr>
+              <a:t>Assignment 2:</a:t>
+            </a:r>
+            <a:br>
+              <a:rPr lang="en-US" sz="2400" noProof="0" dirty="0">
+                <a:ea typeface="+mj-lt"/>
+                <a:cs typeface="+mj-lt"/>
+              </a:rPr>
+            </a:br>
+            <a:r>
+              <a:rPr lang="en-US" sz="2400" noProof="0" dirty="0">
+                <a:ea typeface="+mj-lt"/>
+                <a:cs typeface="+mj-lt"/>
+              </a:rPr>
               <a:t>Baseline Challenge</a:t>
             </a:r>
           </a:p>
@@ -8607,7 +8697,12 @@
             <p:ph type="body" sz="quarter" idx="13"/>
           </p:nvPr>
         </p:nvSpPr>
-        <p:spPr/>
+        <p:spPr>
+          <a:xfrm>
+            <a:off x="1069186" y="3785845"/>
+            <a:ext cx="4680000" cy="1008000"/>
+          </a:xfrm>
+        </p:spPr>
         <p:txBody>
           <a:bodyPr vert="horz" lIns="0" tIns="0" rIns="0" bIns="0" rtlCol="0" anchor="t">
             <a:noAutofit/>
@@ -8615,22 +8710,35 @@
           <a:lstStyle/>
           <a:p>
             <a:r>
+              <a:rPr lang="en-US" b="1" noProof="0" dirty="0">
+                <a:cs typeface="+mn-lt"/>
+              </a:rPr>
+              <a:t>Group 2:</a:t>
+            </a:r>
+          </a:p>
+          <a:p>
+            <a:endParaRPr lang="en-US" sz="1000" b="1" noProof="0" dirty="0">
+              <a:cs typeface="+mn-lt"/>
+            </a:endParaRPr>
+          </a:p>
+          <a:p>
+            <a:r>
               <a:rPr lang="en-US" sz="1600" b="1" noProof="0" dirty="0">
                 <a:cs typeface="+mn-lt"/>
               </a:rPr>
               <a:t>Constantin </a:t>
             </a:r>
             <a:r>
-              <a:rPr lang="en-US" sz="1600" b="1" noProof="0">
+              <a:rPr lang="en-US" sz="1600" b="1" noProof="0" dirty="0" err="1">
                 <a:cs typeface="+mn-lt"/>
               </a:rPr>
-              <a:t>Cimpoes, Julius </a:t>
+              <a:t>Cimpoes</a:t>
             </a:r>
             <a:r>
               <a:rPr lang="en-US" sz="1600" b="1" noProof="0" dirty="0">
                 <a:cs typeface="+mn-lt"/>
               </a:rPr>
-              <a:t>Voss</a:t>
+              <a:t>, Julius Voss</a:t>
             </a:r>
           </a:p>
         </p:txBody>
@@ -8656,7 +8764,10 @@
           <a:bodyPr/>
           <a:lstStyle/>
           <a:p>
-            <a:endParaRPr lang="en-US" noProof="0"/>
+            <a:r>
+              <a:rPr lang="en-US" dirty="0"/>
+              <a:t>Marketing Analytics</a:t>
+            </a:r>
           </a:p>
         </p:txBody>
       </p:sp>
@@ -8841,16 +8952,10 @@
           </a:bodyPr>
           <a:lstStyle/>
           <a:p>
-            <a:pPr>
-              <a:spcAft>
-                <a:spcPts val="600"/>
-              </a:spcAft>
-            </a:pPr>
-            <a:r>
-              <a:rPr lang="de-DE" noProof="0"/>
-              <a:t>Organisationseinheit verbal</a:t>
-            </a:r>
-            <a:endParaRPr lang="de-CH" noProof="0"/>
+            <a:r>
+              <a:rPr lang="en-US" dirty="0"/>
+              <a:t>Marketing Analytics</a:t>
+            </a:r>
           </a:p>
         </p:txBody>
       </p:sp>
@@ -10954,6 +11059,136 @@
                 </a:solidFill>
               </a:rPr>
               <a:t> with behavioral features (e.g., Style Entropy and Cluster Affinity) to precisely predict who is churning and close the error gap even further</a:t>
+            </a:r>
+          </a:p>
+        </p:txBody>
+      </p:sp>
+      <p:sp>
+        <p:nvSpPr>
+          <p:cNvPr id="8" name="Fußzeilenplatzhalter 4">
+            <a:extLst>
+              <a:ext uri="{FF2B5EF4-FFF2-40B4-BE49-F238E27FC236}">
+                <a16:creationId xmlns:a16="http://schemas.microsoft.com/office/drawing/2014/main" id="{1CFF14FB-C344-290F-B84B-465E89ADDC61}"/>
+              </a:ext>
+            </a:extLst>
+          </p:cNvPr>
+          <p:cNvSpPr txBox="1">
+            <a:spLocks/>
+          </p:cNvSpPr>
+          <p:nvPr/>
+        </p:nvSpPr>
+        <p:spPr>
+          <a:xfrm>
+            <a:off x="2165476" y="6525556"/>
+            <a:ext cx="5400000" cy="216000"/>
+          </a:xfrm>
+          <a:prstGeom prst="rect">
+            <a:avLst/>
+          </a:prstGeom>
+        </p:spPr>
+        <p:txBody>
+          <a:bodyPr vert="horz" lIns="0" tIns="0" rIns="0" bIns="0" rtlCol="0" anchor="ctr">
+            <a:normAutofit/>
+          </a:bodyPr>
+          <a:lstStyle>
+            <a:defPPr>
+              <a:defRPr lang="de-DE"/>
+            </a:defPPr>
+            <a:lvl1pPr marL="0" algn="l" defTabSz="914400" rtl="0" eaLnBrk="1" latinLnBrk="0" hangingPunct="1">
+              <a:defRPr sz="800" kern="1200">
+                <a:solidFill>
+                  <a:schemeClr val="tx1"/>
+                </a:solidFill>
+                <a:latin typeface="+mn-lt"/>
+                <a:ea typeface="+mn-ea"/>
+                <a:cs typeface="+mn-cs"/>
+              </a:defRPr>
+            </a:lvl1pPr>
+            <a:lvl2pPr marL="457200" algn="l" defTabSz="914400" rtl="0" eaLnBrk="1" latinLnBrk="0" hangingPunct="1">
+              <a:defRPr sz="1800" kern="1200">
+                <a:solidFill>
+                  <a:schemeClr val="tx1"/>
+                </a:solidFill>
+                <a:latin typeface="+mn-lt"/>
+                <a:ea typeface="+mn-ea"/>
+                <a:cs typeface="+mn-cs"/>
+              </a:defRPr>
+            </a:lvl2pPr>
+            <a:lvl3pPr marL="914400" algn="l" defTabSz="914400" rtl="0" eaLnBrk="1" latinLnBrk="0" hangingPunct="1">
+              <a:defRPr sz="1800" kern="1200">
+                <a:solidFill>
+                  <a:schemeClr val="tx1"/>
+                </a:solidFill>
+                <a:latin typeface="+mn-lt"/>
+                <a:ea typeface="+mn-ea"/>
+                <a:cs typeface="+mn-cs"/>
+              </a:defRPr>
+            </a:lvl3pPr>
+            <a:lvl4pPr marL="1371600" algn="l" defTabSz="914400" rtl="0" eaLnBrk="1" latinLnBrk="0" hangingPunct="1">
+              <a:defRPr sz="1800" kern="1200">
+                <a:solidFill>
+                  <a:schemeClr val="tx1"/>
+                </a:solidFill>
+                <a:latin typeface="+mn-lt"/>
+                <a:ea typeface="+mn-ea"/>
+                <a:cs typeface="+mn-cs"/>
+              </a:defRPr>
+            </a:lvl4pPr>
+            <a:lvl5pPr marL="1828800" algn="l" defTabSz="914400" rtl="0" eaLnBrk="1" latinLnBrk="0" hangingPunct="1">
+              <a:defRPr sz="1800" kern="1200">
+                <a:solidFill>
+                  <a:schemeClr val="tx1"/>
+                </a:solidFill>
+                <a:latin typeface="+mn-lt"/>
+                <a:ea typeface="+mn-ea"/>
+                <a:cs typeface="+mn-cs"/>
+              </a:defRPr>
+            </a:lvl5pPr>
+            <a:lvl6pPr marL="2286000" algn="l" defTabSz="914400" rtl="0" eaLnBrk="1" latinLnBrk="0" hangingPunct="1">
+              <a:defRPr sz="1800" kern="1200">
+                <a:solidFill>
+                  <a:schemeClr val="tx1"/>
+                </a:solidFill>
+                <a:latin typeface="+mn-lt"/>
+                <a:ea typeface="+mn-ea"/>
+                <a:cs typeface="+mn-cs"/>
+              </a:defRPr>
+            </a:lvl6pPr>
+            <a:lvl7pPr marL="2743200" algn="l" defTabSz="914400" rtl="0" eaLnBrk="1" latinLnBrk="0" hangingPunct="1">
+              <a:defRPr sz="1800" kern="1200">
+                <a:solidFill>
+                  <a:schemeClr val="tx1"/>
+                </a:solidFill>
+                <a:latin typeface="+mn-lt"/>
+                <a:ea typeface="+mn-ea"/>
+                <a:cs typeface="+mn-cs"/>
+              </a:defRPr>
+            </a:lvl7pPr>
+            <a:lvl8pPr marL="3200400" algn="l" defTabSz="914400" rtl="0" eaLnBrk="1" latinLnBrk="0" hangingPunct="1">
+              <a:defRPr sz="1800" kern="1200">
+                <a:solidFill>
+                  <a:schemeClr val="tx1"/>
+                </a:solidFill>
+                <a:latin typeface="+mn-lt"/>
+                <a:ea typeface="+mn-ea"/>
+                <a:cs typeface="+mn-cs"/>
+              </a:defRPr>
+            </a:lvl8pPr>
+            <a:lvl9pPr marL="3657600" algn="l" defTabSz="914400" rtl="0" eaLnBrk="1" latinLnBrk="0" hangingPunct="1">
+              <a:defRPr sz="1800" kern="1200">
+                <a:solidFill>
+                  <a:schemeClr val="tx1"/>
+                </a:solidFill>
+                <a:latin typeface="+mn-lt"/>
+                <a:ea typeface="+mn-ea"/>
+                <a:cs typeface="+mn-cs"/>
+              </a:defRPr>
+            </a:lvl9pPr>
+          </a:lstStyle>
+          <a:p>
+            <a:r>
+              <a:rPr lang="en-US" dirty="0"/>
+              <a:t>Marketing Analytics</a:t>
             </a:r>
           </a:p>
         </p:txBody>
@@ -11621,21 +11856,6 @@
 </file>
 
 <file path=customXml/item1.xml><?xml version="1.0" encoding="utf-8"?>
-<p:properties xmlns:p="http://schemas.microsoft.com/office/2006/metadata/properties" xmlns:xsi="http://www.w3.org/2001/XMLSchema-instance" xmlns:pc="http://schemas.microsoft.com/office/infopath/2007/PartnerControls">
-  <documentManagement/>
-</p:properties>
-</file>
-
-<file path=customXml/item2.xml><?xml version="1.0" encoding="utf-8"?>
-<?mso-contentType ?>
-<FormTemplates xmlns="http://schemas.microsoft.com/sharepoint/v3/contenttype/forms">
-  <Display>DocumentLibraryForm</Display>
-  <Edit>DocumentLibraryForm</Edit>
-  <New>DocumentLibraryForm</New>
-</FormTemplates>
-</file>
-
-<file path=customXml/item3.xml><?xml version="1.0" encoding="utf-8"?>
 <ct:contentTypeSchema xmlns:ct="http://schemas.microsoft.com/office/2006/metadata/contentType" xmlns:ma="http://schemas.microsoft.com/office/2006/metadata/properties/metaAttributes" ct:_="" ma:_="" ma:contentTypeName="Dokument" ma:contentTypeID="0x010100D0F59E03F3A02E49BD70E31348545014" ma:contentTypeVersion="7" ma:contentTypeDescription="Ein neues Dokument erstellen." ma:contentTypeScope="" ma:versionID="907cdc0f808be0b4bc1373a5a8f6a492">
   <xsd:schema xmlns:xsd="http://www.w3.org/2001/XMLSchema" xmlns:xs="http://www.w3.org/2001/XMLSchema" xmlns:p="http://schemas.microsoft.com/office/2006/metadata/properties" xmlns:ns2="7fd05bba-d45d-467f-a5a8-3f2970e80e4a" targetNamespace="http://schemas.microsoft.com/office/2006/metadata/properties" ma:root="true" ma:fieldsID="6eaf8534fcc486a778b01aa1a7a62fa4" ns2:_="">
     <xsd:import namespace="7fd05bba-d45d-467f-a5a8-3f2970e80e4a"/>
@@ -11797,31 +12017,22 @@
 </ct:contentTypeSchema>
 </file>
 
-<file path=customXml/itemProps1.xml><?xml version="1.0" encoding="utf-8"?>
-<ds:datastoreItem xmlns:ds="http://schemas.openxmlformats.org/officeDocument/2006/customXml" ds:itemID="{2C3B1C8D-BA84-44B8-B31F-BF26E7BAC85C}">
-  <ds:schemaRefs>
-    <ds:schemaRef ds:uri="http://purl.org/dc/elements/1.1/"/>
-    <ds:schemaRef ds:uri="http://www.w3.org/XML/1998/namespace"/>
-    <ds:schemaRef ds:uri="http://schemas.openxmlformats.org/package/2006/metadata/core-properties"/>
-    <ds:schemaRef ds:uri="http://schemas.microsoft.com/office/2006/documentManagement/types"/>
-    <ds:schemaRef ds:uri="http://purl.org/dc/terms/"/>
-    <ds:schemaRef ds:uri="http://schemas.microsoft.com/office/infopath/2007/PartnerControls"/>
-    <ds:schemaRef ds:uri="http://purl.org/dc/dcmitype/"/>
-    <ds:schemaRef ds:uri="7fd05bba-d45d-467f-a5a8-3f2970e80e4a"/>
-    <ds:schemaRef ds:uri="http://schemas.microsoft.com/office/2006/metadata/properties"/>
-  </ds:schemaRefs>
-</ds:datastoreItem>
+<file path=customXml/item2.xml><?xml version="1.0" encoding="utf-8"?>
+<?mso-contentType ?>
+<FormTemplates xmlns="http://schemas.microsoft.com/sharepoint/v3/contenttype/forms">
+  <Display>DocumentLibraryForm</Display>
+  <Edit>DocumentLibraryForm</Edit>
+  <New>DocumentLibraryForm</New>
+</FormTemplates>
 </file>
 
-<file path=customXml/itemProps2.xml><?xml version="1.0" encoding="utf-8"?>
-<ds:datastoreItem xmlns:ds="http://schemas.openxmlformats.org/officeDocument/2006/customXml" ds:itemID="{E0CFCB78-2973-46E2-963D-C72C98C43B41}">
-  <ds:schemaRefs>
-    <ds:schemaRef ds:uri="http://schemas.microsoft.com/sharepoint/v3/contenttype/forms"/>
-  </ds:schemaRefs>
-</ds:datastoreItem>
+<file path=customXml/item3.xml><?xml version="1.0" encoding="utf-8"?>
+<p:properties xmlns:p="http://schemas.microsoft.com/office/2006/metadata/properties" xmlns:xsi="http://www.w3.org/2001/XMLSchema-instance" xmlns:pc="http://schemas.microsoft.com/office/infopath/2007/PartnerControls">
+  <documentManagement/>
+</p:properties>
 </file>
 
-<file path=customXml/itemProps3.xml><?xml version="1.0" encoding="utf-8"?>
+<file path=customXml/itemProps1.xml><?xml version="1.0" encoding="utf-8"?>
 <ds:datastoreItem xmlns:ds="http://schemas.openxmlformats.org/officeDocument/2006/customXml" ds:itemID="{6B7B52BC-33EF-4C54-820C-9984D5F8AFB1}">
   <ds:schemaRefs>
     <ds:schemaRef ds:uri="7fd05bba-d45d-467f-a5a8-3f2970e80e4a"/>
@@ -11837,4 +12048,28 @@
     <ds:schemaRef ds:uri="http://www.w3.org/2001/XMLSchema"/>
   </ds:schemaRefs>
 </ds:datastoreItem>
+</file>
+
+<file path=customXml/itemProps2.xml><?xml version="1.0" encoding="utf-8"?>
+<ds:datastoreItem xmlns:ds="http://schemas.openxmlformats.org/officeDocument/2006/customXml" ds:itemID="{E0CFCB78-2973-46E2-963D-C72C98C43B41}">
+  <ds:schemaRefs>
+    <ds:schemaRef ds:uri="http://schemas.microsoft.com/sharepoint/v3/contenttype/forms"/>
+  </ds:schemaRefs>
+</ds:datastoreItem>
+</file>
+
+<file path=customXml/itemProps3.xml><?xml version="1.0" encoding="utf-8"?>
+<ds:datastoreItem xmlns:ds="http://schemas.openxmlformats.org/officeDocument/2006/customXml" ds:itemID="{2C3B1C8D-BA84-44B8-B31F-BF26E7BAC85C}">
+  <ds:schemaRefs>
+    <ds:schemaRef ds:uri="http://purl.org/dc/elements/1.1/"/>
+    <ds:schemaRef ds:uri="http://www.w3.org/XML/1998/namespace"/>
+    <ds:schemaRef ds:uri="http://schemas.openxmlformats.org/package/2006/metadata/core-properties"/>
+    <ds:schemaRef ds:uri="http://schemas.microsoft.com/office/2006/documentManagement/types"/>
+    <ds:schemaRef ds:uri="http://purl.org/dc/terms/"/>
+    <ds:schemaRef ds:uri="http://schemas.microsoft.com/office/infopath/2007/PartnerControls"/>
+    <ds:schemaRef ds:uri="http://purl.org/dc/dcmitype/"/>
+    <ds:schemaRef ds:uri="7fd05bba-d45d-467f-a5a8-3f2970e80e4a"/>
+    <ds:schemaRef ds:uri="http://schemas.microsoft.com/office/2006/metadata/properties"/>
+  </ds:schemaRefs>
+</ds:datastoreItem>
 </file>
</xml_diff>

<commit_message>
minor changes to pptx
</commit_message>
<xml_diff>
--- a/Presentations/Assignment_2_MA.pptx
+++ b/Presentations/Assignment_2_MA.pptx
@@ -933,6 +933,18 @@
               </a:rPr>
               <a:t>business</a:t>
             </a:r>
+            <a:r>
+              <a:rPr lang="de-DE" dirty="0">
+                <a:sym typeface="Wingdings" panose="05000000000000000000" pitchFamily="2" charset="2"/>
+              </a:rPr>
+              <a:t> </a:t>
+            </a:r>
+            <a:r>
+              <a:rPr lang="de-DE" dirty="0" err="1">
+                <a:sym typeface="Wingdings" panose="05000000000000000000" pitchFamily="2" charset="2"/>
+              </a:rPr>
+              <a:t>model</a:t>
+            </a:r>
             <a:endParaRPr lang="de-DE" dirty="0">
               <a:sym typeface="Wingdings" panose="05000000000000000000" pitchFamily="2" charset="2"/>
             </a:endParaRPr>
@@ -1137,13 +1149,8 @@
           <a:p>
             <a:r>
               <a:rPr lang="en-US" dirty="0"/>
-              <a:t>But what could also be a point is to check if the first couple of months have too much “variance” in them before the data distribution settles. If the first fold is a lot worse that could be a hind to this and then we would crop the data </a:t>
-            </a:r>
-            <a:r>
-              <a:rPr lang="en-US"/>
-              <a:t>even further</a:t>
-            </a:r>
-            <a:endParaRPr lang="en-US" dirty="0"/>
+              <a:t>But what could also be a point is to check if the first couple of months have too much “variance” in them before the data distribution settles. If the first fold is a lot worse that could be a hind to this and then we would crop the data even further</a:t>
+            </a:r>
           </a:p>
         </p:txBody>
       </p:sp>
@@ -10998,7 +11005,7 @@
                 <a:ea typeface="+mn-ea"/>
                 <a:cs typeface="+mn-cs"/>
               </a:rPr>
-              <a:t>We implement a tree-based model that can implicitly learn to ignore these churned customers. Upgrading to a tree-based model cuts the MAE by ~30%:</a:t>
+              <a:t>We implement a tree-based model that can implicitly learn to ignore these churned customers. Upgrading to a tree-based model cuts the MAE by 31%:</a:t>
             </a:r>
             <a:endParaRPr lang="en-US" sz="2000" dirty="0">
               <a:effectLst/>
@@ -11058,7 +11065,7 @@
                   <a:schemeClr val="bg1"/>
                 </a:solidFill>
               </a:rPr>
-              <a:t> with behavioral features (e.g., Style Entropy and Cluster Affinity) to precisely predict who is churning and close the error gap even further</a:t>
+              <a:t> with behavioral features (e.g., Style Entropy and Cluster Affinity) to precisely predict who is churning and reduce the error gap even further</a:t>
             </a:r>
           </a:p>
         </p:txBody>
@@ -11856,6 +11863,21 @@
 </file>
 
 <file path=customXml/item1.xml><?xml version="1.0" encoding="utf-8"?>
+<p:properties xmlns:p="http://schemas.microsoft.com/office/2006/metadata/properties" xmlns:xsi="http://www.w3.org/2001/XMLSchema-instance" xmlns:pc="http://schemas.microsoft.com/office/infopath/2007/PartnerControls">
+  <documentManagement/>
+</p:properties>
+</file>
+
+<file path=customXml/item2.xml><?xml version="1.0" encoding="utf-8"?>
+<?mso-contentType ?>
+<FormTemplates xmlns="http://schemas.microsoft.com/sharepoint/v3/contenttype/forms">
+  <Display>DocumentLibraryForm</Display>
+  <Edit>DocumentLibraryForm</Edit>
+  <New>DocumentLibraryForm</New>
+</FormTemplates>
+</file>
+
+<file path=customXml/item3.xml><?xml version="1.0" encoding="utf-8"?>
 <ct:contentTypeSchema xmlns:ct="http://schemas.microsoft.com/office/2006/metadata/contentType" xmlns:ma="http://schemas.microsoft.com/office/2006/metadata/properties/metaAttributes" ct:_="" ma:_="" ma:contentTypeName="Dokument" ma:contentTypeID="0x010100D0F59E03F3A02E49BD70E31348545014" ma:contentTypeVersion="7" ma:contentTypeDescription="Ein neues Dokument erstellen." ma:contentTypeScope="" ma:versionID="907cdc0f808be0b4bc1373a5a8f6a492">
   <xsd:schema xmlns:xsd="http://www.w3.org/2001/XMLSchema" xmlns:xs="http://www.w3.org/2001/XMLSchema" xmlns:p="http://schemas.microsoft.com/office/2006/metadata/properties" xmlns:ns2="7fd05bba-d45d-467f-a5a8-3f2970e80e4a" targetNamespace="http://schemas.microsoft.com/office/2006/metadata/properties" ma:root="true" ma:fieldsID="6eaf8534fcc486a778b01aa1a7a62fa4" ns2:_="">
     <xsd:import namespace="7fd05bba-d45d-467f-a5a8-3f2970e80e4a"/>
@@ -12017,22 +12039,31 @@
 </ct:contentTypeSchema>
 </file>
 
-<file path=customXml/item2.xml><?xml version="1.0" encoding="utf-8"?>
-<?mso-contentType ?>
-<FormTemplates xmlns="http://schemas.microsoft.com/sharepoint/v3/contenttype/forms">
-  <Display>DocumentLibraryForm</Display>
-  <Edit>DocumentLibraryForm</Edit>
-  <New>DocumentLibraryForm</New>
-</FormTemplates>
+<file path=customXml/itemProps1.xml><?xml version="1.0" encoding="utf-8"?>
+<ds:datastoreItem xmlns:ds="http://schemas.openxmlformats.org/officeDocument/2006/customXml" ds:itemID="{2C3B1C8D-BA84-44B8-B31F-BF26E7BAC85C}">
+  <ds:schemaRefs>
+    <ds:schemaRef ds:uri="http://purl.org/dc/elements/1.1/"/>
+    <ds:schemaRef ds:uri="http://www.w3.org/XML/1998/namespace"/>
+    <ds:schemaRef ds:uri="http://schemas.openxmlformats.org/package/2006/metadata/core-properties"/>
+    <ds:schemaRef ds:uri="http://schemas.microsoft.com/office/2006/documentManagement/types"/>
+    <ds:schemaRef ds:uri="http://purl.org/dc/terms/"/>
+    <ds:schemaRef ds:uri="http://schemas.microsoft.com/office/infopath/2007/PartnerControls"/>
+    <ds:schemaRef ds:uri="http://purl.org/dc/dcmitype/"/>
+    <ds:schemaRef ds:uri="7fd05bba-d45d-467f-a5a8-3f2970e80e4a"/>
+    <ds:schemaRef ds:uri="http://schemas.microsoft.com/office/2006/metadata/properties"/>
+  </ds:schemaRefs>
+</ds:datastoreItem>
 </file>
 
-<file path=customXml/item3.xml><?xml version="1.0" encoding="utf-8"?>
-<p:properties xmlns:p="http://schemas.microsoft.com/office/2006/metadata/properties" xmlns:xsi="http://www.w3.org/2001/XMLSchema-instance" xmlns:pc="http://schemas.microsoft.com/office/infopath/2007/PartnerControls">
-  <documentManagement/>
-</p:properties>
+<file path=customXml/itemProps2.xml><?xml version="1.0" encoding="utf-8"?>
+<ds:datastoreItem xmlns:ds="http://schemas.openxmlformats.org/officeDocument/2006/customXml" ds:itemID="{E0CFCB78-2973-46E2-963D-C72C98C43B41}">
+  <ds:schemaRefs>
+    <ds:schemaRef ds:uri="http://schemas.microsoft.com/sharepoint/v3/contenttype/forms"/>
+  </ds:schemaRefs>
+</ds:datastoreItem>
 </file>
 
-<file path=customXml/itemProps1.xml><?xml version="1.0" encoding="utf-8"?>
+<file path=customXml/itemProps3.xml><?xml version="1.0" encoding="utf-8"?>
 <ds:datastoreItem xmlns:ds="http://schemas.openxmlformats.org/officeDocument/2006/customXml" ds:itemID="{6B7B52BC-33EF-4C54-820C-9984D5F8AFB1}">
   <ds:schemaRefs>
     <ds:schemaRef ds:uri="7fd05bba-d45d-467f-a5a8-3f2970e80e4a"/>
@@ -12048,28 +12079,4 @@
     <ds:schemaRef ds:uri="http://www.w3.org/2001/XMLSchema"/>
   </ds:schemaRefs>
 </ds:datastoreItem>
-</file>
-
-<file path=customXml/itemProps2.xml><?xml version="1.0" encoding="utf-8"?>
-<ds:datastoreItem xmlns:ds="http://schemas.openxmlformats.org/officeDocument/2006/customXml" ds:itemID="{E0CFCB78-2973-46E2-963D-C72C98C43B41}">
-  <ds:schemaRefs>
-    <ds:schemaRef ds:uri="http://schemas.microsoft.com/sharepoint/v3/contenttype/forms"/>
-  </ds:schemaRefs>
-</ds:datastoreItem>
-</file>
-
-<file path=customXml/itemProps3.xml><?xml version="1.0" encoding="utf-8"?>
-<ds:datastoreItem xmlns:ds="http://schemas.openxmlformats.org/officeDocument/2006/customXml" ds:itemID="{2C3B1C8D-BA84-44B8-B31F-BF26E7BAC85C}">
-  <ds:schemaRefs>
-    <ds:schemaRef ds:uri="http://purl.org/dc/elements/1.1/"/>
-    <ds:schemaRef ds:uri="http://www.w3.org/XML/1998/namespace"/>
-    <ds:schemaRef ds:uri="http://schemas.openxmlformats.org/package/2006/metadata/core-properties"/>
-    <ds:schemaRef ds:uri="http://schemas.microsoft.com/office/2006/documentManagement/types"/>
-    <ds:schemaRef ds:uri="http://purl.org/dc/terms/"/>
-    <ds:schemaRef ds:uri="http://schemas.microsoft.com/office/infopath/2007/PartnerControls"/>
-    <ds:schemaRef ds:uri="http://purl.org/dc/dcmitype/"/>
-    <ds:schemaRef ds:uri="7fd05bba-d45d-467f-a5a8-3f2970e80e4a"/>
-    <ds:schemaRef ds:uri="http://schemas.microsoft.com/office/2006/metadata/properties"/>
-  </ds:schemaRefs>
-</ds:datastoreItem>
 </file>
</xml_diff>